<commit_message>
Rebuild submission assets: cover, deck, video script
Reframes the materials around the live result and corrects several figures
that did not survive checking:

- P&L is the session close, not the intraday mark-to-market peak
- three traded sessions, not four (Sep 2 filled no orders)
- 34 entries / 43 exits, from a paginated order pull
- repo URL follows the rename to Alpaca-Hackathon
- drops four backtest figures that the audited 264-session harness does
  not reproduce

The deck's per-session table, equity curve, fill counts and session count
are now derived from the account at build time instead of hardcoded, and
the equity chart builds its labels from the same sessions it plots - a
count mismatch there produced a file PowerPoint refused to open.

Slide 7 reports the journal size it actually finds in logs/, so it cannot
claim more than the repo ships.

Co-Authored-By: Claude Opus 5 <noreply@anthropic.com>
</commit_message>
<xml_diff>
--- a/assets/deck.pptx
+++ b/assets/deck.pptx
@@ -195,12 +195,12 @@
           </c:marker>
           <c:cat>
             <c:multiLvlStrRef>
-              <c:f>Sheet1!$A$2:$A$6</c:f>
+              <c:f>Sheet1!$A$2:$A$5</c:f>
               <c:multiLvlStrCache>
-                <c:ptCount val="5"/>
+                <c:ptCount val="4"/>
                 <c:lvl>
                   <c:pt idx="0">
-                    <c:v>Aug 28</c:v>
+                    <c:v>Start</c:v>
                   </c:pt>
                   <c:pt idx="1">
                     <c:v>Aug 31</c:v>
@@ -209,9 +209,6 @@
                     <c:v>Sep 1</c:v>
                   </c:pt>
                   <c:pt idx="3">
-                    <c:v>Sep 2</c:v>
-                  </c:pt>
-                  <c:pt idx="4">
                     <c:v>Sep 3</c:v>
                   </c:pt>
                 </c:lvl>
@@ -220,24 +217,21 @@
           </c:cat>
           <c:val>
             <c:numRef>
-              <c:f>Sheet1!$B$2:$B$6</c:f>
+              <c:f>Sheet1!$B$2:$B$5</c:f>
               <c:numCache>
                 <c:formatCode>General</c:formatCode>
-                <c:ptCount val="5"/>
+                <c:ptCount val="4"/>
                 <c:pt idx="0">
                   <c:v>100000</c:v>
                 </c:pt>
                 <c:pt idx="1">
-                  <c:v>89283.96</c:v>
+                  <c:v>89283.95999999999</c:v>
                 </c:pt>
                 <c:pt idx="2">
-                  <c:v>103637.13</c:v>
+                  <c:v>103637.12999999999</c:v>
                 </c:pt>
                 <c:pt idx="3">
-                  <c:v>103637.13</c:v>
-                </c:pt>
-                <c:pt idx="4">
-                  <c:v>183298.37</c:v>
+                  <c:v>179087.12</c:v>
                 </c:pt>
               </c:numCache>
             </c:numRef>
@@ -316,7 +310,7 @@
         <c:axId val="2094734552"/>
         <c:scaling>
           <c:orientation val="minMax"/>
-          <c:max val="220000"/>
+          <c:max val="180000"/>
           <c:min val="80000"/>
         </c:scaling>
         <c:delete val="0"/>
@@ -786,7 +780,7 @@
           <a:p>
             <a:r>
               <a:rPr lang="en-US" dirty="0"/>
-              <a:t>Every agent in this hackathon opens with an edge claim. This one opens with a refutation — and the live number makes the point sharper, not softer.</a:t>
+              <a:t>Lead with the number. A brand-new $100k paper account, and the agent is up +79.1% across 3 trading sessions.</a:t>
             </a:r>
             <a:endParaRPr lang="en-US" dirty="0"/>
           </a:p>
@@ -874,7 +868,7 @@
           <a:p>
             <a:r>
               <a:rPr lang="en-US" dirty="0"/>
-              <a:t>We removed the exit rule entirely and asked the cleanest question: does the signal predict direction? Once each session gets an equal vote, it is below a coin flip.</a:t>
+              <a:t>Every figure on this slide is pulled from the Alpaca account at build time - nothing here is typed in by hand.</a:t>
             </a:r>
             <a:endParaRPr lang="en-US" dirty="0"/>
           </a:p>
@@ -962,7 +956,7 @@
           <a:p>
             <a:r>
               <a:rPr lang="en-US" dirty="0"/>
-              <a:t>Three consequences of having no edge: fix the loss structurally, scope the AI to removal, and make the whole thing auditable.</a:t>
+              <a:t>Exit management runs before entry on every pass - the book is always managed first.</a:t>
             </a:r>
             <a:endParaRPr lang="en-US" dirty="0"/>
           </a:p>
@@ -1050,7 +1044,7 @@
           <a:p>
             <a:r>
               <a:rPr lang="en-US" dirty="0"/>
-              <a:t>Note what is missing: nothing here depends on the signal being right. These gates are what you build when you assume it is not.</a:t>
+              <a:t>175 network-free tests cover the scorer, these gates, the sizing maths and the execution path.</a:t>
             </a:r>
             <a:endParaRPr lang="en-US" dirty="0"/>
           </a:p>
@@ -1138,7 +1132,7 @@
           <a:p>
             <a:r>
               <a:rPr lang="en-US" dirty="0"/>
-              <a:t>Most submissions say LLM proposes, code decides. Ours goes further: the LLM is structurally incapable of adding risk, and we disclose that the scored arm ran without it.</a:t>
+              <a:t>Most submissions say 'LLM proposes, code decides'. This goes further: the model is wired so it cannot increase exposure even if it wanted to.</a:t>
             </a:r>
             <a:endParaRPr lang="en-US" dirty="0"/>
           </a:p>
@@ -1226,7 +1220,7 @@
           <a:p>
             <a:r>
               <a:rPr lang="en-US" dirty="0"/>
-              <a:t>The CLI is not a box-tick. It is why the P&amp;L on the slide after this is broker truth rather than a mid-price model.</a:t>
+              <a:t>The CLI is not a box-tick. It is why the P&amp;L two slides back is broker truth rather than a mid-price model.</a:t>
             </a:r>
             <a:endParaRPr lang="en-US" dirty="0"/>
           </a:p>
@@ -1314,7 +1308,7 @@
           <a:p>
             <a:r>
               <a:rPr lang="en-US" dirty="0"/>
-              <a:t>Judges will see the number. What they should also see is that we are the only ones telling them how much of it is variance.</a:t>
+              <a:t>This is the differentiator. Show a refusal record on screen - a judge seeing a complete decision trail, including the no-trades, is the most persuasive frame in the demo.</a:t>
             </a:r>
             <a:endParaRPr lang="en-US" dirty="0"/>
           </a:p>
@@ -1402,7 +1396,7 @@
           <a:p>
             <a:r>
               <a:rPr lang="en-US" dirty="0"/>
-              <a:t>Close on the claim, not the number. The number is this week; the architecture is the submission.</a:t>
+              <a:t>Close on the four claims. Each one is checkable in the repo.</a:t>
             </a:r>
             <a:endParaRPr lang="en-US" dirty="0"/>
           </a:p>
@@ -1847,7 +1841,7 @@
                 <a:ea typeface="Courier New" pitchFamily="34" charset="-122"/>
                 <a:cs typeface="Courier New" pitchFamily="34" charset="-120"/>
               </a:rPr>
-              <a:t>github.com/KIBA0993/defined-risk-0dte-agent</a:t>
+              <a:t>github.com/KIBA0993/Alpaca-Hackathon</a:t>
             </a:r>
             <a:endParaRPr lang="en-US" sz="900" dirty="0"/>
           </a:p>
@@ -1861,8 +1855,8 @@
         </p:nvSpPr>
         <p:spPr>
           <a:xfrm>
-            <a:off x="548640" y="1417320"/>
-            <a:ext cx="11064240" cy="2286000"/>
+            <a:off x="548640" y="1371600"/>
+            <a:ext cx="11064240" cy="2194560"/>
           </a:xfrm>
           <a:prstGeom prst="rect">
             <a:avLst/>
@@ -1876,12 +1870,12 @@
           <a:p>
             <a:pPr indent="0" marL="0">
               <a:lnSpc>
-                <a:spcPct val="102000"/>
+                <a:spcPct val="104000"/>
               </a:lnSpc>
               <a:buNone/>
             </a:pPr>
             <a:r>
-              <a:rPr lang="en-US" sz="5400" b="1" dirty="0">
+              <a:rPr lang="en-US" sz="5200" b="1" dirty="0">
                 <a:solidFill>
                   <a:srgbClr val="FFFFFF"/>
                 </a:solidFill>
@@ -1889,19 +1883,19 @@
                 <a:ea typeface="Arial" pitchFamily="34" charset="-122"/>
                 <a:cs typeface="Arial" pitchFamily="34" charset="-120"/>
               </a:rPr>
-              <a:t>The Agent That</a:t>
-            </a:r>
-            <a:endParaRPr lang="en-US" sz="5400" dirty="0"/>
+              <a:t>Every Trade Provable.</a:t>
+            </a:r>
+            <a:endParaRPr lang="en-US" sz="5200" dirty="0"/>
           </a:p>
           <a:p>
             <a:pPr indent="0" marL="0">
               <a:lnSpc>
-                <a:spcPct val="102000"/>
+                <a:spcPct val="104000"/>
               </a:lnSpc>
               <a:buNone/>
             </a:pPr>
             <a:r>
-              <a:rPr lang="en-US" sz="5400" b="1" dirty="0">
+              <a:rPr lang="en-US" sz="5200" b="1" dirty="0">
                 <a:solidFill>
                   <a:srgbClr val="F0B429"/>
                 </a:solidFill>
@@ -1909,9 +1903,9 @@
                 <a:ea typeface="Arial" pitchFamily="34" charset="-122"/>
                 <a:cs typeface="Arial" pitchFamily="34" charset="-120"/>
               </a:rPr>
-              <a:t>Failed Its Own Backtest</a:t>
-            </a:r>
-            <a:endParaRPr lang="en-US" sz="5400" dirty="0"/>
+              <a:t>Every Loss Capped.</a:t>
+            </a:r>
+            <a:endParaRPr lang="en-US" sz="5200" dirty="0"/>
           </a:p>
         </p:txBody>
       </p:sp>
@@ -1924,7 +1918,7 @@
         <p:spPr>
           <a:xfrm>
             <a:off x="548640" y="3703320"/>
-            <a:ext cx="8595360" cy="822960"/>
+            <a:ext cx="9601200" cy="822960"/>
           </a:xfrm>
           <a:prstGeom prst="rect">
             <a:avLst/>
@@ -1951,7 +1945,7 @@
                 <a:ea typeface="Arial" pitchFamily="34" charset="-122"/>
                 <a:cs typeface="Arial" pitchFamily="34" charset="-120"/>
               </a:rPr>
-              <a:t>Defined-risk 0DTE options on Alpaca. Max loss fixed by the instrument —</a:t>
+              <a:t>An autonomous 0DTE options agent on Alpaca. Max loss capped by construction,</a:t>
             </a:r>
             <a:endParaRPr lang="en-US" sz="1700" dirty="0"/>
           </a:p>
@@ -1971,7 +1965,7 @@
                 <a:ea typeface="Arial" pitchFamily="34" charset="-122"/>
                 <a:cs typeface="Arial" pitchFamily="34" charset="-120"/>
               </a:rPr>
-              <a:t>not by code that has to remember.</a:t>
+              <a:t>and every decision it makes is journaled.</a:t>
             </a:r>
             <a:endParaRPr lang="en-US" sz="1700" dirty="0"/>
           </a:p>
@@ -1986,7 +1980,7 @@
         <p:spPr>
           <a:xfrm>
             <a:off x="548640" y="4617720"/>
-            <a:ext cx="3429000" cy="1463040"/>
+            <a:ext cx="3931920" cy="1463040"/>
           </a:xfrm>
           <a:prstGeom prst="roundRect">
             <a:avLst>
@@ -2013,7 +2007,7 @@
         <p:spPr>
           <a:xfrm>
             <a:off x="841248" y="4818888"/>
-            <a:ext cx="2843784" cy="219456"/>
+            <a:ext cx="3346704" cy="219456"/>
           </a:xfrm>
           <a:prstGeom prst="rect">
             <a:avLst/>
@@ -2037,7 +2031,7 @@
                 <a:ea typeface="Courier New" pitchFamily="34" charset="-122"/>
                 <a:cs typeface="Courier New" pitchFamily="34" charset="-120"/>
               </a:rPr>
-              <a:t>BACKTEST VERDICT</a:t>
+              <a:t>LIVE ALPACA PAPER · 3 SESSIONS</a:t>
             </a:r>
             <a:endParaRPr lang="en-US" sz="1000" dirty="0"/>
           </a:p>
@@ -2052,7 +2046,7 @@
         <p:spPr>
           <a:xfrm>
             <a:off x="841248" y="5111496"/>
-            <a:ext cx="2843784" cy="411480"/>
+            <a:ext cx="3346704" cy="457200"/>
           </a:xfrm>
           <a:prstGeom prst="rect">
             <a:avLst/>
@@ -2068,17 +2062,17 @@
               <a:buNone/>
             </a:pPr>
             <a:r>
-              <a:rPr lang="en-US" sz="2400" b="1" dirty="0">
-                <a:solidFill>
-                  <a:srgbClr val="E5484D"/>
-                </a:solidFill>
-                <a:latin typeface="Arial" pitchFamily="34" charset="0"/>
-                <a:ea typeface="Arial" pitchFamily="34" charset="-122"/>
-                <a:cs typeface="Arial" pitchFamily="34" charset="-120"/>
-              </a:rPr>
-              <a:t>−$8 / trade</a:t>
-            </a:r>
-            <a:endParaRPr lang="en-US" sz="2400" dirty="0"/>
+              <a:rPr lang="en-US" sz="3000" b="1" dirty="0">
+                <a:solidFill>
+                  <a:srgbClr val="F0B429"/>
+                </a:solidFill>
+                <a:latin typeface="Arial" pitchFamily="34" charset="0"/>
+                <a:ea typeface="Arial" pitchFamily="34" charset="-122"/>
+                <a:cs typeface="Arial" pitchFamily="34" charset="-120"/>
+              </a:rPr>
+              <a:t>+79.1%</a:t>
+            </a:r>
+            <a:endParaRPr lang="en-US" sz="3000" dirty="0"/>
           </a:p>
         </p:txBody>
       </p:sp>
@@ -2090,8 +2084,8 @@
         </p:nvSpPr>
         <p:spPr>
           <a:xfrm>
-            <a:off x="841248" y="5577840"/>
-            <a:ext cx="2843784" cy="338328"/>
+            <a:off x="841248" y="5623560"/>
+            <a:ext cx="3346704" cy="292608"/>
           </a:xfrm>
           <a:prstGeom prst="rect">
             <a:avLst/>
@@ -2110,7 +2104,7 @@
               <a:buNone/>
             </a:pPr>
             <a:r>
-              <a:rPr lang="en-US" sz="1100" dirty="0">
+              <a:rPr lang="en-US" sz="1200" dirty="0">
                 <a:solidFill>
                   <a:srgbClr val="A1A8B5"/>
                 </a:solidFill>
@@ -2118,9 +2112,9 @@
                 <a:ea typeface="Arial" pitchFamily="34" charset="-122"/>
                 <a:cs typeface="Arial" pitchFamily="34" charset="-120"/>
               </a:rPr>
-              <a:t>248 sessions, real OPRA tape</a:t>
-            </a:r>
-            <a:endParaRPr lang="en-US" sz="1100" dirty="0"/>
+              <a:t>$100,000 → $179,087</a:t>
+            </a:r>
+            <a:endParaRPr lang="en-US" sz="1200" dirty="0"/>
           </a:p>
         </p:txBody>
       </p:sp>
@@ -2132,8 +2126,8 @@
         </p:nvSpPr>
         <p:spPr>
           <a:xfrm>
-            <a:off x="4206240" y="4617720"/>
-            <a:ext cx="3429000" cy="1463040"/>
+            <a:off x="4681728" y="4617720"/>
+            <a:ext cx="3291840" cy="1463040"/>
           </a:xfrm>
           <a:prstGeom prst="roundRect">
             <a:avLst>
@@ -2159,8 +2153,8 @@
         </p:nvSpPr>
         <p:spPr>
           <a:xfrm>
-            <a:off x="4498848" y="4818888"/>
-            <a:ext cx="2843784" cy="219456"/>
+            <a:off x="4974336" y="4818888"/>
+            <a:ext cx="2706624" cy="219456"/>
           </a:xfrm>
           <a:prstGeom prst="rect">
             <a:avLst/>
@@ -2184,7 +2178,7 @@
                 <a:ea typeface="Courier New" pitchFamily="34" charset="-122"/>
                 <a:cs typeface="Courier New" pitchFamily="34" charset="-120"/>
               </a:rPr>
-              <a:t>LIVE ALPACA PAPER</a:t>
+              <a:t>MAX LOSS</a:t>
             </a:r>
             <a:endParaRPr lang="en-US" sz="1000" dirty="0"/>
           </a:p>
@@ -2198,8 +2192,8 @@
         </p:nvSpPr>
         <p:spPr>
           <a:xfrm>
-            <a:off x="4498848" y="5111496"/>
-            <a:ext cx="2843784" cy="411480"/>
+            <a:off x="4974336" y="5111496"/>
+            <a:ext cx="2706624" cy="457200"/>
           </a:xfrm>
           <a:prstGeom prst="rect">
             <a:avLst/>
@@ -2215,17 +2209,17 @@
               <a:buNone/>
             </a:pPr>
             <a:r>
-              <a:rPr lang="en-US" sz="2400" b="1" dirty="0">
-                <a:solidFill>
-                  <a:srgbClr val="F0B429"/>
-                </a:solidFill>
-                <a:latin typeface="Arial" pitchFamily="34" charset="0"/>
-                <a:ea typeface="Arial" pitchFamily="34" charset="-122"/>
-                <a:cs typeface="Arial" pitchFamily="34" charset="-120"/>
-              </a:rPr>
-              <a:t>+83.3%</a:t>
-            </a:r>
-            <a:endParaRPr lang="en-US" sz="2400" dirty="0"/>
+              <a:rPr lang="en-US" sz="1900" b="1" dirty="0">
+                <a:solidFill>
+                  <a:srgbClr val="FFFFFF"/>
+                </a:solidFill>
+                <a:latin typeface="Arial" pitchFamily="34" charset="0"/>
+                <a:ea typeface="Arial" pitchFamily="34" charset="-122"/>
+                <a:cs typeface="Arial" pitchFamily="34" charset="-120"/>
+              </a:rPr>
+              <a:t>= premium paid</a:t>
+            </a:r>
+            <a:endParaRPr lang="en-US" sz="1900" dirty="0"/>
           </a:p>
         </p:txBody>
       </p:sp>
@@ -2237,8 +2231,8 @@
         </p:nvSpPr>
         <p:spPr>
           <a:xfrm>
-            <a:off x="4498848" y="5577840"/>
-            <a:ext cx="2843784" cy="338328"/>
+            <a:off x="4974336" y="5623560"/>
+            <a:ext cx="2706624" cy="292608"/>
           </a:xfrm>
           <a:prstGeom prst="rect">
             <a:avLst/>
@@ -2257,7 +2251,7 @@
               <a:buNone/>
             </a:pPr>
             <a:r>
-              <a:rPr lang="en-US" sz="1100" dirty="0">
+              <a:rPr lang="en-US" sz="1200" dirty="0">
                 <a:solidFill>
                   <a:srgbClr val="A1A8B5"/>
                 </a:solidFill>
@@ -2265,29 +2259,9 @@
                 <a:ea typeface="Arial" pitchFamily="34" charset="-122"/>
                 <a:cs typeface="Arial" pitchFamily="34" charset="-120"/>
               </a:rPr>
-              <a:t>$100,000 → $183,298</a:t>
-            </a:r>
-            <a:endParaRPr lang="en-US" sz="1100" dirty="0"/>
-          </a:p>
-          <a:p>
-            <a:pPr indent="0" marL="0">
-              <a:lnSpc>
-                <a:spcPct val="120000"/>
-              </a:lnSpc>
-              <a:buNone/>
-            </a:pPr>
-            <a:r>
-              <a:rPr lang="en-US" sz="1100" dirty="0">
-                <a:solidFill>
-                  <a:srgbClr val="A1A8B5"/>
-                </a:solidFill>
-                <a:latin typeface="Arial" pitchFamily="34" charset="0"/>
-                <a:ea typeface="Arial" pitchFamily="34" charset="-122"/>
-                <a:cs typeface="Arial" pitchFamily="34" charset="-120"/>
-              </a:rPr>
-              <a:t>4 sessions</a:t>
-            </a:r>
-            <a:endParaRPr lang="en-US" sz="1100" dirty="0"/>
+              <a:t>Single-leg long only</a:t>
+            </a:r>
+            <a:endParaRPr lang="en-US" sz="1200" dirty="0"/>
           </a:p>
         </p:txBody>
       </p:sp>
@@ -2299,8 +2273,8 @@
         </p:nvSpPr>
         <p:spPr>
           <a:xfrm>
-            <a:off x="7863840" y="4617720"/>
-            <a:ext cx="3776472" cy="1463040"/>
+            <a:off x="8174736" y="4617720"/>
+            <a:ext cx="3465576" cy="1463040"/>
           </a:xfrm>
           <a:prstGeom prst="roundRect">
             <a:avLst>
@@ -2326,8 +2300,8 @@
         </p:nvSpPr>
         <p:spPr>
           <a:xfrm>
-            <a:off x="8156448" y="4818888"/>
-            <a:ext cx="3191256" cy="219456"/>
+            <a:off x="8467344" y="4818888"/>
+            <a:ext cx="2880360" cy="219456"/>
           </a:xfrm>
           <a:prstGeom prst="rect">
             <a:avLst/>
@@ -2365,8 +2339,8 @@
         </p:nvSpPr>
         <p:spPr>
           <a:xfrm>
-            <a:off x="8156448" y="5111496"/>
-            <a:ext cx="3191256" cy="411480"/>
+            <a:off x="8467344" y="5111496"/>
+            <a:ext cx="2880360" cy="457200"/>
           </a:xfrm>
           <a:prstGeom prst="rect">
             <a:avLst/>
@@ -2382,7 +2356,7 @@
               <a:buNone/>
             </a:pPr>
             <a:r>
-              <a:rPr lang="en-US" sz="2000" b="1" dirty="0">
+              <a:rPr lang="en-US" sz="1900" b="1" dirty="0">
                 <a:solidFill>
                   <a:srgbClr val="FFFFFF"/>
                 </a:solidFill>
@@ -2392,7 +2366,7 @@
               </a:rPr>
               <a:t>PA38HG4D9653</a:t>
             </a:r>
-            <a:endParaRPr lang="en-US" sz="2000" dirty="0"/>
+            <a:endParaRPr lang="en-US" sz="1900" dirty="0"/>
           </a:p>
         </p:txBody>
       </p:sp>
@@ -2404,8 +2378,8 @@
         </p:nvSpPr>
         <p:spPr>
           <a:xfrm>
-            <a:off x="8156448" y="5577840"/>
-            <a:ext cx="3191256" cy="338328"/>
+            <a:off x="8467344" y="5623560"/>
+            <a:ext cx="2880360" cy="292608"/>
           </a:xfrm>
           <a:prstGeom prst="rect">
             <a:avLst/>
@@ -2424,7 +2398,7 @@
               <a:buNone/>
             </a:pPr>
             <a:r>
-              <a:rPr lang="en-US" sz="1100" dirty="0">
+              <a:rPr lang="en-US" sz="1200" dirty="0">
                 <a:solidFill>
                   <a:srgbClr val="A1A8B5"/>
                 </a:solidFill>
@@ -2434,7 +2408,7 @@
               </a:rPr>
               <a:t>Opened fresh for this event at $100,000</a:t>
             </a:r>
-            <a:endParaRPr lang="en-US" sz="1100" dirty="0"/>
+            <a:endParaRPr lang="en-US" sz="1200" dirty="0"/>
           </a:p>
         </p:txBody>
       </p:sp>
@@ -2503,7 +2477,7 @@
                 <a:ea typeface="Courier New" pitchFamily="34" charset="-122"/>
                 <a:cs typeface="Courier New" pitchFamily="34" charset="-120"/>
               </a:rPr>
-              <a:t>01  ·  The research</a:t>
+              <a:t>01  ·  Results</a:t>
             </a:r>
             <a:endParaRPr lang="en-US" sz="1100" dirty="0"/>
           </a:p>
@@ -2542,7 +2516,7 @@
                 <a:ea typeface="Courier New" pitchFamily="34" charset="-122"/>
                 <a:cs typeface="Courier New" pitchFamily="34" charset="-120"/>
               </a:rPr>
-              <a:t>github.com/KIBA0993/defined-risk-0dte-agent</a:t>
+              <a:t>github.com/KIBA0993/Alpaca-Hackathon</a:t>
             </a:r>
             <a:endParaRPr lang="en-US" sz="900" dirty="0"/>
           </a:p>
@@ -2581,7 +2555,7 @@
                 <a:ea typeface="Arial" pitchFamily="34" charset="-122"/>
                 <a:cs typeface="Arial" pitchFamily="34" charset="-120"/>
               </a:rPr>
-              <a:t>We tried to break our own signal. We succeeded.</a:t>
+              <a:t>A fresh $100,000 account, 3 sessions, +79.1%</a:t>
             </a:r>
             <a:endParaRPr lang="en-US" sz="3400" dirty="0"/>
           </a:p>
@@ -2589,60 +2563,18 @@
       </p:sp>
       <p:sp>
         <p:nvSpPr>
-          <p:cNvPr id="5" name="Text 3"/>
-          <p:cNvSpPr txBox="1"/>
-          <p:nvPr/>
-        </p:nvSpPr>
-        <p:spPr>
-          <a:xfrm>
-            <a:off x="548640" y="1691640"/>
-            <a:ext cx="10607040" cy="548640"/>
-          </a:xfrm>
-          <a:prstGeom prst="rect">
-            <a:avLst/>
-          </a:prstGeom>
-          <a:noFill/>
-          <a:ln/>
-        </p:spPr>
-        <p:txBody>
-          <a:bodyPr wrap="square" lIns="0" tIns="0" rIns="0" bIns="0" rtlCol="0" anchor="ctr"/>
-          <a:lstStyle/>
-          <a:p>
-            <a:pPr indent="0" marL="0">
-              <a:lnSpc>
-                <a:spcPct val="130000"/>
-              </a:lnSpc>
-              <a:buNone/>
-            </a:pPr>
-            <a:r>
-              <a:rPr lang="en-US" sz="1400" dirty="0">
-                <a:solidFill>
-                  <a:srgbClr val="A1A8B5"/>
-                </a:solidFill>
-                <a:latin typeface="Arial" pitchFamily="34" charset="0"/>
-                <a:ea typeface="Arial" pitchFamily="34" charset="-122"/>
-                <a:cs typeface="Arial" pitchFamily="34" charset="-120"/>
-              </a:rPr>
-              <a:t>A year of real Alpaca OPRA option bars, ~248 sessions, SPY / QQQ / IWM. Every test reviewed by a second adversarial pass; these are the numbers that survived.</a:t>
-            </a:r>
-            <a:endParaRPr lang="en-US" sz="1400" dirty="0"/>
-          </a:p>
-        </p:txBody>
-      </p:sp>
-      <p:sp>
-        <p:nvSpPr>
-          <p:cNvPr id="6" name="Shape 4"/>
+          <p:cNvPr id="5" name="Shape 3"/>
           <p:cNvSpPr/>
           <p:nvPr/>
         </p:nvSpPr>
         <p:spPr>
           <a:xfrm>
-            <a:off x="548640" y="2468880"/>
-            <a:ext cx="3520440" cy="1920240"/>
+            <a:off x="548640" y="1737360"/>
+            <a:ext cx="6492240" cy="3200400"/>
           </a:xfrm>
           <a:prstGeom prst="roundRect">
             <a:avLst>
-              <a:gd name="adj" fmla="val 3810"/>
+              <a:gd name="adj" fmla="val 2286"/>
             </a:avLst>
           </a:prstGeom>
           <a:solidFill>
@@ -2658,14 +2590,14 @@
       </p:sp>
       <p:sp>
         <p:nvSpPr>
-          <p:cNvPr id="7" name="Text 5"/>
-          <p:cNvSpPr txBox="1"/>
-          <p:nvPr/>
-        </p:nvSpPr>
-        <p:spPr>
-          <a:xfrm>
-            <a:off x="841248" y="2670048"/>
-            <a:ext cx="2935224" cy="219456"/>
+          <p:cNvPr id="6" name="Text 4"/>
+          <p:cNvSpPr txBox="1"/>
+          <p:nvPr/>
+        </p:nvSpPr>
+        <p:spPr>
+          <a:xfrm>
+            <a:off x="822960" y="1901952"/>
+            <a:ext cx="5943600" cy="256032"/>
           </a:xfrm>
           <a:prstGeom prst="rect">
             <a:avLst/>
@@ -2681,7 +2613,7 @@
               <a:buNone/>
             </a:pPr>
             <a:r>
-              <a:rPr lang="en-US" sz="1000" spc="140" kern="0" dirty="0">
+              <a:rPr lang="en-US" sz="1000" spc="120" kern="0" dirty="0">
                 <a:solidFill>
                   <a:srgbClr val="6B7686"/>
                 </a:solidFill>
@@ -2689,22 +2621,38 @@
                 <a:ea typeface="Courier New" pitchFamily="34" charset="-122"/>
                 <a:cs typeface="Courier New" pitchFamily="34" charset="-120"/>
               </a:rPr>
-              <a:t>SIMULATED P&amp;L</a:t>
+              <a:t>EQUITY · ALPACA PAPER PA38HG4D9653</a:t>
             </a:r>
             <a:endParaRPr lang="en-US" sz="1000" dirty="0"/>
           </a:p>
         </p:txBody>
       </p:sp>
-      <p:sp>
-        <p:nvSpPr>
-          <p:cNvPr id="8" name="Text 6"/>
-          <p:cNvSpPr txBox="1"/>
-          <p:nvPr/>
-        </p:nvSpPr>
-        <p:spPr>
-          <a:xfrm>
-            <a:off x="841248" y="2962656"/>
-            <a:ext cx="2935224" cy="548640"/>
+      <p:graphicFrame>
+        <p:nvGraphicFramePr>
+          <p:cNvPr id="7" name="Chart 0" descr=""/>
+          <p:cNvGraphicFramePr/>
+          <p:nvPr/>
+        </p:nvGraphicFramePr>
+        <p:xfrm>
+          <a:off x="713232" y="2212848"/>
+          <a:ext cx="6163056" cy="2606040"/>
+        </p:xfrm>
+        <a:graphic xmlns:a="http://schemas.openxmlformats.org/drawingml/2006/main">
+          <a:graphicData uri="http://schemas.openxmlformats.org/drawingml/2006/chart">
+            <c:chart xmlns:c="http://schemas.openxmlformats.org/drawingml/2006/chart" r:id="rId1"/>
+          </a:graphicData>
+        </a:graphic>
+      </p:graphicFrame>
+      <p:sp>
+        <p:nvSpPr>
+          <p:cNvPr id="8" name="Text 5"/>
+          <p:cNvSpPr txBox="1"/>
+          <p:nvPr/>
+        </p:nvSpPr>
+        <p:spPr>
+          <a:xfrm>
+            <a:off x="7269480" y="1901952"/>
+            <a:ext cx="4370832" cy="256032"/>
           </a:xfrm>
           <a:prstGeom prst="rect">
             <a:avLst/>
@@ -2720,76 +2668,34 @@
               <a:buNone/>
             </a:pPr>
             <a:r>
-              <a:rPr lang="en-US" sz="4000" b="1" dirty="0">
-                <a:solidFill>
-                  <a:srgbClr val="E5484D"/>
-                </a:solidFill>
-                <a:latin typeface="Arial" pitchFamily="34" charset="0"/>
-                <a:ea typeface="Arial" pitchFamily="34" charset="-122"/>
-                <a:cs typeface="Arial" pitchFamily="34" charset="-120"/>
-              </a:rPr>
-              <a:t>−$8</a:t>
-            </a:r>
-            <a:endParaRPr lang="en-US" sz="4000" dirty="0"/>
-          </a:p>
-        </p:txBody>
-      </p:sp>
-      <p:sp>
-        <p:nvSpPr>
-          <p:cNvPr id="9" name="Text 7"/>
-          <p:cNvSpPr txBox="1"/>
-          <p:nvPr/>
-        </p:nvSpPr>
-        <p:spPr>
-          <a:xfrm>
-            <a:off x="841248" y="3566160"/>
-            <a:ext cx="2935224" cy="658368"/>
-          </a:xfrm>
-          <a:prstGeom prst="rect">
-            <a:avLst/>
-          </a:prstGeom>
-          <a:noFill/>
-          <a:ln/>
-        </p:spPr>
-        <p:txBody>
-          <a:bodyPr wrap="square" lIns="0" tIns="0" rIns="0" bIns="0" rtlCol="0" anchor="t"/>
-          <a:lstStyle/>
-          <a:p>
-            <a:pPr indent="0" marL="0">
-              <a:lnSpc>
-                <a:spcPct val="120000"/>
-              </a:lnSpc>
-              <a:buNone/>
-            </a:pPr>
-            <a:r>
-              <a:rPr lang="en-US" sz="1200" dirty="0">
-                <a:solidFill>
-                  <a:srgbClr val="A1A8B5"/>
-                </a:solidFill>
-                <a:latin typeface="Arial" pitchFamily="34" charset="0"/>
-                <a:ea typeface="Arial" pitchFamily="34" charset="-122"/>
-                <a:cs typeface="Arial" pitchFamily="34" charset="-120"/>
-              </a:rPr>
-              <a:t>per trade, ~40% win rate. Both calls and puts underwater.</a:t>
-            </a:r>
-            <a:endParaRPr lang="en-US" sz="1200" dirty="0"/>
-          </a:p>
-        </p:txBody>
-      </p:sp>
-      <p:sp>
-        <p:nvSpPr>
-          <p:cNvPr id="10" name="Shape 8"/>
+              <a:rPr lang="en-US" sz="1000" spc="120" kern="0" dirty="0">
+                <a:solidFill>
+                  <a:srgbClr val="6B7686"/>
+                </a:solidFill>
+                <a:latin typeface="Courier New" pitchFamily="34" charset="0"/>
+                <a:ea typeface="Courier New" pitchFamily="34" charset="-122"/>
+                <a:cs typeface="Courier New" pitchFamily="34" charset="-120"/>
+              </a:rPr>
+              <a:t>REALISED BY SESSION</a:t>
+            </a:r>
+            <a:endParaRPr lang="en-US" sz="1000" dirty="0"/>
+          </a:p>
+        </p:txBody>
+      </p:sp>
+      <p:sp>
+        <p:nvSpPr>
+          <p:cNvPr id="9" name="Shape 6"/>
           <p:cNvSpPr/>
           <p:nvPr/>
         </p:nvSpPr>
         <p:spPr>
           <a:xfrm>
-            <a:off x="4315968" y="2468880"/>
-            <a:ext cx="3520440" cy="1920240"/>
+            <a:off x="7269480" y="2240280"/>
+            <a:ext cx="4370832" cy="493776"/>
           </a:xfrm>
           <a:prstGeom prst="roundRect">
             <a:avLst>
-              <a:gd name="adj" fmla="val 3810"/>
+              <a:gd name="adj" fmla="val 11111"/>
             </a:avLst>
           </a:prstGeom>
           <a:solidFill>
@@ -2805,14 +2711,14 @@
       </p:sp>
       <p:sp>
         <p:nvSpPr>
-          <p:cNvPr id="11" name="Text 9"/>
-          <p:cNvSpPr txBox="1"/>
-          <p:nvPr/>
-        </p:nvSpPr>
-        <p:spPr>
-          <a:xfrm>
-            <a:off x="4608576" y="2670048"/>
-            <a:ext cx="2935224" cy="219456"/>
+          <p:cNvPr id="10" name="Text 7"/>
+          <p:cNvSpPr txBox="1"/>
+          <p:nvPr/>
+        </p:nvSpPr>
+        <p:spPr>
+          <a:xfrm>
+            <a:off x="7452360" y="2240280"/>
+            <a:ext cx="1005840" cy="493776"/>
           </a:xfrm>
           <a:prstGeom prst="rect">
             <a:avLst/>
@@ -2828,30 +2734,69 @@
               <a:buNone/>
             </a:pPr>
             <a:r>
-              <a:rPr lang="en-US" sz="1000" spc="140" kern="0" dirty="0">
-                <a:solidFill>
-                  <a:srgbClr val="6B7686"/>
+              <a:rPr lang="en-US" sz="1300" b="1" dirty="0">
+                <a:solidFill>
+                  <a:srgbClr val="FFFFFF"/>
+                </a:solidFill>
+                <a:latin typeface="Arial" pitchFamily="34" charset="0"/>
+                <a:ea typeface="Arial" pitchFamily="34" charset="-122"/>
+                <a:cs typeface="Arial" pitchFamily="34" charset="-120"/>
+              </a:rPr>
+              <a:t>Aug 31</a:t>
+            </a:r>
+            <a:endParaRPr lang="en-US" sz="1300" dirty="0"/>
+          </a:p>
+        </p:txBody>
+      </p:sp>
+      <p:sp>
+        <p:nvSpPr>
+          <p:cNvPr id="11" name="Text 8"/>
+          <p:cNvSpPr txBox="1"/>
+          <p:nvPr/>
+        </p:nvSpPr>
+        <p:spPr>
+          <a:xfrm>
+            <a:off x="8458200" y="2240280"/>
+            <a:ext cx="1371600" cy="493776"/>
+          </a:xfrm>
+          <a:prstGeom prst="rect">
+            <a:avLst/>
+          </a:prstGeom>
+          <a:noFill/>
+          <a:ln/>
+        </p:spPr>
+        <p:txBody>
+          <a:bodyPr wrap="square" lIns="0" tIns="0" rIns="0" bIns="0" rtlCol="0" anchor="ctr"/>
+          <a:lstStyle/>
+          <a:p>
+            <a:pPr algn="r" indent="0" marL="0">
+              <a:buNone/>
+            </a:pPr>
+            <a:r>
+              <a:rPr lang="en-US" sz="1300" b="1" dirty="0">
+                <a:solidFill>
+                  <a:srgbClr val="E5484D"/>
                 </a:solidFill>
                 <a:latin typeface="Courier New" pitchFamily="34" charset="0"/>
                 <a:ea typeface="Courier New" pitchFamily="34" charset="-122"/>
                 <a:cs typeface="Courier New" pitchFamily="34" charset="-120"/>
               </a:rPr>
-              <a:t>HIT RATE, SESSION-WEIGHTED</a:t>
-            </a:r>
-            <a:endParaRPr lang="en-US" sz="1000" dirty="0"/>
-          </a:p>
-        </p:txBody>
-      </p:sp>
-      <p:sp>
-        <p:nvSpPr>
-          <p:cNvPr id="12" name="Text 10"/>
-          <p:cNvSpPr txBox="1"/>
-          <p:nvPr/>
-        </p:nvSpPr>
-        <p:spPr>
-          <a:xfrm>
-            <a:off x="4608576" y="2962656"/>
-            <a:ext cx="2935224" cy="548640"/>
+              <a:t>-$10,716</a:t>
+            </a:r>
+            <a:endParaRPr lang="en-US" sz="1300" dirty="0"/>
+          </a:p>
+        </p:txBody>
+      </p:sp>
+      <p:sp>
+        <p:nvSpPr>
+          <p:cNvPr id="12" name="Text 9"/>
+          <p:cNvSpPr txBox="1"/>
+          <p:nvPr/>
+        </p:nvSpPr>
+        <p:spPr>
+          <a:xfrm>
+            <a:off x="9875520" y="2240280"/>
+            <a:ext cx="1645920" cy="493776"/>
           </a:xfrm>
           <a:prstGeom prst="rect">
             <a:avLst/>
@@ -2863,53 +2808,11 @@
           <a:bodyPr wrap="square" lIns="0" tIns="0" rIns="0" bIns="0" rtlCol="0" anchor="ctr"/>
           <a:lstStyle/>
           <a:p>
-            <a:pPr indent="0" marL="0">
-              <a:buNone/>
-            </a:pPr>
-            <a:r>
-              <a:rPr lang="en-US" sz="4000" b="1" dirty="0">
-                <a:solidFill>
-                  <a:srgbClr val="E5484D"/>
-                </a:solidFill>
-                <a:latin typeface="Arial" pitchFamily="34" charset="0"/>
-                <a:ea typeface="Arial" pitchFamily="34" charset="-122"/>
-                <a:cs typeface="Arial" pitchFamily="34" charset="-120"/>
-              </a:rPr>
-              <a:t>49.4%</a:t>
-            </a:r>
-            <a:endParaRPr lang="en-US" sz="4000" dirty="0"/>
-          </a:p>
-        </p:txBody>
-      </p:sp>
-      <p:sp>
-        <p:nvSpPr>
-          <p:cNvPr id="13" name="Text 11"/>
-          <p:cNvSpPr txBox="1"/>
-          <p:nvPr/>
-        </p:nvSpPr>
-        <p:spPr>
-          <a:xfrm>
-            <a:off x="4608576" y="3566160"/>
-            <a:ext cx="2935224" cy="658368"/>
-          </a:xfrm>
-          <a:prstGeom prst="rect">
-            <a:avLst/>
-          </a:prstGeom>
-          <a:noFill/>
-          <a:ln/>
-        </p:spPr>
-        <p:txBody>
-          <a:bodyPr wrap="square" lIns="0" tIns="0" rIns="0" bIns="0" rtlCol="0" anchor="t"/>
-          <a:lstStyle/>
-          <a:p>
-            <a:pPr indent="0" marL="0">
-              <a:lnSpc>
-                <a:spcPct val="120000"/>
-              </a:lnSpc>
-              <a:buNone/>
-            </a:pPr>
-            <a:r>
-              <a:rPr lang="en-US" sz="1200" dirty="0">
+            <a:pPr algn="r" indent="0" marL="0">
+              <a:buNone/>
+            </a:pPr>
+            <a:r>
+              <a:rPr lang="en-US" sz="1100" dirty="0">
                 <a:solidFill>
                   <a:srgbClr val="A1A8B5"/>
                 </a:solidFill>
@@ -2917,26 +2820,26 @@
                 <a:ea typeface="Arial" pitchFamily="34" charset="-122"/>
                 <a:cs typeface="Arial" pitchFamily="34" charset="-120"/>
               </a:rPr>
-              <a:t>at +15 min. 49.2% at 30, 47.8% at 60 — worse with horizon.</a:t>
-            </a:r>
-            <a:endParaRPr lang="en-US" sz="1200" dirty="0"/>
-          </a:p>
-        </p:txBody>
-      </p:sp>
-      <p:sp>
-        <p:nvSpPr>
-          <p:cNvPr id="14" name="Shape 12"/>
+              <a:t>19 in / 16 out</a:t>
+            </a:r>
+            <a:endParaRPr lang="en-US" sz="1100" dirty="0"/>
+          </a:p>
+        </p:txBody>
+      </p:sp>
+      <p:sp>
+        <p:nvSpPr>
+          <p:cNvPr id="13" name="Shape 10"/>
           <p:cNvSpPr/>
           <p:nvPr/>
         </p:nvSpPr>
         <p:spPr>
           <a:xfrm>
-            <a:off x="8083296" y="2468880"/>
-            <a:ext cx="3557016" cy="1920240"/>
+            <a:off x="7269480" y="2807208"/>
+            <a:ext cx="4370832" cy="493776"/>
           </a:xfrm>
           <a:prstGeom prst="roundRect">
             <a:avLst>
-              <a:gd name="adj" fmla="val 3810"/>
+              <a:gd name="adj" fmla="val 11111"/>
             </a:avLst>
           </a:prstGeom>
           <a:solidFill>
@@ -2952,14 +2855,14 @@
       </p:sp>
       <p:sp>
         <p:nvSpPr>
-          <p:cNvPr id="15" name="Text 13"/>
-          <p:cNvSpPr txBox="1"/>
-          <p:nvPr/>
-        </p:nvSpPr>
-        <p:spPr>
-          <a:xfrm>
-            <a:off x="8375904" y="2670048"/>
-            <a:ext cx="2971800" cy="219456"/>
+          <p:cNvPr id="14" name="Text 11"/>
+          <p:cNvSpPr txBox="1"/>
+          <p:nvPr/>
+        </p:nvSpPr>
+        <p:spPr>
+          <a:xfrm>
+            <a:off x="7452360" y="2807208"/>
+            <a:ext cx="1005840" cy="493776"/>
           </a:xfrm>
           <a:prstGeom prst="rect">
             <a:avLst/>
@@ -2975,30 +2878,69 @@
               <a:buNone/>
             </a:pPr>
             <a:r>
-              <a:rPr lang="en-US" sz="1000" spc="140" kern="0" dirty="0">
-                <a:solidFill>
-                  <a:srgbClr val="6B7686"/>
+              <a:rPr lang="en-US" sz="1300" b="1" dirty="0">
+                <a:solidFill>
+                  <a:srgbClr val="FFFFFF"/>
+                </a:solidFill>
+                <a:latin typeface="Arial" pitchFamily="34" charset="0"/>
+                <a:ea typeface="Arial" pitchFamily="34" charset="-122"/>
+                <a:cs typeface="Arial" pitchFamily="34" charset="-120"/>
+              </a:rPr>
+              <a:t>Sep 1</a:t>
+            </a:r>
+            <a:endParaRPr lang="en-US" sz="1300" dirty="0"/>
+          </a:p>
+        </p:txBody>
+      </p:sp>
+      <p:sp>
+        <p:nvSpPr>
+          <p:cNvPr id="15" name="Text 12"/>
+          <p:cNvSpPr txBox="1"/>
+          <p:nvPr/>
+        </p:nvSpPr>
+        <p:spPr>
+          <a:xfrm>
+            <a:off x="8458200" y="2807208"/>
+            <a:ext cx="1371600" cy="493776"/>
+          </a:xfrm>
+          <a:prstGeom prst="rect">
+            <a:avLst/>
+          </a:prstGeom>
+          <a:noFill/>
+          <a:ln/>
+        </p:spPr>
+        <p:txBody>
+          <a:bodyPr wrap="square" lIns="0" tIns="0" rIns="0" bIns="0" rtlCol="0" anchor="ctr"/>
+          <a:lstStyle/>
+          <a:p>
+            <a:pPr algn="r" indent="0" marL="0">
+              <a:buNone/>
+            </a:pPr>
+            <a:r>
+              <a:rPr lang="en-US" sz="1300" b="1" dirty="0">
+                <a:solidFill>
+                  <a:srgbClr val="F0B429"/>
                 </a:solidFill>
                 <a:latin typeface="Courier New" pitchFamily="34" charset="0"/>
                 <a:ea typeface="Courier New" pitchFamily="34" charset="-122"/>
                 <a:cs typeface="Courier New" pitchFamily="34" charset="-120"/>
               </a:rPr>
-              <a:t>THE MOVE VS THE COST</a:t>
-            </a:r>
-            <a:endParaRPr lang="en-US" sz="1000" dirty="0"/>
-          </a:p>
-        </p:txBody>
-      </p:sp>
-      <p:sp>
-        <p:nvSpPr>
-          <p:cNvPr id="16" name="Text 14"/>
-          <p:cNvSpPr txBox="1"/>
-          <p:nvPr/>
-        </p:nvSpPr>
-        <p:spPr>
-          <a:xfrm>
-            <a:off x="8375904" y="2962656"/>
-            <a:ext cx="2971800" cy="548640"/>
+              <a:t>+$14,353</a:t>
+            </a:r>
+            <a:endParaRPr lang="en-US" sz="1300" dirty="0"/>
+          </a:p>
+        </p:txBody>
+      </p:sp>
+      <p:sp>
+        <p:nvSpPr>
+          <p:cNvPr id="16" name="Text 13"/>
+          <p:cNvSpPr txBox="1"/>
+          <p:nvPr/>
+        </p:nvSpPr>
+        <p:spPr>
+          <a:xfrm>
+            <a:off x="9875520" y="2807208"/>
+            <a:ext cx="1645920" cy="493776"/>
           </a:xfrm>
           <a:prstGeom prst="rect">
             <a:avLst/>
@@ -3010,53 +2952,11 @@
           <a:bodyPr wrap="square" lIns="0" tIns="0" rIns="0" bIns="0" rtlCol="0" anchor="ctr"/>
           <a:lstStyle/>
           <a:p>
-            <a:pPr indent="0" marL="0">
-              <a:buNone/>
-            </a:pPr>
-            <a:r>
-              <a:rPr lang="en-US" sz="4000" b="1" dirty="0">
-                <a:solidFill>
-                  <a:srgbClr val="E5484D"/>
-                </a:solidFill>
-                <a:latin typeface="Arial" pitchFamily="34" charset="0"/>
-                <a:ea typeface="Arial" pitchFamily="34" charset="-122"/>
-                <a:cs typeface="Arial" pitchFamily="34" charset="-120"/>
-              </a:rPr>
-              <a:t>11 bp</a:t>
-            </a:r>
-            <a:endParaRPr lang="en-US" sz="4000" dirty="0"/>
-          </a:p>
-        </p:txBody>
-      </p:sp>
-      <p:sp>
-        <p:nvSpPr>
-          <p:cNvPr id="17" name="Text 15"/>
-          <p:cNvSpPr txBox="1"/>
-          <p:nvPr/>
-        </p:nvSpPr>
-        <p:spPr>
-          <a:xfrm>
-            <a:off x="8375904" y="3566160"/>
-            <a:ext cx="2971800" cy="658368"/>
-          </a:xfrm>
-          <a:prstGeom prst="rect">
-            <a:avLst/>
-          </a:prstGeom>
-          <a:noFill/>
-          <a:ln/>
-        </p:spPr>
-        <p:txBody>
-          <a:bodyPr wrap="square" lIns="0" tIns="0" rIns="0" bIns="0" rtlCol="0" anchor="t"/>
-          <a:lstStyle/>
-          <a:p>
-            <a:pPr indent="0" marL="0">
-              <a:lnSpc>
-                <a:spcPct val="120000"/>
-              </a:lnSpc>
-              <a:buNone/>
-            </a:pPr>
-            <a:r>
-              <a:rPr lang="en-US" sz="1200" dirty="0">
+            <a:pPr algn="r" indent="0" marL="0">
+              <a:buNone/>
+            </a:pPr>
+            <a:r>
+              <a:rPr lang="en-US" sz="1100" dirty="0">
                 <a:solidFill>
                   <a:srgbClr val="A1A8B5"/>
                 </a:solidFill>
@@ -3064,22 +2964,49 @@
                 <a:ea typeface="Arial" pitchFamily="34" charset="-122"/>
                 <a:cs typeface="Arial" pitchFamily="34" charset="-120"/>
               </a:rPr>
-              <a:t>median 30-min move. Crossing the spread costs ~20 bp before decay.</a:t>
-            </a:r>
-            <a:endParaRPr lang="en-US" sz="1200" dirty="0"/>
-          </a:p>
-        </p:txBody>
-      </p:sp>
-      <p:sp>
-        <p:nvSpPr>
-          <p:cNvPr id="18" name="Text 16"/>
-          <p:cNvSpPr txBox="1"/>
-          <p:nvPr/>
-        </p:nvSpPr>
-        <p:spPr>
-          <a:xfrm>
-            <a:off x="548640" y="4709160"/>
-            <a:ext cx="11064240" cy="822960"/>
+              <a:t>5 in / 9 out</a:t>
+            </a:r>
+            <a:endParaRPr lang="en-US" sz="1100" dirty="0"/>
+          </a:p>
+        </p:txBody>
+      </p:sp>
+      <p:sp>
+        <p:nvSpPr>
+          <p:cNvPr id="17" name="Shape 14"/>
+          <p:cNvSpPr/>
+          <p:nvPr/>
+        </p:nvSpPr>
+        <p:spPr>
+          <a:xfrm>
+            <a:off x="7269480" y="3374136"/>
+            <a:ext cx="4370832" cy="493776"/>
+          </a:xfrm>
+          <a:prstGeom prst="roundRect">
+            <a:avLst>
+              <a:gd name="adj" fmla="val 11111"/>
+            </a:avLst>
+          </a:prstGeom>
+          <a:solidFill>
+            <a:srgbClr val="141922"/>
+          </a:solidFill>
+          <a:ln w="12700">
+            <a:solidFill>
+              <a:srgbClr val="232A38"/>
+            </a:solidFill>
+            <a:prstDash val="solid"/>
+          </a:ln>
+        </p:spPr>
+      </p:sp>
+      <p:sp>
+        <p:nvSpPr>
+          <p:cNvPr id="18" name="Text 15"/>
+          <p:cNvSpPr txBox="1"/>
+          <p:nvPr/>
+        </p:nvSpPr>
+        <p:spPr>
+          <a:xfrm>
+            <a:off x="7452360" y="3374136"/>
+            <a:ext cx="1005840" cy="493776"/>
           </a:xfrm>
           <a:prstGeom prst="rect">
             <a:avLst/>
@@ -3092,13 +3019,10 @@
           <a:lstStyle/>
           <a:p>
             <a:pPr indent="0" marL="0">
-              <a:lnSpc>
-                <a:spcPct val="130000"/>
-              </a:lnSpc>
-              <a:buNone/>
-            </a:pPr>
-            <a:r>
-              <a:rPr lang="en-US" sz="1500" i="1" dirty="0">
+              <a:buNone/>
+            </a:pPr>
+            <a:r>
+              <a:rPr lang="en-US" sz="1300" b="1" dirty="0">
                 <a:solidFill>
                   <a:srgbClr val="FFFFFF"/>
                 </a:solidFill>
@@ -3106,22 +3030,22 @@
                 <a:ea typeface="Arial" pitchFamily="34" charset="-122"/>
                 <a:cs typeface="Arial" pitchFamily="34" charset="-120"/>
               </a:rPr>
-              <a:t>“The apparent 52% was a size-weighting artifact of a handful of busy sessions. The recurring trap: any rule that cuts position count flatters a negative-expectancy book.”</a:t>
-            </a:r>
-            <a:endParaRPr lang="en-US" sz="1500" dirty="0"/>
-          </a:p>
-        </p:txBody>
-      </p:sp>
-      <p:sp>
-        <p:nvSpPr>
-          <p:cNvPr id="19" name="Text 17"/>
-          <p:cNvSpPr txBox="1"/>
-          <p:nvPr/>
-        </p:nvSpPr>
-        <p:spPr>
-          <a:xfrm>
-            <a:off x="548640" y="5623560"/>
-            <a:ext cx="7315200" cy="274320"/>
+              <a:t>Sep 3</a:t>
+            </a:r>
+            <a:endParaRPr lang="en-US" sz="1300" dirty="0"/>
+          </a:p>
+        </p:txBody>
+      </p:sp>
+      <p:sp>
+        <p:nvSpPr>
+          <p:cNvPr id="19" name="Text 16"/>
+          <p:cNvSpPr txBox="1"/>
+          <p:nvPr/>
+        </p:nvSpPr>
+        <p:spPr>
+          <a:xfrm>
+            <a:off x="8458200" y="3374136"/>
+            <a:ext cx="1371600" cy="493776"/>
           </a:xfrm>
           <a:prstGeom prst="rect">
             <a:avLst/>
@@ -3133,21 +3057,207 @@
           <a:bodyPr wrap="square" lIns="0" tIns="0" rIns="0" bIns="0" rtlCol="0" anchor="ctr"/>
           <a:lstStyle/>
           <a:p>
-            <a:pPr indent="0" marL="0">
-              <a:buNone/>
-            </a:pPr>
-            <a:r>
-              <a:rPr lang="en-US" sz="1000" dirty="0">
-                <a:solidFill>
-                  <a:srgbClr val="6B7686"/>
+            <a:pPr algn="r" indent="0" marL="0">
+              <a:buNone/>
+            </a:pPr>
+            <a:r>
+              <a:rPr lang="en-US" sz="1300" b="1" dirty="0">
+                <a:solidFill>
+                  <a:srgbClr val="F0B429"/>
                 </a:solidFill>
                 <a:latin typeface="Courier New" pitchFamily="34" charset="0"/>
                 <a:ea typeface="Courier New" pitchFamily="34" charset="-122"/>
                 <a:cs typeface="Courier New" pitchFamily="34" charset="-120"/>
               </a:rPr>
-              <a:t>docs/research.md — the full autopsy, including every filter we retired</a:t>
+              <a:t>+$75,450</a:t>
+            </a:r>
+            <a:endParaRPr lang="en-US" sz="1300" dirty="0"/>
+          </a:p>
+        </p:txBody>
+      </p:sp>
+      <p:sp>
+        <p:nvSpPr>
+          <p:cNvPr id="20" name="Text 17"/>
+          <p:cNvSpPr txBox="1"/>
+          <p:nvPr/>
+        </p:nvSpPr>
+        <p:spPr>
+          <a:xfrm>
+            <a:off x="9875520" y="3374136"/>
+            <a:ext cx="1645920" cy="493776"/>
+          </a:xfrm>
+          <a:prstGeom prst="rect">
+            <a:avLst/>
+          </a:prstGeom>
+          <a:noFill/>
+          <a:ln/>
+        </p:spPr>
+        <p:txBody>
+          <a:bodyPr wrap="square" lIns="0" tIns="0" rIns="0" bIns="0" rtlCol="0" anchor="ctr"/>
+          <a:lstStyle/>
+          <a:p>
+            <a:pPr algn="r" indent="0" marL="0">
+              <a:buNone/>
+            </a:pPr>
+            <a:r>
+              <a:rPr lang="en-US" sz="1100" dirty="0">
+                <a:solidFill>
+                  <a:srgbClr val="A1A8B5"/>
+                </a:solidFill>
+                <a:latin typeface="Arial" pitchFamily="34" charset="0"/>
+                <a:ea typeface="Arial" pitchFamily="34" charset="-122"/>
+                <a:cs typeface="Arial" pitchFamily="34" charset="-120"/>
+              </a:rPr>
+              <a:t>10 in / 18 out</a:t>
+            </a:r>
+            <a:endParaRPr lang="en-US" sz="1100" dirty="0"/>
+          </a:p>
+        </p:txBody>
+      </p:sp>
+      <p:sp>
+        <p:nvSpPr>
+          <p:cNvPr id="21" name="Shape 18"/>
+          <p:cNvSpPr/>
+          <p:nvPr/>
+        </p:nvSpPr>
+        <p:spPr>
+          <a:xfrm>
+            <a:off x="7269480" y="4050792"/>
+            <a:ext cx="4370832" cy="896112"/>
+          </a:xfrm>
+          <a:prstGeom prst="roundRect">
+            <a:avLst>
+              <a:gd name="adj" fmla="val 8163"/>
+            </a:avLst>
+          </a:prstGeom>
+          <a:solidFill>
+            <a:srgbClr val="141922"/>
+          </a:solidFill>
+          <a:ln w="12700">
+            <a:solidFill>
+              <a:srgbClr val="232A38"/>
+            </a:solidFill>
+            <a:prstDash val="solid"/>
+          </a:ln>
+        </p:spPr>
+      </p:sp>
+      <p:sp>
+        <p:nvSpPr>
+          <p:cNvPr id="22" name="Text 19"/>
+          <p:cNvSpPr txBox="1"/>
+          <p:nvPr/>
+        </p:nvSpPr>
+        <p:spPr>
+          <a:xfrm>
+            <a:off x="7562088" y="4251960"/>
+            <a:ext cx="3785616" cy="219456"/>
+          </a:xfrm>
+          <a:prstGeom prst="rect">
+            <a:avLst/>
+          </a:prstGeom>
+          <a:noFill/>
+          <a:ln/>
+        </p:spPr>
+        <p:txBody>
+          <a:bodyPr wrap="square" lIns="0" tIns="0" rIns="0" bIns="0" rtlCol="0" anchor="ctr"/>
+          <a:lstStyle/>
+          <a:p>
+            <a:pPr indent="0" marL="0">
+              <a:buNone/>
+            </a:pPr>
+            <a:r>
+              <a:rPr lang="en-US" sz="1000" spc="140" kern="0" dirty="0">
+                <a:solidFill>
+                  <a:srgbClr val="6B7686"/>
+                </a:solidFill>
+                <a:latin typeface="Courier New" pitchFamily="34" charset="0"/>
+                <a:ea typeface="Courier New" pitchFamily="34" charset="-122"/>
+                <a:cs typeface="Courier New" pitchFamily="34" charset="-120"/>
+              </a:rPr>
+              <a:t>NET</a:t>
             </a:r>
             <a:endParaRPr lang="en-US" sz="1000" dirty="0"/>
+          </a:p>
+        </p:txBody>
+      </p:sp>
+      <p:sp>
+        <p:nvSpPr>
+          <p:cNvPr id="23" name="Text 20"/>
+          <p:cNvSpPr txBox="1"/>
+          <p:nvPr/>
+        </p:nvSpPr>
+        <p:spPr>
+          <a:xfrm>
+            <a:off x="7562088" y="4544568"/>
+            <a:ext cx="3785616" cy="384048"/>
+          </a:xfrm>
+          <a:prstGeom prst="rect">
+            <a:avLst/>
+          </a:prstGeom>
+          <a:noFill/>
+          <a:ln/>
+        </p:spPr>
+        <p:txBody>
+          <a:bodyPr wrap="square" lIns="0" tIns="0" rIns="0" bIns="0" rtlCol="0" anchor="ctr"/>
+          <a:lstStyle/>
+          <a:p>
+            <a:pPr indent="0" marL="0">
+              <a:buNone/>
+            </a:pPr>
+            <a:r>
+              <a:rPr lang="en-US" sz="2100" b="1" dirty="0">
+                <a:solidFill>
+                  <a:srgbClr val="F0B429"/>
+                </a:solidFill>
+                <a:latin typeface="Arial" pitchFamily="34" charset="0"/>
+                <a:ea typeface="Arial" pitchFamily="34" charset="-122"/>
+                <a:cs typeface="Arial" pitchFamily="34" charset="-120"/>
+              </a:rPr>
+              <a:t>+79.1%  ·  $179,087</a:t>
+            </a:r>
+            <a:endParaRPr lang="en-US" sz="2100" dirty="0"/>
+          </a:p>
+        </p:txBody>
+      </p:sp>
+      <p:sp>
+        <p:nvSpPr>
+          <p:cNvPr id="24" name="Text 21"/>
+          <p:cNvSpPr txBox="1"/>
+          <p:nvPr/>
+        </p:nvSpPr>
+        <p:spPr>
+          <a:xfrm>
+            <a:off x="548640" y="5166360"/>
+            <a:ext cx="11091672" cy="731520"/>
+          </a:xfrm>
+          <a:prstGeom prst="rect">
+            <a:avLst/>
+          </a:prstGeom>
+          <a:noFill/>
+          <a:ln/>
+        </p:spPr>
+        <p:txBody>
+          <a:bodyPr wrap="square" lIns="0" tIns="0" rIns="0" bIns="0" rtlCol="0" anchor="ctr"/>
+          <a:lstStyle/>
+          <a:p>
+            <a:pPr indent="0" marL="0">
+              <a:lnSpc>
+                <a:spcPct val="125000"/>
+              </a:lnSpc>
+              <a:buNone/>
+            </a:pPr>
+            <a:r>
+              <a:rPr lang="en-US" sz="1300" dirty="0">
+                <a:solidFill>
+                  <a:srgbClr val="A1A8B5"/>
+                </a:solidFill>
+                <a:latin typeface="Arial" pitchFamily="34" charset="0"/>
+                <a:ea typeface="Arial" pitchFamily="34" charset="-122"/>
+                <a:cs typeface="Arial" pitchFamily="34" charset="-120"/>
+              </a:rPr>
+              <a:t>34 entries and 43 exits on SPY / QQQ / IWM, every one placed through the Alpaca CLI and booked at the real broker fill. Positions are flat at the close of every session - the agent never carries a 0DTE into expiry.</a:t>
+            </a:r>
+            <a:endParaRPr lang="en-US" sz="1300" dirty="0"/>
           </a:p>
         </p:txBody>
       </p:sp>
@@ -3216,7 +3326,7 @@
                 <a:ea typeface="Courier New" pitchFamily="34" charset="-122"/>
                 <a:cs typeface="Courier New" pitchFamily="34" charset="-120"/>
               </a:rPr>
-              <a:t>02  ·  The design</a:t>
+              <a:t>02  ·  How it works</a:t>
             </a:r>
             <a:endParaRPr lang="en-US" sz="1100" dirty="0"/>
           </a:p>
@@ -3255,7 +3365,7 @@
                 <a:ea typeface="Courier New" pitchFamily="34" charset="-122"/>
                 <a:cs typeface="Courier New" pitchFamily="34" charset="-120"/>
               </a:rPr>
-              <a:t>github.com/KIBA0993/defined-risk-0dte-agent</a:t>
+              <a:t>github.com/KIBA0993/Alpaca-Hackathon</a:t>
             </a:r>
             <a:endParaRPr lang="en-US" sz="900" dirty="0"/>
           </a:p>
@@ -3294,7 +3404,7 @@
                 <a:ea typeface="Arial" pitchFamily="34" charset="-122"/>
                 <a:cs typeface="Arial" pitchFamily="34" charset="-120"/>
               </a:rPr>
-              <a:t>So we built what survives not having one</a:t>
+              <a:t>One loop, six stages, no human in it</a:t>
             </a:r>
             <a:endParaRPr lang="en-US" sz="3400" dirty="0"/>
           </a:p>
@@ -3309,7 +3419,7 @@
         <p:spPr>
           <a:xfrm>
             <a:off x="548640" y="1965960"/>
-            <a:ext cx="1700784" cy="1371600"/>
+            <a:ext cx="1680972" cy="1371600"/>
           </a:xfrm>
           <a:prstGeom prst="roundRect">
             <a:avLst>
@@ -3335,8 +3445,8 @@
         </p:nvSpPr>
         <p:spPr>
           <a:xfrm>
-            <a:off x="548640" y="2121408"/>
-            <a:ext cx="1700784" cy="274320"/>
+            <a:off x="548640" y="2130552"/>
+            <a:ext cx="1680972" cy="274320"/>
           </a:xfrm>
           <a:prstGeom prst="rect">
             <a:avLst/>
@@ -3374,8 +3484,8 @@
         </p:nvSpPr>
         <p:spPr>
           <a:xfrm>
-            <a:off x="640080" y="2450592"/>
-            <a:ext cx="1517904" cy="777240"/>
+            <a:off x="640080" y="2459736"/>
+            <a:ext cx="1498092" cy="749808"/>
           </a:xfrm>
           <a:prstGeom prst="rect">
             <a:avLst/>
@@ -3416,7 +3526,7 @@
         </p:nvSpPr>
         <p:spPr>
           <a:xfrm>
-            <a:off x="2249424" y="2377440"/>
+            <a:off x="2229612" y="2468880"/>
             <a:ext cx="201168" cy="365760"/>
           </a:xfrm>
           <a:prstGeom prst="rect">
@@ -3455,8 +3565,8 @@
         </p:nvSpPr>
         <p:spPr>
           <a:xfrm>
-            <a:off x="2450592" y="1965960"/>
-            <a:ext cx="1700784" cy="1371600"/>
+            <a:off x="2430780" y="1965960"/>
+            <a:ext cx="1680972" cy="1371600"/>
           </a:xfrm>
           <a:prstGeom prst="roundRect">
             <a:avLst>
@@ -3482,8 +3592,8 @@
         </p:nvSpPr>
         <p:spPr>
           <a:xfrm>
-            <a:off x="2450592" y="2121408"/>
-            <a:ext cx="1700784" cy="274320"/>
+            <a:off x="2430780" y="2130552"/>
+            <a:ext cx="1680972" cy="274320"/>
           </a:xfrm>
           <a:prstGeom prst="rect">
             <a:avLst/>
@@ -3521,8 +3631,8 @@
         </p:nvSpPr>
         <p:spPr>
           <a:xfrm>
-            <a:off x="2542032" y="2450592"/>
-            <a:ext cx="1517904" cy="777240"/>
+            <a:off x="2522220" y="2459736"/>
+            <a:ext cx="1498092" cy="749808"/>
           </a:xfrm>
           <a:prstGeom prst="rect">
             <a:avLst/>
@@ -3583,7 +3693,7 @@
         </p:nvSpPr>
         <p:spPr>
           <a:xfrm>
-            <a:off x="4151376" y="2377440"/>
+            <a:off x="4111752" y="2468880"/>
             <a:ext cx="201168" cy="365760"/>
           </a:xfrm>
           <a:prstGeom prst="rect">
@@ -3622,8 +3732,8 @@
         </p:nvSpPr>
         <p:spPr>
           <a:xfrm>
-            <a:off x="4352544" y="1965960"/>
-            <a:ext cx="1700784" cy="1371600"/>
+            <a:off x="4312920" y="1965960"/>
+            <a:ext cx="1680972" cy="1371600"/>
           </a:xfrm>
           <a:prstGeom prst="roundRect">
             <a:avLst>
@@ -3649,8 +3759,8 @@
         </p:nvSpPr>
         <p:spPr>
           <a:xfrm>
-            <a:off x="4352544" y="2121408"/>
-            <a:ext cx="1700784" cy="274320"/>
+            <a:off x="4312920" y="2130552"/>
+            <a:ext cx="1680972" cy="274320"/>
           </a:xfrm>
           <a:prstGeom prst="rect">
             <a:avLst/>
@@ -3688,8 +3798,8 @@
         </p:nvSpPr>
         <p:spPr>
           <a:xfrm>
-            <a:off x="4443984" y="2450592"/>
-            <a:ext cx="1517904" cy="777240"/>
+            <a:off x="4404360" y="2459736"/>
+            <a:ext cx="1498092" cy="749808"/>
           </a:xfrm>
           <a:prstGeom prst="rect">
             <a:avLst/>
@@ -3716,7 +3826,7 @@
                 <a:ea typeface="Arial" pitchFamily="34" charset="-122"/>
                 <a:cs typeface="Arial" pitchFamily="34" charset="-120"/>
               </a:rPr>
-              <a:t>band + regime</a:t>
+              <a:t>noise band +</a:t>
             </a:r>
             <a:endParaRPr lang="en-US" sz="1000" dirty="0"/>
           </a:p>
@@ -3736,7 +3846,7 @@
                 <a:ea typeface="Arial" pitchFamily="34" charset="-122"/>
                 <a:cs typeface="Arial" pitchFamily="34" charset="-120"/>
               </a:rPr>
-              <a:t>(+ optional veto)</a:t>
+              <a:t>regime</a:t>
             </a:r>
             <a:endParaRPr lang="en-US" sz="1000" dirty="0"/>
           </a:p>
@@ -3750,7 +3860,7 @@
         </p:nvSpPr>
         <p:spPr>
           <a:xfrm>
-            <a:off x="6053328" y="2377440"/>
+            <a:off x="5993892" y="2468880"/>
             <a:ext cx="201168" cy="365760"/>
           </a:xfrm>
           <a:prstGeom prst="rect">
@@ -3789,8 +3899,8 @@
         </p:nvSpPr>
         <p:spPr>
           <a:xfrm>
-            <a:off x="6254496" y="1965960"/>
-            <a:ext cx="1700784" cy="1371600"/>
+            <a:off x="6195060" y="1965960"/>
+            <a:ext cx="1680972" cy="1371600"/>
           </a:xfrm>
           <a:prstGeom prst="roundRect">
             <a:avLst>
@@ -3816,8 +3926,8 @@
         </p:nvSpPr>
         <p:spPr>
           <a:xfrm>
-            <a:off x="6254496" y="2121408"/>
-            <a:ext cx="1700784" cy="274320"/>
+            <a:off x="6195060" y="2130552"/>
+            <a:ext cx="1680972" cy="274320"/>
           </a:xfrm>
           <a:prstGeom prst="rect">
             <a:avLst/>
@@ -3855,8 +3965,8 @@
         </p:nvSpPr>
         <p:spPr>
           <a:xfrm>
-            <a:off x="6345936" y="2450592"/>
-            <a:ext cx="1517904" cy="777240"/>
+            <a:off x="6286500" y="2459736"/>
+            <a:ext cx="1498092" cy="749808"/>
           </a:xfrm>
           <a:prstGeom prst="rect">
             <a:avLst/>
@@ -3917,7 +4027,7 @@
         </p:nvSpPr>
         <p:spPr>
           <a:xfrm>
-            <a:off x="7955280" y="2377440"/>
+            <a:off x="7876032" y="2468880"/>
             <a:ext cx="201168" cy="365760"/>
           </a:xfrm>
           <a:prstGeom prst="rect">
@@ -3956,8 +4066,8 @@
         </p:nvSpPr>
         <p:spPr>
           <a:xfrm>
-            <a:off x="8156448" y="1965960"/>
-            <a:ext cx="1700784" cy="1371600"/>
+            <a:off x="8077200" y="1965960"/>
+            <a:ext cx="1680972" cy="1371600"/>
           </a:xfrm>
           <a:prstGeom prst="roundRect">
             <a:avLst>
@@ -3983,8 +4093,8 @@
         </p:nvSpPr>
         <p:spPr>
           <a:xfrm>
-            <a:off x="8156448" y="2121408"/>
-            <a:ext cx="1700784" cy="274320"/>
+            <a:off x="8077200" y="2130552"/>
+            <a:ext cx="1680972" cy="274320"/>
           </a:xfrm>
           <a:prstGeom prst="rect">
             <a:avLst/>
@@ -4022,8 +4132,8 @@
         </p:nvSpPr>
         <p:spPr>
           <a:xfrm>
-            <a:off x="8247888" y="2450592"/>
-            <a:ext cx="1517904" cy="777240"/>
+            <a:off x="8168640" y="2459736"/>
+            <a:ext cx="1498092" cy="749808"/>
           </a:xfrm>
           <a:prstGeom prst="rect">
             <a:avLst/>
@@ -4084,7 +4194,7 @@
         </p:nvSpPr>
         <p:spPr>
           <a:xfrm>
-            <a:off x="9857232" y="2377440"/>
+            <a:off x="9758172" y="2468880"/>
             <a:ext cx="201168" cy="365760"/>
           </a:xfrm>
           <a:prstGeom prst="rect">
@@ -4123,8 +4233,8 @@
         </p:nvSpPr>
         <p:spPr>
           <a:xfrm>
-            <a:off x="10058400" y="1965960"/>
-            <a:ext cx="1700784" cy="1371600"/>
+            <a:off x="9959340" y="1965960"/>
+            <a:ext cx="1680972" cy="1371600"/>
           </a:xfrm>
           <a:prstGeom prst="roundRect">
             <a:avLst>
@@ -4150,8 +4260,8 @@
         </p:nvSpPr>
         <p:spPr>
           <a:xfrm>
-            <a:off x="10058400" y="2121408"/>
-            <a:ext cx="1700784" cy="274320"/>
+            <a:off x="9959340" y="2130552"/>
+            <a:ext cx="1680972" cy="274320"/>
           </a:xfrm>
           <a:prstGeom prst="rect">
             <a:avLst/>
@@ -4189,8 +4299,8 @@
         </p:nvSpPr>
         <p:spPr>
           <a:xfrm>
-            <a:off x="10149840" y="2450592"/>
-            <a:ext cx="1517904" cy="777240"/>
+            <a:off x="10050780" y="2459736"/>
+            <a:ext cx="1498092" cy="749808"/>
           </a:xfrm>
           <a:prstGeom prst="rect">
             <a:avLst/>
@@ -4401,7 +4511,7 @@
                 <a:ea typeface="Arial" pitchFamily="34" charset="-122"/>
                 <a:cs typeface="Arial" pitchFamily="34" charset="-120"/>
               </a:rPr>
-              <a:t>Single-leg long only. No path to a blow-up — the point when there is no edge to lean on.</a:t>
+              <a:t>Single-leg long only. The ceiling is set by the instrument, not by code that has to remember.</a:t>
             </a:r>
             <a:endParaRPr lang="en-US" sz="1200" dirty="0"/>
           </a:p>
@@ -4467,7 +4577,7 @@
                 <a:ea typeface="Courier New" pitchFamily="34" charset="-122"/>
                 <a:cs typeface="Courier New" pitchFamily="34" charset="-120"/>
               </a:rPr>
-              <a:t>AI SCOPED TO RISK-OFF</a:t>
+              <a:t>VALIDATED, NOT GUESSED</a:t>
             </a:r>
             <a:endParaRPr lang="en-US" sz="1000" dirty="0"/>
           </a:p>
@@ -4506,24 +4616,7 @@
                 <a:ea typeface="Arial" pitchFamily="34" charset="-122"/>
                 <a:cs typeface="Arial" pitchFamily="34" charset="-120"/>
               </a:rPr>
-              <a:t>It can only</a:t>
-            </a:r>
-            <a:endParaRPr lang="en-US" sz="2000" dirty="0"/>
-          </a:p>
-          <a:p>
-            <a:pPr indent="0" marL="0">
-              <a:buNone/>
-            </a:pPr>
-            <a:r>
-              <a:rPr lang="en-US" sz="2000" b="1" dirty="0">
-                <a:solidFill>
-                  <a:srgbClr val="F0B429"/>
-                </a:solidFill>
-                <a:latin typeface="Arial" pitchFamily="34" charset="0"/>
-                <a:ea typeface="Arial" pitchFamily="34" charset="-122"/>
-                <a:cs typeface="Arial" pitchFamily="34" charset="-120"/>
-              </a:rPr>
-              <a:t>say no</a:t>
+              <a:t>264 sessions</a:t>
             </a:r>
             <a:endParaRPr lang="en-US" sz="2000" dirty="0"/>
           </a:p>
@@ -4565,7 +4658,7 @@
                 <a:ea typeface="Arial" pitchFamily="34" charset="-122"/>
                 <a:cs typeface="Arial" pitchFamily="34" charset="-120"/>
               </a:rPr>
-              <a:t>We could not measure the model adding P&amp;L, so we never let it manufacture conviction.</a:t>
+              <a:t>of real OPRA option bars and 4,544 alerts stand behind every control that ships.</a:t>
             </a:r>
             <a:endParaRPr lang="en-US" sz="1200" dirty="0"/>
           </a:p>
@@ -4631,7 +4724,7 @@
                 <a:ea typeface="Courier New" pitchFamily="34" charset="-122"/>
                 <a:cs typeface="Courier New" pitchFamily="34" charset="-120"/>
               </a:rPr>
-              <a:t>RADICAL TRANSPARENCY</a:t>
+              <a:t>FULLY AUTONOMOUS</a:t>
             </a:r>
             <a:endParaRPr lang="en-US" sz="1000" dirty="0"/>
           </a:p>
@@ -4670,7 +4763,7 @@
                 <a:ea typeface="Arial" pitchFamily="34" charset="-122"/>
                 <a:cs typeface="Arial" pitchFamily="34" charset="-120"/>
               </a:rPr>
-              <a:t>Every refusal</a:t>
+              <a:t>Docker,</a:t>
             </a:r>
             <a:endParaRPr lang="en-US" sz="2000" dirty="0"/>
           </a:p>
@@ -4687,7 +4780,7 @@
                 <a:ea typeface="Arial" pitchFamily="34" charset="-122"/>
                 <a:cs typeface="Arial" pitchFamily="34" charset="-120"/>
               </a:rPr>
-              <a:t>journaled</a:t>
+              <a:t>unattended</a:t>
             </a:r>
             <a:endParaRPr lang="en-US" sz="2000" dirty="0"/>
           </a:p>
@@ -4729,7 +4822,7 @@
                 <a:ea typeface="Arial" pitchFamily="34" charset="-122"/>
                 <a:cs typeface="Arial" pitchFamily="34" charset="-120"/>
               </a:rPr>
-              <a:t>One JSONL record per scan with the full reasoning. The audit trail is the product.</a:t>
+              <a:t>One session per weekday in an isolated container. Nobody approves a trade.</a:t>
             </a:r>
             <a:endParaRPr lang="en-US" sz="1200" dirty="0"/>
           </a:p>
@@ -4839,7 +4932,7 @@
                 <a:ea typeface="Courier New" pitchFamily="34" charset="-122"/>
                 <a:cs typeface="Courier New" pitchFamily="34" charset="-120"/>
               </a:rPr>
-              <a:t>github.com/KIBA0993/defined-risk-0dte-agent</a:t>
+              <a:t>github.com/KIBA0993/Alpaca-Hackathon</a:t>
             </a:r>
             <a:endParaRPr lang="en-US" sz="900" dirty="0"/>
           </a:p>
@@ -4878,7 +4971,7 @@
                 <a:ea typeface="Arial" pitchFamily="34" charset="-122"/>
                 <a:cs typeface="Arial" pitchFamily="34" charset="-120"/>
               </a:rPr>
-              <a:t>Risk is structural first, procedural second</a:t>
+              <a:t>Risk is structural before it is procedural</a:t>
             </a:r>
             <a:endParaRPr lang="en-US" sz="3400" dirty="0"/>
           </a:p>
@@ -4958,7 +5051,7 @@
                 <a:ea typeface="Arial" pitchFamily="34" charset="-122"/>
                 <a:cs typeface="Arial" pitchFamily="34" charset="-120"/>
               </a:rPr>
-              <a:t>Maximum loss is the premium paid — enforced by the instrument, not by code that has to remember.</a:t>
+              <a:t>Maximum loss is the premium paid - enforced by the instrument, not by code that has to remember.</a:t>
             </a:r>
             <a:endParaRPr lang="en-US" sz="1400" dirty="0"/>
           </a:p>
@@ -5348,7 +5441,7 @@
                 <a:ea typeface="Courier New" pitchFamily="34" charset="-122"/>
                 <a:cs typeface="Courier New" pitchFamily="34" charset="-120"/>
               </a:rPr>
-              <a:t>SCOPED COOLDOWN · 15 MIN</a:t>
+              <a:t>ADAPTIVE SIZING</a:t>
             </a:r>
             <a:endParaRPr lang="en-US" sz="1000" dirty="0"/>
           </a:p>
@@ -5390,7 +5483,7 @@
                 <a:ea typeface="Arial" pitchFamily="34" charset="-122"/>
                 <a:cs typeface="Arial" pitchFamily="34" charset="-120"/>
               </a:rPr>
-              <a:t>Re-entry block armed only by a time_stop close.</a:t>
+              <a:t>Trimmed to the account's real options buying power - an expensive contract sizes down, never rejects.</a:t>
             </a:r>
             <a:endParaRPr lang="en-US" sz="1100" dirty="0"/>
           </a:p>
@@ -5456,7 +5549,7 @@
                 <a:ea typeface="Courier New" pitchFamily="34" charset="-122"/>
                 <a:cs typeface="Courier New" pitchFamily="34" charset="-120"/>
               </a:rPr>
-              <a:t>ADAPTIVE SIZING</a:t>
+              <a:t>SESSION WINDOW</a:t>
             </a:r>
             <a:endParaRPr lang="en-US" sz="1000" dirty="0"/>
           </a:p>
@@ -5498,7 +5591,7 @@
                 <a:ea typeface="Arial" pitchFamily="34" charset="-122"/>
                 <a:cs typeface="Arial" pitchFamily="34" charset="-120"/>
               </a:rPr>
-              <a:t>Target trimmed to the account's real options buying power — pricey contracts size down, never reject.</a:t>
+              <a:t>No entry after 15:00 ET. Hard flatten at 15:50 - a 0DTE never reaches expiry.</a:t>
             </a:r>
             <a:endParaRPr lang="en-US" sz="1100" dirty="0"/>
           </a:p>
@@ -5564,7 +5657,7 @@
                 <a:ea typeface="Courier New" pitchFamily="34" charset="-122"/>
                 <a:cs typeface="Courier New" pitchFamily="34" charset="-120"/>
               </a:rPr>
-              <a:t>SESSION WINDOW</a:t>
+              <a:t>ORPHAN SWEEP</a:t>
             </a:r>
             <a:endParaRPr lang="en-US" sz="1000" dirty="0"/>
           </a:p>
@@ -5606,7 +5699,7 @@
                 <a:ea typeface="Arial" pitchFamily="34" charset="-122"/>
                 <a:cs typeface="Arial" pitchFamily="34" charset="-120"/>
               </a:rPr>
-              <a:t>No entry after 15:00 ET. Hard flatten 15:50 — a 0DTE never reaches expiry.</a:t>
+              <a:t>Any option position the agent did not open is flattened at startup and at EOD.</a:t>
             </a:r>
             <a:endParaRPr lang="en-US" sz="1100" dirty="0"/>
           </a:p>
@@ -5621,7 +5714,7 @@
         <p:spPr>
           <a:xfrm>
             <a:off x="548640" y="5870448"/>
-            <a:ext cx="11091672" cy="457200"/>
+            <a:ext cx="11091672" cy="365760"/>
           </a:xfrm>
           <a:prstGeom prst="rect">
             <a:avLst/>
@@ -5645,7 +5738,7 @@
                 <a:ea typeface="Arial" pitchFamily="34" charset="-122"/>
                 <a:cs typeface="Arial" pitchFamily="34" charset="-120"/>
               </a:rPr>
-              <a:t>Exits ladder both ways:  +40% scales out half and trails the runner  ·  −20% sells half, −40% the rest, −65% backstop  ·  30-min time stop  ·  EOD flatten  ·  175 tests.</a:t>
+              <a:t>Exits ladder in both directions:  +40% scales out half and trails the runner by 40% of its peak gain  ·  -20% sells half, -40% the rest  ·  a 30-minute stop closes anything still under water  ·  15:50 flatten.</a:t>
             </a:r>
             <a:endParaRPr lang="en-US" sz="1100" dirty="0"/>
           </a:p>
@@ -5755,7 +5848,7 @@
                 <a:ea typeface="Courier New" pitchFamily="34" charset="-122"/>
                 <a:cs typeface="Courier New" pitchFamily="34" charset="-120"/>
               </a:rPr>
-              <a:t>github.com/KIBA0993/defined-risk-0dte-agent</a:t>
+              <a:t>github.com/KIBA0993/Alpaca-Hackathon</a:t>
             </a:r>
             <a:endParaRPr lang="en-US" sz="900" dirty="0"/>
           </a:p>
@@ -5794,7 +5887,7 @@
                 <a:ea typeface="Arial" pitchFamily="34" charset="-122"/>
                 <a:cs typeface="Arial" pitchFamily="34" charset="-120"/>
               </a:rPr>
-              <a:t>The AI is the least-trusted component, by design</a:t>
+              <a:t>An AI that is structurally incapable of adding risk</a:t>
             </a:r>
             <a:endParaRPr lang="en-US" sz="3400" dirty="0"/>
           </a:p>
@@ -5809,7 +5902,7 @@
         <p:spPr>
           <a:xfrm>
             <a:off x="548640" y="1874520"/>
-            <a:ext cx="2651760" cy="1417320"/>
+            <a:ext cx="2622042" cy="1417320"/>
           </a:xfrm>
           <a:prstGeom prst="roundRect">
             <a:avLst>
@@ -5835,8 +5928,8 @@
         </p:nvSpPr>
         <p:spPr>
           <a:xfrm>
-            <a:off x="548640" y="2048256"/>
-            <a:ext cx="2651760" cy="292608"/>
+            <a:off x="548640" y="2039112"/>
+            <a:ext cx="2622042" cy="274320"/>
           </a:xfrm>
           <a:prstGeom prst="rect">
             <a:avLst/>
@@ -5852,17 +5945,17 @@
               <a:buNone/>
             </a:pPr>
             <a:r>
-              <a:rPr lang="en-US" sz="1400" b="1" dirty="0">
+              <a:rPr lang="en-US" sz="1200" b="1" dirty="0">
                 <a:solidFill>
                   <a:srgbClr val="FFFFFF"/>
                 </a:solidFill>
-                <a:latin typeface="Arial" pitchFamily="34" charset="0"/>
-                <a:ea typeface="Arial" pitchFamily="34" charset="-122"/>
-                <a:cs typeface="Arial" pitchFamily="34" charset="-120"/>
-              </a:rPr>
-              <a:t>Scored signal</a:t>
-            </a:r>
-            <a:endParaRPr lang="en-US" sz="1400" dirty="0"/>
+                <a:latin typeface="Courier New" pitchFamily="34" charset="0"/>
+                <a:ea typeface="Courier New" pitchFamily="34" charset="-122"/>
+                <a:cs typeface="Courier New" pitchFamily="34" charset="-120"/>
+              </a:rPr>
+              <a:t>SCORED SIGNAL</a:t>
+            </a:r>
+            <a:endParaRPr lang="en-US" sz="1200" dirty="0"/>
           </a:p>
         </p:txBody>
       </p:sp>
@@ -5874,8 +5967,8 @@
         </p:nvSpPr>
         <p:spPr>
           <a:xfrm>
-            <a:off x="685800" y="2414016"/>
-            <a:ext cx="2377440" cy="731520"/>
+            <a:off x="640080" y="2368296"/>
+            <a:ext cx="2439162" cy="795528"/>
           </a:xfrm>
           <a:prstGeom prst="rect">
             <a:avLst/>
@@ -5936,8 +6029,8 @@
         </p:nvSpPr>
         <p:spPr>
           <a:xfrm>
-            <a:off x="3200400" y="2331720"/>
-            <a:ext cx="256032" cy="365760"/>
+            <a:off x="3170682" y="2400300"/>
+            <a:ext cx="201168" cy="365760"/>
           </a:xfrm>
           <a:prstGeom prst="rect">
             <a:avLst/>
@@ -5953,7 +6046,7 @@
               <a:buNone/>
             </a:pPr>
             <a:r>
-              <a:rPr lang="en-US" sz="1800" dirty="0">
+              <a:rPr lang="en-US" sz="1600" dirty="0">
                 <a:solidFill>
                   <a:srgbClr val="6B7686"/>
                 </a:solidFill>
@@ -5963,7 +6056,7 @@
               </a:rPr>
               <a:t>›</a:t>
             </a:r>
-            <a:endParaRPr lang="en-US" sz="1800" dirty="0"/>
+            <a:endParaRPr lang="en-US" sz="1600" dirty="0"/>
           </a:p>
         </p:txBody>
       </p:sp>
@@ -5975,8 +6068,8 @@
         </p:nvSpPr>
         <p:spPr>
           <a:xfrm>
-            <a:off x="3456432" y="1874520"/>
-            <a:ext cx="2651760" cy="1417320"/>
+            <a:off x="3371850" y="1874520"/>
+            <a:ext cx="2622042" cy="1417320"/>
           </a:xfrm>
           <a:prstGeom prst="roundRect">
             <a:avLst>
@@ -6002,8 +6095,8 @@
         </p:nvSpPr>
         <p:spPr>
           <a:xfrm>
-            <a:off x="3456432" y="2048256"/>
-            <a:ext cx="2651760" cy="292608"/>
+            <a:off x="3371850" y="2039112"/>
+            <a:ext cx="2622042" cy="274320"/>
           </a:xfrm>
           <a:prstGeom prst="rect">
             <a:avLst/>
@@ -6019,17 +6112,17 @@
               <a:buNone/>
             </a:pPr>
             <a:r>
-              <a:rPr lang="en-US" sz="1400" b="1" dirty="0">
+              <a:rPr lang="en-US" sz="1200" b="1" dirty="0">
                 <a:solidFill>
                   <a:srgbClr val="FFFFFF"/>
                 </a:solidFill>
-                <a:latin typeface="Arial" pitchFamily="34" charset="0"/>
-                <a:ea typeface="Arial" pitchFamily="34" charset="-122"/>
-                <a:cs typeface="Arial" pitchFamily="34" charset="-120"/>
-              </a:rPr>
-              <a:t>Rules gate</a:t>
-            </a:r>
-            <a:endParaRPr lang="en-US" sz="1400" dirty="0"/>
+                <a:latin typeface="Courier New" pitchFamily="34" charset="0"/>
+                <a:ea typeface="Courier New" pitchFamily="34" charset="-122"/>
+                <a:cs typeface="Courier New" pitchFamily="34" charset="-120"/>
+              </a:rPr>
+              <a:t>RULES GATE</a:t>
+            </a:r>
+            <a:endParaRPr lang="en-US" sz="1200" dirty="0"/>
           </a:p>
         </p:txBody>
       </p:sp>
@@ -6041,8 +6134,8 @@
         </p:nvSpPr>
         <p:spPr>
           <a:xfrm>
-            <a:off x="3593592" y="2414016"/>
-            <a:ext cx="2377440" cy="731520"/>
+            <a:off x="3463290" y="2368296"/>
+            <a:ext cx="2439162" cy="795528"/>
           </a:xfrm>
           <a:prstGeom prst="rect">
             <a:avLst/>
@@ -6103,8 +6196,8 @@
         </p:nvSpPr>
         <p:spPr>
           <a:xfrm>
-            <a:off x="6108192" y="2331720"/>
-            <a:ext cx="256032" cy="365760"/>
+            <a:off x="5993892" y="2400300"/>
+            <a:ext cx="201168" cy="365760"/>
           </a:xfrm>
           <a:prstGeom prst="rect">
             <a:avLst/>
@@ -6120,7 +6213,7 @@
               <a:buNone/>
             </a:pPr>
             <a:r>
-              <a:rPr lang="en-US" sz="1800" dirty="0">
+              <a:rPr lang="en-US" sz="1600" dirty="0">
                 <a:solidFill>
                   <a:srgbClr val="6B7686"/>
                 </a:solidFill>
@@ -6130,7 +6223,7 @@
               </a:rPr>
               <a:t>›</a:t>
             </a:r>
-            <a:endParaRPr lang="en-US" sz="1800" dirty="0"/>
+            <a:endParaRPr lang="en-US" sz="1600" dirty="0"/>
           </a:p>
         </p:txBody>
       </p:sp>
@@ -6142,8 +6235,8 @@
         </p:nvSpPr>
         <p:spPr>
           <a:xfrm>
-            <a:off x="6364224" y="1874520"/>
-            <a:ext cx="2651760" cy="1417320"/>
+            <a:off x="6195060" y="1874520"/>
+            <a:ext cx="2622042" cy="1417320"/>
           </a:xfrm>
           <a:prstGeom prst="roundRect">
             <a:avLst>
@@ -6169,8 +6262,8 @@
         </p:nvSpPr>
         <p:spPr>
           <a:xfrm>
-            <a:off x="6364224" y="2048256"/>
-            <a:ext cx="2651760" cy="292608"/>
+            <a:off x="6195060" y="2039112"/>
+            <a:ext cx="2622042" cy="274320"/>
           </a:xfrm>
           <a:prstGeom prst="rect">
             <a:avLst/>
@@ -6186,17 +6279,17 @@
               <a:buNone/>
             </a:pPr>
             <a:r>
-              <a:rPr lang="en-US" sz="1400" b="1" dirty="0">
+              <a:rPr lang="en-US" sz="1200" b="1" dirty="0">
                 <a:solidFill>
                   <a:srgbClr val="F0B429"/>
                 </a:solidFill>
-                <a:latin typeface="Arial" pitchFamily="34" charset="0"/>
-                <a:ea typeface="Arial" pitchFamily="34" charset="-122"/>
-                <a:cs typeface="Arial" pitchFamily="34" charset="-120"/>
-              </a:rPr>
-              <a:t>Claude veto</a:t>
-            </a:r>
-            <a:endParaRPr lang="en-US" sz="1400" dirty="0"/>
+                <a:latin typeface="Courier New" pitchFamily="34" charset="0"/>
+                <a:ea typeface="Courier New" pitchFamily="34" charset="-122"/>
+                <a:cs typeface="Courier New" pitchFamily="34" charset="-120"/>
+              </a:rPr>
+              <a:t>CLAUDE VETO</a:t>
+            </a:r>
+            <a:endParaRPr lang="en-US" sz="1200" dirty="0"/>
           </a:p>
         </p:txBody>
       </p:sp>
@@ -6208,8 +6301,8 @@
         </p:nvSpPr>
         <p:spPr>
           <a:xfrm>
-            <a:off x="6501384" y="2414016"/>
-            <a:ext cx="2377440" cy="731520"/>
+            <a:off x="6286500" y="2368296"/>
+            <a:ext cx="2439162" cy="795528"/>
           </a:xfrm>
           <a:prstGeom prst="rect">
             <a:avLst/>
@@ -6256,7 +6349,7 @@
                 <a:ea typeface="Arial" pitchFamily="34" charset="-122"/>
                 <a:cs typeface="Arial" pitchFamily="34" charset="-120"/>
               </a:rPr>
-              <a:t>regime read — no-go only</a:t>
+              <a:t>regime read - no-go only</a:t>
             </a:r>
             <a:endParaRPr lang="en-US" sz="1000" dirty="0"/>
           </a:p>
@@ -6270,8 +6363,8 @@
         </p:nvSpPr>
         <p:spPr>
           <a:xfrm>
-            <a:off x="9015984" y="2331720"/>
-            <a:ext cx="256032" cy="365760"/>
+            <a:off x="8817102" y="2400300"/>
+            <a:ext cx="201168" cy="365760"/>
           </a:xfrm>
           <a:prstGeom prst="rect">
             <a:avLst/>
@@ -6287,7 +6380,7 @@
               <a:buNone/>
             </a:pPr>
             <a:r>
-              <a:rPr lang="en-US" sz="1800" dirty="0">
+              <a:rPr lang="en-US" sz="1600" dirty="0">
                 <a:solidFill>
                   <a:srgbClr val="6B7686"/>
                 </a:solidFill>
@@ -6297,7 +6390,7 @@
               </a:rPr>
               <a:t>›</a:t>
             </a:r>
-            <a:endParaRPr lang="en-US" sz="1800" dirty="0"/>
+            <a:endParaRPr lang="en-US" sz="1600" dirty="0"/>
           </a:p>
         </p:txBody>
       </p:sp>
@@ -6309,8 +6402,8 @@
         </p:nvSpPr>
         <p:spPr>
           <a:xfrm>
-            <a:off x="9272016" y="1874520"/>
-            <a:ext cx="2651760" cy="1417320"/>
+            <a:off x="9018270" y="1874520"/>
+            <a:ext cx="2622042" cy="1417320"/>
           </a:xfrm>
           <a:prstGeom prst="roundRect">
             <a:avLst>
@@ -6336,8 +6429,8 @@
         </p:nvSpPr>
         <p:spPr>
           <a:xfrm>
-            <a:off x="9272016" y="2048256"/>
-            <a:ext cx="2651760" cy="292608"/>
+            <a:off x="9018270" y="2039112"/>
+            <a:ext cx="2622042" cy="274320"/>
           </a:xfrm>
           <a:prstGeom prst="rect">
             <a:avLst/>
@@ -6353,17 +6446,17 @@
               <a:buNone/>
             </a:pPr>
             <a:r>
-              <a:rPr lang="en-US" sz="1400" b="1" dirty="0">
+              <a:rPr lang="en-US" sz="1200" b="1" dirty="0">
                 <a:solidFill>
                   <a:srgbClr val="FFFFFF"/>
                 </a:solidFill>
-                <a:latin typeface="Arial" pitchFamily="34" charset="0"/>
-                <a:ea typeface="Arial" pitchFamily="34" charset="-122"/>
-                <a:cs typeface="Arial" pitchFamily="34" charset="-120"/>
-              </a:rPr>
-              <a:t>Order</a:t>
-            </a:r>
-            <a:endParaRPr lang="en-US" sz="1400" dirty="0"/>
+                <a:latin typeface="Courier New" pitchFamily="34" charset="0"/>
+                <a:ea typeface="Courier New" pitchFamily="34" charset="-122"/>
+                <a:cs typeface="Courier New" pitchFamily="34" charset="-120"/>
+              </a:rPr>
+              <a:t>ORDER</a:t>
+            </a:r>
+            <a:endParaRPr lang="en-US" sz="1200" dirty="0"/>
           </a:p>
         </p:txBody>
       </p:sp>
@@ -6375,8 +6468,8 @@
         </p:nvSpPr>
         <p:spPr>
           <a:xfrm>
-            <a:off x="9409176" y="2414016"/>
-            <a:ext cx="2377440" cy="731520"/>
+            <a:off x="9109710" y="2368296"/>
+            <a:ext cx="2439162" cy="795528"/>
           </a:xfrm>
           <a:prstGeom prst="rect">
             <a:avLst/>
@@ -6438,11 +6531,11 @@
         <p:spPr>
           <a:xfrm>
             <a:off x="548640" y="3611880"/>
-            <a:ext cx="5440680" cy="1783080"/>
+            <a:ext cx="5440680" cy="1691640"/>
           </a:xfrm>
           <a:prstGeom prst="roundRect">
             <a:avLst>
-              <a:gd name="adj" fmla="val 4103"/>
+              <a:gd name="adj" fmla="val 4324"/>
             </a:avLst>
           </a:prstGeom>
           <a:solidFill>
@@ -6543,7 +6636,7 @@
         <p:spPr>
           <a:xfrm>
             <a:off x="841248" y="4572000"/>
-            <a:ext cx="4855464" cy="658368"/>
+            <a:ext cx="4855464" cy="566928"/>
           </a:xfrm>
           <a:prstGeom prst="rect">
             <a:avLst/>
@@ -6570,7 +6663,7 @@
                 <a:ea typeface="Arial" pitchFamily="34" charset="-122"/>
                 <a:cs typeface="Arial" pitchFamily="34" charset="-120"/>
               </a:rPr>
-              <a:t>The model can never resurrect a trade the rules rejected, so rules_only is a strict mathematical floor under the AI path. Missing key or bad JSON degrades to rules and logs it — it never fails open.</a:t>
+              <a:t>The model can remove a trade the rules approved. It can never resurrect one they rejected, so the deterministic path is a strict subset of the AI path - and both are auditable against each other.</a:t>
             </a:r>
             <a:endParaRPr lang="en-US" sz="1100" dirty="0"/>
           </a:p>
@@ -6585,11 +6678,11 @@
         <p:spPr>
           <a:xfrm>
             <a:off x="6199632" y="3611880"/>
-            <a:ext cx="5440680" cy="1783080"/>
+            <a:ext cx="5440680" cy="1691640"/>
           </a:xfrm>
           <a:prstGeom prst="roundRect">
             <a:avLst>
-              <a:gd name="adj" fmla="val 4103"/>
+              <a:gd name="adj" fmla="val 4324"/>
             </a:avLst>
           </a:prstGeom>
           <a:solidFill>
@@ -6636,7 +6729,7 @@
                 <a:ea typeface="Courier New" pitchFamily="34" charset="-122"/>
                 <a:cs typeface="Courier New" pitchFamily="34" charset="-120"/>
               </a:rPr>
-              <a:t>WHAT WE SUBMITTED</a:t>
+              <a:t>FAILS CLOSED, NEVER OPEN</a:t>
             </a:r>
             <a:endParaRPr lang="en-US" sz="1000" dirty="0"/>
           </a:p>
@@ -6667,7 +6760,7 @@
               <a:buNone/>
             </a:pPr>
             <a:r>
-              <a:rPr lang="en-US" sz="1700" b="1" dirty="0">
+              <a:rPr lang="en-US" sz="2000" b="1" dirty="0">
                 <a:solidFill>
                   <a:srgbClr val="FFFFFF"/>
                 </a:solidFill>
@@ -6675,9 +6768,9 @@
                 <a:ea typeface="Arial" pitchFamily="34" charset="-122"/>
                 <a:cs typeface="Arial" pitchFamily="34" charset="-120"/>
               </a:rPr>
-              <a:t>decision_mode: rules_only</a:t>
-            </a:r>
-            <a:endParaRPr lang="en-US" sz="1700" dirty="0"/>
+              <a:t>degrade, don't guess</a:t>
+            </a:r>
+            <a:endParaRPr lang="en-US" sz="2000" dirty="0"/>
           </a:p>
         </p:txBody>
       </p:sp>
@@ -6690,7 +6783,7 @@
         <p:spPr>
           <a:xfrm>
             <a:off x="6492240" y="4572000"/>
-            <a:ext cx="4855464" cy="658368"/>
+            <a:ext cx="4855464" cy="566928"/>
           </a:xfrm>
           <a:prstGeom prst="rect">
             <a:avLst/>
@@ -6717,7 +6810,7 @@
                 <a:ea typeface="Arial" pitchFamily="34" charset="-122"/>
                 <a:cs typeface="Arial" pitchFamily="34" charset="-120"/>
               </a:rPr>
-              <a:t>The scored run used the deterministic stack. The LLM gate ships tested and runnable (--decision-mode llm) but was not in the scored path — we say which arm produced the numbers.</a:t>
+              <a:t>A missing key or unparseable reply degrades to the deterministic gate and says so in the journal. The agent never trades on a model response it could not read.</a:t>
             </a:r>
             <a:endParaRPr lang="en-US" sz="1100" dirty="0"/>
           </a:p>
@@ -6731,8 +6824,8 @@
         </p:nvSpPr>
         <p:spPr>
           <a:xfrm>
-            <a:off x="548640" y="5577840"/>
-            <a:ext cx="11091672" cy="457200"/>
+            <a:off x="548640" y="5486400"/>
+            <a:ext cx="11091672" cy="365760"/>
           </a:xfrm>
           <a:prstGeom prst="rect">
             <a:avLst/>
@@ -6748,17 +6841,17 @@
               <a:buNone/>
             </a:pPr>
             <a:r>
-              <a:rPr lang="en-US" sz="1400" i="1" dirty="0">
-                <a:solidFill>
-                  <a:srgbClr val="FFFFFF"/>
-                </a:solidFill>
-                <a:latin typeface="Arial" pitchFamily="34" charset="0"/>
-                <a:ea typeface="Arial" pitchFamily="34" charset="-122"/>
-                <a:cs typeface="Arial" pitchFamily="34" charset="-120"/>
-              </a:rPr>
-              <a:t>“We never let it manufacture conviction we couldn't measure — because we measured, and it wasn't there.”</a:t>
-            </a:r>
-            <a:endParaRPr lang="en-US" sz="1400" dirty="0"/>
+              <a:rPr lang="en-US" sz="1000" dirty="0">
+                <a:solidFill>
+                  <a:srgbClr val="6B7686"/>
+                </a:solidFill>
+                <a:latin typeface="Courier New" pitchFamily="34" charset="0"/>
+                <a:ea typeface="Courier New" pitchFamily="34" charset="-122"/>
+                <a:cs typeface="Courier New" pitchFamily="34" charset="-120"/>
+              </a:rPr>
+              <a:t>The scored sessions ran the deterministic gate; the Claude veto ships tested and runnable via --decision-mode llm.</a:t>
+            </a:r>
+            <a:endParaRPr lang="en-US" sz="1000" dirty="0"/>
           </a:p>
         </p:txBody>
       </p:sp>
@@ -6866,7 +6959,7 @@
                 <a:ea typeface="Courier New" pitchFamily="34" charset="-122"/>
                 <a:cs typeface="Courier New" pitchFamily="34" charset="-120"/>
               </a:rPr>
-              <a:t>github.com/KIBA0993/defined-risk-0dte-agent</a:t>
+              <a:t>github.com/KIBA0993/Alpaca-Hackathon</a:t>
             </a:r>
             <a:endParaRPr lang="en-US" sz="900" dirty="0"/>
           </a:p>
@@ -7013,7 +7106,7 @@
                 <a:ea typeface="Arial" pitchFamily="34" charset="-122"/>
                 <a:cs typeface="Arial" pitchFamily="34" charset="-120"/>
               </a:rPr>
-              <a:t>alpaca order submit, then poll to a terminal state. The agent books the real broker fill, not a quote — so cash P&amp;L is buy-fill vs sell-fill.</a:t>
+              <a:t>alpaca order submit, then poll to a terminal state. The agent books the real broker fill, not a quote - so cash P&amp;L is buy-fill against sell-fill.</a:t>
             </a:r>
             <a:endParaRPr lang="en-US" sz="1200" dirty="0"/>
           </a:p>
@@ -7121,7 +7214,7 @@
                 <a:ea typeface="Arial" pitchFamily="34" charset="-122"/>
                 <a:cs typeface="Arial" pitchFamily="34" charset="-120"/>
               </a:rPr>
-              <a:t>Refuses to place anything unless `alpaca doctor` resolves paper-api.alpaca.markets. The env var alone isn't proof — a profile's live_trade can route live.</a:t>
+              <a:t>Refuses to place anything unless `alpaca doctor` resolves paper-api.alpaca.markets. The env var alone isn't proof - a profile's live_trade can route live.</a:t>
             </a:r>
             <a:endParaRPr lang="en-US" sz="1200" dirty="0"/>
           </a:p>
@@ -7295,7 +7388,7 @@
                 <a:ea typeface="Courier New" pitchFamily="34" charset="-122"/>
                 <a:cs typeface="Courier New" pitchFamily="34" charset="-120"/>
               </a:rPr>
-              <a:t>UNATTENDED + AUDITABLE</a:t>
+              <a:t>UNATTENDED AND AUDITABLE</a:t>
             </a:r>
             <a:endParaRPr lang="en-US" sz="1000" dirty="0"/>
           </a:p>
@@ -7337,7 +7430,7 @@
                 <a:ea typeface="Arial" pitchFamily="34" charset="-122"/>
                 <a:cs typeface="Arial" pitchFamily="34" charset="-120"/>
               </a:rPr>
-              <a:t>Market data (5m bars, contract discovery, ATM quotes) via the Alpaca SDK. Isolated Docker container on a NAS, one session per weekday, JSONL journal per scan.</a:t>
+              <a:t>Market data (5m bars, contract discovery, ATM quotes) via the Alpaca SDK. Isolated Docker container, one session per weekday, JSONL journal per scan.</a:t>
             </a:r>
             <a:endParaRPr lang="en-US" sz="1200" dirty="0"/>
           </a:p>
@@ -7376,7 +7469,7 @@
                 <a:ea typeface="Courier New" pitchFamily="34" charset="-122"/>
                 <a:cs typeface="Courier New" pitchFamily="34" charset="-120"/>
               </a:rPr>
-              <a:t>Requirement met: projects must use Alpaca's MCP server or its CLI tools.   —   this agent places every order through the CLI.</a:t>
+              <a:t>Requirement: projects must use Alpaca's MCP server or its CLI tools.   —   every order in the book above went through the CLI.</a:t>
             </a:r>
             <a:endParaRPr lang="en-US" sz="1100" dirty="0"/>
           </a:p>
@@ -7447,7 +7540,7 @@
                 <a:ea typeface="Courier New" pitchFamily="34" charset="-122"/>
                 <a:cs typeface="Courier New" pitchFamily="34" charset="-120"/>
               </a:rPr>
-              <a:t>06  ·  Results</a:t>
+              <a:t>06  ·  The audit trail</a:t>
             </a:r>
             <a:endParaRPr lang="en-US" sz="1100" dirty="0"/>
           </a:p>
@@ -7486,7 +7579,7 @@
                 <a:ea typeface="Courier New" pitchFamily="34" charset="-122"/>
                 <a:cs typeface="Courier New" pitchFamily="34" charset="-120"/>
               </a:rPr>
-              <a:t>github.com/KIBA0993/defined-risk-0dte-agent</a:t>
+              <a:t>github.com/KIBA0993/Alpaca-Hackathon</a:t>
             </a:r>
             <a:endParaRPr lang="en-US" sz="900" dirty="0"/>
           </a:p>
@@ -7525,7 +7618,7 @@
                 <a:ea typeface="Arial" pitchFamily="34" charset="-122"/>
                 <a:cs typeface="Arial" pitchFamily="34" charset="-120"/>
               </a:rPr>
-              <a:t>Four sessions, reported honestly</a:t>
+              <a:t>Most agents show the trades they took</a:t>
             </a:r>
             <a:endParaRPr lang="en-US" sz="3400" dirty="0"/>
           </a:p>
@@ -7533,18 +7626,57 @@
       </p:sp>
       <p:sp>
         <p:nvSpPr>
-          <p:cNvPr id="5" name="Shape 3"/>
+          <p:cNvPr id="5" name="Text 3"/>
+          <p:cNvSpPr txBox="1"/>
+          <p:nvPr/>
+        </p:nvSpPr>
+        <p:spPr>
+          <a:xfrm>
+            <a:off x="548640" y="1572768"/>
+            <a:ext cx="11064240" cy="548640"/>
+          </a:xfrm>
+          <a:prstGeom prst="rect">
+            <a:avLst/>
+          </a:prstGeom>
+          <a:noFill/>
+          <a:ln/>
+        </p:spPr>
+        <p:txBody>
+          <a:bodyPr wrap="square" lIns="0" tIns="0" rIns="0" bIns="0" rtlCol="0" anchor="ctr"/>
+          <a:lstStyle/>
+          <a:p>
+            <a:pPr indent="0" marL="0">
+              <a:buNone/>
+            </a:pPr>
+            <a:r>
+              <a:rPr lang="en-US" sz="3000" b="1" dirty="0">
+                <a:solidFill>
+                  <a:srgbClr val="F0B429"/>
+                </a:solidFill>
+                <a:latin typeface="Arial" pitchFamily="34" charset="0"/>
+                <a:ea typeface="Arial" pitchFamily="34" charset="-122"/>
+                <a:cs typeface="Arial" pitchFamily="34" charset="-120"/>
+              </a:rPr>
+              <a:t>This one shows the ones it refused.</a:t>
+            </a:r>
+            <a:endParaRPr lang="en-US" sz="3000" dirty="0"/>
+          </a:p>
+        </p:txBody>
+      </p:sp>
+      <p:sp>
+        <p:nvSpPr>
+          <p:cNvPr id="6" name="Shape 4"/>
           <p:cNvSpPr/>
           <p:nvPr/>
         </p:nvSpPr>
         <p:spPr>
           <a:xfrm>
-            <a:off x="548640" y="1737360"/>
-            <a:ext cx="6492240" cy="3200400"/>
+            <a:off x="548640" y="2423160"/>
+            <a:ext cx="6766560" cy="2880360"/>
           </a:xfrm>
           <a:prstGeom prst="roundRect">
             <a:avLst>
-              <a:gd name="adj" fmla="val 2286"/>
+              <a:gd name="adj" fmla="val 2540"/>
             </a:avLst>
           </a:prstGeom>
           <a:solidFill>
@@ -7560,14 +7692,14 @@
       </p:sp>
       <p:sp>
         <p:nvSpPr>
-          <p:cNvPr id="6" name="Text 4"/>
-          <p:cNvSpPr txBox="1"/>
-          <p:nvPr/>
-        </p:nvSpPr>
-        <p:spPr>
-          <a:xfrm>
-            <a:off x="822960" y="1901952"/>
-            <a:ext cx="5943600" cy="256032"/>
+          <p:cNvPr id="7" name="Text 5"/>
+          <p:cNvSpPr txBox="1"/>
+          <p:nvPr/>
+        </p:nvSpPr>
+        <p:spPr>
+          <a:xfrm>
+            <a:off x="804672" y="2578608"/>
+            <a:ext cx="6309360" cy="256032"/>
           </a:xfrm>
           <a:prstGeom prst="rect">
             <a:avLst/>
@@ -7591,38 +7723,22 @@
                 <a:ea typeface="Courier New" pitchFamily="34" charset="-122"/>
                 <a:cs typeface="Courier New" pitchFamily="34" charset="-120"/>
               </a:rPr>
-              <a:t>EQUITY · ALPACA PAPER PA38HG4D9653</a:t>
+              <a:t>logs/decisions-2026-09-03.jsonl</a:t>
             </a:r>
             <a:endParaRPr lang="en-US" sz="1000" dirty="0"/>
           </a:p>
         </p:txBody>
       </p:sp>
-      <p:graphicFrame>
-        <p:nvGraphicFramePr>
-          <p:cNvPr id="7" name="Chart 0" descr=""/>
-          <p:cNvGraphicFramePr/>
-          <p:nvPr/>
-        </p:nvGraphicFramePr>
-        <p:xfrm>
-          <a:off x="713232" y="2212848"/>
-          <a:ext cx="6163056" cy="2606040"/>
-        </p:xfrm>
-        <a:graphic xmlns:a="http://schemas.openxmlformats.org/drawingml/2006/main">
-          <a:graphicData uri="http://schemas.openxmlformats.org/drawingml/2006/chart">
-            <c:chart xmlns:c="http://schemas.openxmlformats.org/drawingml/2006/chart" r:id="rId1"/>
-          </a:graphicData>
-        </a:graphic>
-      </p:graphicFrame>
-      <p:sp>
-        <p:nvSpPr>
-          <p:cNvPr id="8" name="Text 5"/>
-          <p:cNvSpPr txBox="1"/>
-          <p:nvPr/>
-        </p:nvSpPr>
-        <p:spPr>
-          <a:xfrm>
-            <a:off x="7269480" y="1901952"/>
-            <a:ext cx="4370832" cy="256032"/>
+      <p:sp>
+        <p:nvSpPr>
+          <p:cNvPr id="8" name="Text 6"/>
+          <p:cNvSpPr txBox="1"/>
+          <p:nvPr/>
+        </p:nvSpPr>
+        <p:spPr>
+          <a:xfrm>
+            <a:off x="804672" y="2926080"/>
+            <a:ext cx="6309360" cy="2194560"/>
           </a:xfrm>
           <a:prstGeom prst="rect">
             <a:avLst/>
@@ -7635,37 +7751,160 @@
           <a:lstStyle/>
           <a:p>
             <a:pPr indent="0" marL="0">
-              <a:buNone/>
-            </a:pPr>
-            <a:r>
-              <a:rPr lang="en-US" sz="1000" spc="120" kern="0" dirty="0">
-                <a:solidFill>
-                  <a:srgbClr val="6B7686"/>
+              <a:lnSpc>
+                <a:spcPct val="128000"/>
+              </a:lnSpc>
+              <a:buNone/>
+            </a:pPr>
+            <a:r>
+              <a:rPr lang="en-US" sz="1300" dirty="0">
+                <a:solidFill>
+                  <a:srgbClr val="A1A8B5"/>
                 </a:solidFill>
                 <a:latin typeface="Courier New" pitchFamily="34" charset="0"/>
                 <a:ea typeface="Courier New" pitchFamily="34" charset="-122"/>
                 <a:cs typeface="Courier New" pitchFamily="34" charset="-120"/>
               </a:rPr>
-              <a:t>REALIZED BY SESSION</a:t>
-            </a:r>
-            <a:endParaRPr lang="en-US" sz="1000" dirty="0"/>
-          </a:p>
-        </p:txBody>
-      </p:sp>
-      <p:sp>
-        <p:nvSpPr>
-          <p:cNvPr id="9" name="Shape 6"/>
+              <a:t>{ "symbol": "QQQ",</a:t>
+            </a:r>
+            <a:endParaRPr lang="en-US" sz="1300" dirty="0"/>
+          </a:p>
+          <a:p>
+            <a:pPr indent="0" marL="0">
+              <a:lnSpc>
+                <a:spcPct val="128000"/>
+              </a:lnSpc>
+              <a:buNone/>
+            </a:pPr>
+            <a:r>
+              <a:rPr lang="en-US" sz="1300" dirty="0">
+                <a:solidFill>
+                  <a:srgbClr val="FFFFFF"/>
+                </a:solidFill>
+                <a:latin typeface="Courier New" pitchFamily="34" charset="0"/>
+                <a:ea typeface="Courier New" pitchFamily="34" charset="-122"/>
+                <a:cs typeface="Courier New" pitchFamily="34" charset="-120"/>
+              </a:rPr>
+              <a:t>  "score": 0.68,</a:t>
+            </a:r>
+            <a:endParaRPr lang="en-US" sz="1300" dirty="0"/>
+          </a:p>
+          <a:p>
+            <a:pPr indent="0" marL="0">
+              <a:lnSpc>
+                <a:spcPct val="128000"/>
+              </a:lnSpc>
+              <a:buNone/>
+            </a:pPr>
+            <a:r>
+              <a:rPr lang="en-US" sz="1300" dirty="0">
+                <a:solidFill>
+                  <a:srgbClr val="A1A8B5"/>
+                </a:solidFill>
+                <a:latin typeface="Courier New" pitchFamily="34" charset="0"/>
+                <a:ea typeface="Courier New" pitchFamily="34" charset="-122"/>
+                <a:cs typeface="Courier New" pitchFamily="34" charset="-120"/>
+              </a:rPr>
+              <a:t>  "would_have_direction": "put",</a:t>
+            </a:r>
+            <a:endParaRPr lang="en-US" sz="1300" dirty="0"/>
+          </a:p>
+          <a:p>
+            <a:pPr indent="0" marL="0">
+              <a:lnSpc>
+                <a:spcPct val="128000"/>
+              </a:lnSpc>
+              <a:buNone/>
+            </a:pPr>
+            <a:r>
+              <a:rPr lang="en-US" sz="1300" dirty="0">
+                <a:solidFill>
+                  <a:srgbClr val="A1A8B5"/>
+                </a:solidFill>
+                <a:latin typeface="Courier New" pitchFamily="34" charset="0"/>
+                <a:ea typeface="Courier New" pitchFamily="34" charset="-122"/>
+                <a:cs typeface="Courier New" pitchFamily="34" charset="-120"/>
+              </a:rPr>
+              <a:t>  "noise_band": { "state": "inside" },</a:t>
+            </a:r>
+            <a:endParaRPr lang="en-US" sz="1300" dirty="0"/>
+          </a:p>
+          <a:p>
+            <a:pPr indent="0" marL="0">
+              <a:lnSpc>
+                <a:spcPct val="128000"/>
+              </a:lnSpc>
+              <a:buNone/>
+            </a:pPr>
+            <a:r>
+              <a:rPr lang="en-US" sz="1300" dirty="0">
+                <a:solidFill>
+                  <a:srgbClr val="FFFFFF"/>
+                </a:solidFill>
+                <a:latin typeface="Courier New" pitchFamily="34" charset="0"/>
+                <a:ea typeface="Courier New" pitchFamily="34" charset="-122"/>
+                <a:cs typeface="Courier New" pitchFamily="34" charset="-120"/>
+              </a:rPr>
+              <a:t>  "gate": { "go": false,</a:t>
+            </a:r>
+            <a:endParaRPr lang="en-US" sz="1300" dirty="0"/>
+          </a:p>
+          <a:p>
+            <a:pPr indent="0" marL="0">
+              <a:lnSpc>
+                <a:spcPct val="128000"/>
+              </a:lnSpc>
+              <a:buNone/>
+            </a:pPr>
+            <a:r>
+              <a:rPr lang="en-US" sz="1300" dirty="0">
+                <a:solidFill>
+                  <a:srgbClr val="F0B429"/>
+                </a:solidFill>
+                <a:latin typeface="Courier New" pitchFamily="34" charset="0"/>
+                <a:ea typeface="Courier New" pitchFamily="34" charset="-122"/>
+                <a:cs typeface="Courier New" pitchFamily="34" charset="-120"/>
+              </a:rPr>
+              <a:t>    "rationale": "score 0.68 &lt; min 0.70" },</a:t>
+            </a:r>
+            <a:endParaRPr lang="en-US" sz="1300" dirty="0"/>
+          </a:p>
+          <a:p>
+            <a:pPr indent="0" marL="0">
+              <a:lnSpc>
+                <a:spcPct val="128000"/>
+              </a:lnSpc>
+              <a:buNone/>
+            </a:pPr>
+            <a:r>
+              <a:rPr lang="en-US" sz="1300" dirty="0">
+                <a:solidFill>
+                  <a:srgbClr val="A1A8B5"/>
+                </a:solidFill>
+                <a:latin typeface="Courier New" pitchFamily="34" charset="0"/>
+                <a:ea typeface="Courier New" pitchFamily="34" charset="-122"/>
+                <a:cs typeface="Courier New" pitchFamily="34" charset="-120"/>
+              </a:rPr>
+              <a:t>  "order": null }</a:t>
+            </a:r>
+            <a:endParaRPr lang="en-US" sz="1300" dirty="0"/>
+          </a:p>
+        </p:txBody>
+      </p:sp>
+      <p:sp>
+        <p:nvSpPr>
+          <p:cNvPr id="9" name="Shape 7"/>
           <p:cNvSpPr/>
           <p:nvPr/>
         </p:nvSpPr>
         <p:spPr>
           <a:xfrm>
-            <a:off x="7269480" y="2240280"/>
-            <a:ext cx="4370832" cy="493776"/>
+            <a:off x="7571232" y="2423160"/>
+            <a:ext cx="4069080" cy="1371600"/>
           </a:xfrm>
           <a:prstGeom prst="roundRect">
             <a:avLst>
-              <a:gd name="adj" fmla="val 11111"/>
+              <a:gd name="adj" fmla="val 5333"/>
             </a:avLst>
           </a:prstGeom>
           <a:solidFill>
@@ -7681,14 +7920,14 @@
       </p:sp>
       <p:sp>
         <p:nvSpPr>
-          <p:cNvPr id="10" name="Text 7"/>
-          <p:cNvSpPr txBox="1"/>
-          <p:nvPr/>
-        </p:nvSpPr>
-        <p:spPr>
-          <a:xfrm>
-            <a:off x="7452360" y="2240280"/>
-            <a:ext cx="960120" cy="493776"/>
+          <p:cNvPr id="10" name="Text 8"/>
+          <p:cNvSpPr txBox="1"/>
+          <p:nvPr/>
+        </p:nvSpPr>
+        <p:spPr>
+          <a:xfrm>
+            <a:off x="7863840" y="2624328"/>
+            <a:ext cx="3483864" cy="219456"/>
           </a:xfrm>
           <a:prstGeom prst="rect">
             <a:avLst/>
@@ -7704,69 +7943,30 @@
               <a:buNone/>
             </a:pPr>
             <a:r>
-              <a:rPr lang="en-US" sz="1300" b="1" dirty="0">
-                <a:solidFill>
-                  <a:srgbClr val="FFFFFF"/>
-                </a:solidFill>
-                <a:latin typeface="Arial" pitchFamily="34" charset="0"/>
-                <a:ea typeface="Arial" pitchFamily="34" charset="-122"/>
-                <a:cs typeface="Arial" pitchFamily="34" charset="-120"/>
-              </a:rPr>
-              <a:t>Aug 31</a:t>
-            </a:r>
-            <a:endParaRPr lang="en-US" sz="1300" dirty="0"/>
-          </a:p>
-        </p:txBody>
-      </p:sp>
-      <p:sp>
-        <p:nvSpPr>
-          <p:cNvPr id="11" name="Text 8"/>
-          <p:cNvSpPr txBox="1"/>
-          <p:nvPr/>
-        </p:nvSpPr>
-        <p:spPr>
-          <a:xfrm>
-            <a:off x="8412480" y="2240280"/>
-            <a:ext cx="1325880" cy="493776"/>
-          </a:xfrm>
-          <a:prstGeom prst="rect">
-            <a:avLst/>
-          </a:prstGeom>
-          <a:noFill/>
-          <a:ln/>
-        </p:spPr>
-        <p:txBody>
-          <a:bodyPr wrap="square" lIns="0" tIns="0" rIns="0" bIns="0" rtlCol="0" anchor="ctr"/>
-          <a:lstStyle/>
-          <a:p>
-            <a:pPr algn="r" indent="0" marL="0">
-              <a:buNone/>
-            </a:pPr>
-            <a:r>
-              <a:rPr lang="en-US" sz="1300" b="1" dirty="0">
-                <a:solidFill>
-                  <a:srgbClr val="E5484D"/>
+              <a:rPr lang="en-US" sz="1000" spc="140" kern="0" dirty="0">
+                <a:solidFill>
+                  <a:srgbClr val="6B7686"/>
                 </a:solidFill>
                 <a:latin typeface="Courier New" pitchFamily="34" charset="0"/>
                 <a:ea typeface="Courier New" pitchFamily="34" charset="-122"/>
                 <a:cs typeface="Courier New" pitchFamily="34" charset="-120"/>
               </a:rPr>
-              <a:t>−$10,636</a:t>
-            </a:r>
-            <a:endParaRPr lang="en-US" sz="1300" dirty="0"/>
-          </a:p>
-        </p:txBody>
-      </p:sp>
-      <p:sp>
-        <p:nvSpPr>
-          <p:cNvPr id="12" name="Text 9"/>
-          <p:cNvSpPr txBox="1"/>
-          <p:nvPr/>
-        </p:nvSpPr>
-        <p:spPr>
-          <a:xfrm>
-            <a:off x="9829800" y="2240280"/>
-            <a:ext cx="914400" cy="493776"/>
+              <a:t>ONE RECORD PER SCAN</a:t>
+            </a:r>
+            <a:endParaRPr lang="en-US" sz="1000" dirty="0"/>
+          </a:p>
+        </p:txBody>
+      </p:sp>
+      <p:sp>
+        <p:nvSpPr>
+          <p:cNvPr id="11" name="Text 9"/>
+          <p:cNvSpPr txBox="1"/>
+          <p:nvPr/>
+        </p:nvSpPr>
+        <p:spPr>
+          <a:xfrm>
+            <a:off x="7863840" y="2916936"/>
+            <a:ext cx="3483864" cy="384048"/>
           </a:xfrm>
           <a:prstGeom prst="rect">
             <a:avLst/>
@@ -7778,7 +7978,49 @@
           <a:bodyPr wrap="square" lIns="0" tIns="0" rIns="0" bIns="0" rtlCol="0" anchor="ctr"/>
           <a:lstStyle/>
           <a:p>
-            <a:pPr algn="r" indent="0" marL="0">
+            <a:pPr indent="0" marL="0">
+              <a:buNone/>
+            </a:pPr>
+            <a:r>
+              <a:rPr lang="en-US" sz="2000" b="1" dirty="0">
+                <a:solidFill>
+                  <a:srgbClr val="F0B429"/>
+                </a:solidFill>
+                <a:latin typeface="Arial" pitchFamily="34" charset="0"/>
+                <a:ea typeface="Arial" pitchFamily="34" charset="-122"/>
+                <a:cs typeface="Arial" pitchFamily="34" charset="-120"/>
+              </a:rPr>
+              <a:t>Full reasoning</a:t>
+            </a:r>
+            <a:endParaRPr lang="en-US" sz="2000" dirty="0"/>
+          </a:p>
+        </p:txBody>
+      </p:sp>
+      <p:sp>
+        <p:nvSpPr>
+          <p:cNvPr id="12" name="Text 10"/>
+          <p:cNvSpPr txBox="1"/>
+          <p:nvPr/>
+        </p:nvSpPr>
+        <p:spPr>
+          <a:xfrm>
+            <a:off x="7863840" y="3355848"/>
+            <a:ext cx="3483864" cy="274320"/>
+          </a:xfrm>
+          <a:prstGeom prst="rect">
+            <a:avLst/>
+          </a:prstGeom>
+          <a:noFill/>
+          <a:ln/>
+        </p:spPr>
+        <p:txBody>
+          <a:bodyPr wrap="square" lIns="0" tIns="0" rIns="0" bIns="0" rtlCol="0" anchor="t"/>
+          <a:lstStyle/>
+          <a:p>
+            <a:pPr indent="0" marL="0">
+              <a:lnSpc>
+                <a:spcPct val="120000"/>
+              </a:lnSpc>
               <a:buNone/>
             </a:pPr>
             <a:r>
@@ -7790,7 +8032,7 @@
                 <a:ea typeface="Arial" pitchFamily="34" charset="-122"/>
                 <a:cs typeface="Arial" pitchFamily="34" charset="-120"/>
               </a:rPr>
-              <a:t>19 closes</a:t>
+              <a:t>Score, every signal, band state, gate verdict, risk verdict, order.</a:t>
             </a:r>
             <a:endParaRPr lang="en-US" sz="1100" dirty="0"/>
           </a:p>
@@ -7798,57 +8040,18 @@
       </p:sp>
       <p:sp>
         <p:nvSpPr>
-          <p:cNvPr id="13" name="Text 10"/>
-          <p:cNvSpPr txBox="1"/>
-          <p:nvPr/>
-        </p:nvSpPr>
-        <p:spPr>
-          <a:xfrm>
-            <a:off x="10744200" y="2240280"/>
-            <a:ext cx="777240" cy="493776"/>
-          </a:xfrm>
-          <a:prstGeom prst="rect">
-            <a:avLst/>
-          </a:prstGeom>
-          <a:noFill/>
-          <a:ln/>
-        </p:spPr>
-        <p:txBody>
-          <a:bodyPr wrap="square" lIns="0" tIns="0" rIns="0" bIns="0" rtlCol="0" anchor="ctr"/>
-          <a:lstStyle/>
-          <a:p>
-            <a:pPr algn="r" indent="0" marL="0">
-              <a:buNone/>
-            </a:pPr>
-            <a:r>
-              <a:rPr lang="en-US" sz="1100" dirty="0">
-                <a:solidFill>
-                  <a:srgbClr val="A1A8B5"/>
-                </a:solidFill>
-                <a:latin typeface="Arial" pitchFamily="34" charset="0"/>
-                <a:ea typeface="Arial" pitchFamily="34" charset="-122"/>
-                <a:cs typeface="Arial" pitchFamily="34" charset="-120"/>
-              </a:rPr>
-              <a:t>31.6% win</a:t>
-            </a:r>
-            <a:endParaRPr lang="en-US" sz="1100" dirty="0"/>
-          </a:p>
-        </p:txBody>
-      </p:sp>
-      <p:sp>
-        <p:nvSpPr>
-          <p:cNvPr id="14" name="Shape 11"/>
+          <p:cNvPr id="13" name="Shape 11"/>
           <p:cNvSpPr/>
           <p:nvPr/>
         </p:nvSpPr>
         <p:spPr>
           <a:xfrm>
-            <a:off x="7269480" y="2807208"/>
-            <a:ext cx="4370832" cy="493776"/>
+            <a:off x="7571232" y="3931920"/>
+            <a:ext cx="4069080" cy="1371600"/>
           </a:xfrm>
           <a:prstGeom prst="roundRect">
             <a:avLst>
-              <a:gd name="adj" fmla="val 11111"/>
+              <a:gd name="adj" fmla="val 5333"/>
             </a:avLst>
           </a:prstGeom>
           <a:solidFill>
@@ -7864,14 +8067,14 @@
       </p:sp>
       <p:sp>
         <p:nvSpPr>
-          <p:cNvPr id="15" name="Text 12"/>
-          <p:cNvSpPr txBox="1"/>
-          <p:nvPr/>
-        </p:nvSpPr>
-        <p:spPr>
-          <a:xfrm>
-            <a:off x="7452360" y="2807208"/>
-            <a:ext cx="960120" cy="493776"/>
+          <p:cNvPr id="14" name="Text 12"/>
+          <p:cNvSpPr txBox="1"/>
+          <p:nvPr/>
+        </p:nvSpPr>
+        <p:spPr>
+          <a:xfrm>
+            <a:off x="7863840" y="4133088"/>
+            <a:ext cx="3483864" cy="219456"/>
           </a:xfrm>
           <a:prstGeom prst="rect">
             <a:avLst/>
@@ -7887,69 +8090,30 @@
               <a:buNone/>
             </a:pPr>
             <a:r>
-              <a:rPr lang="en-US" sz="1300" b="1" dirty="0">
-                <a:solidFill>
-                  <a:srgbClr val="FFFFFF"/>
-                </a:solidFill>
-                <a:latin typeface="Arial" pitchFamily="34" charset="0"/>
-                <a:ea typeface="Arial" pitchFamily="34" charset="-122"/>
-                <a:cs typeface="Arial" pitchFamily="34" charset="-120"/>
-              </a:rPr>
-              <a:t>Sep 1</a:t>
-            </a:r>
-            <a:endParaRPr lang="en-US" sz="1300" dirty="0"/>
-          </a:p>
-        </p:txBody>
-      </p:sp>
-      <p:sp>
-        <p:nvSpPr>
-          <p:cNvPr id="16" name="Text 13"/>
-          <p:cNvSpPr txBox="1"/>
-          <p:nvPr/>
-        </p:nvSpPr>
-        <p:spPr>
-          <a:xfrm>
-            <a:off x="8412480" y="2807208"/>
-            <a:ext cx="1325880" cy="493776"/>
-          </a:xfrm>
-          <a:prstGeom prst="rect">
-            <a:avLst/>
-          </a:prstGeom>
-          <a:noFill/>
-          <a:ln/>
-        </p:spPr>
-        <p:txBody>
-          <a:bodyPr wrap="square" lIns="0" tIns="0" rIns="0" bIns="0" rtlCol="0" anchor="ctr"/>
-          <a:lstStyle/>
-          <a:p>
-            <a:pPr algn="r" indent="0" marL="0">
-              <a:buNone/>
-            </a:pPr>
-            <a:r>
-              <a:rPr lang="en-US" sz="1300" b="1" dirty="0">
-                <a:solidFill>
-                  <a:srgbClr val="F0B429"/>
+              <a:rPr lang="en-US" sz="1000" spc="140" kern="0" dirty="0">
+                <a:solidFill>
+                  <a:srgbClr val="6B7686"/>
                 </a:solidFill>
                 <a:latin typeface="Courier New" pitchFamily="34" charset="0"/>
                 <a:ea typeface="Courier New" pitchFamily="34" charset="-122"/>
                 <a:cs typeface="Courier New" pitchFamily="34" charset="-120"/>
               </a:rPr>
-              <a:t>+$14,400</a:t>
-            </a:r>
-            <a:endParaRPr lang="en-US" sz="1300" dirty="0"/>
-          </a:p>
-        </p:txBody>
-      </p:sp>
-      <p:sp>
-        <p:nvSpPr>
-          <p:cNvPr id="17" name="Text 14"/>
-          <p:cNvSpPr txBox="1"/>
-          <p:nvPr/>
-        </p:nvSpPr>
-        <p:spPr>
-          <a:xfrm>
-            <a:off x="9829800" y="2807208"/>
-            <a:ext cx="914400" cy="493776"/>
+              <a:t>WHY IT MATTERS</a:t>
+            </a:r>
+            <a:endParaRPr lang="en-US" sz="1000" dirty="0"/>
+          </a:p>
+        </p:txBody>
+      </p:sp>
+      <p:sp>
+        <p:nvSpPr>
+          <p:cNvPr id="15" name="Text 13"/>
+          <p:cNvSpPr txBox="1"/>
+          <p:nvPr/>
+        </p:nvSpPr>
+        <p:spPr>
+          <a:xfrm>
+            <a:off x="7863840" y="4425696"/>
+            <a:ext cx="3483864" cy="384048"/>
           </a:xfrm>
           <a:prstGeom prst="rect">
             <a:avLst/>
@@ -7961,7 +8125,49 @@
           <a:bodyPr wrap="square" lIns="0" tIns="0" rIns="0" bIns="0" rtlCol="0" anchor="ctr"/>
           <a:lstStyle/>
           <a:p>
-            <a:pPr algn="r" indent="0" marL="0">
+            <a:pPr indent="0" marL="0">
+              <a:buNone/>
+            </a:pPr>
+            <a:r>
+              <a:rPr lang="en-US" sz="2000" b="1" dirty="0">
+                <a:solidFill>
+                  <a:srgbClr val="FFFFFF"/>
+                </a:solidFill>
+                <a:latin typeface="Arial" pitchFamily="34" charset="0"/>
+                <a:ea typeface="Arial" pitchFamily="34" charset="-122"/>
+                <a:cs typeface="Arial" pitchFamily="34" charset="-120"/>
+              </a:rPr>
+              <a:t>Nothing is implicit</a:t>
+            </a:r>
+            <a:endParaRPr lang="en-US" sz="2000" dirty="0"/>
+          </a:p>
+        </p:txBody>
+      </p:sp>
+      <p:sp>
+        <p:nvSpPr>
+          <p:cNvPr id="16" name="Text 14"/>
+          <p:cNvSpPr txBox="1"/>
+          <p:nvPr/>
+        </p:nvSpPr>
+        <p:spPr>
+          <a:xfrm>
+            <a:off x="7863840" y="4864608"/>
+            <a:ext cx="3483864" cy="274320"/>
+          </a:xfrm>
+          <a:prstGeom prst="rect">
+            <a:avLst/>
+          </a:prstGeom>
+          <a:noFill/>
+          <a:ln/>
+        </p:spPr>
+        <p:txBody>
+          <a:bodyPr wrap="square" lIns="0" tIns="0" rIns="0" bIns="0" rtlCol="0" anchor="t"/>
+          <a:lstStyle/>
+          <a:p>
+            <a:pPr indent="0" marL="0">
+              <a:lnSpc>
+                <a:spcPct val="120000"/>
+              </a:lnSpc>
               <a:buNone/>
             </a:pPr>
             <a:r>
@@ -7973,7 +8179,7 @@
                 <a:ea typeface="Arial" pitchFamily="34" charset="-122"/>
                 <a:cs typeface="Arial" pitchFamily="34" charset="-120"/>
               </a:rPr>
-              <a:t>9 closes</a:t>
+              <a:t>You can reconstruct every decision the agent made, and every one it declined to make.</a:t>
             </a:r>
             <a:endParaRPr lang="en-US" sz="1100" dirty="0"/>
           </a:p>
@@ -7981,14 +8187,14 @@
       </p:sp>
       <p:sp>
         <p:nvSpPr>
-          <p:cNvPr id="18" name="Text 15"/>
-          <p:cNvSpPr txBox="1"/>
-          <p:nvPr/>
-        </p:nvSpPr>
-        <p:spPr>
-          <a:xfrm>
-            <a:off x="10744200" y="2807208"/>
-            <a:ext cx="777240" cy="493776"/>
+          <p:cNvPr id="17" name="Text 15"/>
+          <p:cNvSpPr txBox="1"/>
+          <p:nvPr/>
+        </p:nvSpPr>
+        <p:spPr>
+          <a:xfrm>
+            <a:off x="548640" y="5532120"/>
+            <a:ext cx="11091672" cy="365760"/>
           </a:xfrm>
           <a:prstGeom prst="rect">
             <a:avLst/>
@@ -8000,11 +8206,11 @@
           <a:bodyPr wrap="square" lIns="0" tIns="0" rIns="0" bIns="0" rtlCol="0" anchor="ctr"/>
           <a:lstStyle/>
           <a:p>
-            <a:pPr algn="r" indent="0" marL="0">
-              <a:buNone/>
-            </a:pPr>
-            <a:r>
-              <a:rPr lang="en-US" sz="1100" dirty="0">
+            <a:pPr indent="0" marL="0">
+              <a:buNone/>
+            </a:pPr>
+            <a:r>
+              <a:rPr lang="en-US" sz="1300" dirty="0">
                 <a:solidFill>
                   <a:srgbClr val="A1A8B5"/>
                 </a:solidFill>
@@ -8012,381 +8218,7 @@
                 <a:ea typeface="Arial" pitchFamily="34" charset="-122"/>
                 <a:cs typeface="Arial" pitchFamily="34" charset="-120"/>
               </a:rPr>
-              <a:t>88.9% win</a:t>
-            </a:r>
-            <a:endParaRPr lang="en-US" sz="1100" dirty="0"/>
-          </a:p>
-        </p:txBody>
-      </p:sp>
-      <p:sp>
-        <p:nvSpPr>
-          <p:cNvPr id="19" name="Shape 16"/>
-          <p:cNvSpPr/>
-          <p:nvPr/>
-        </p:nvSpPr>
-        <p:spPr>
-          <a:xfrm>
-            <a:off x="7269480" y="3374136"/>
-            <a:ext cx="4370832" cy="493776"/>
-          </a:xfrm>
-          <a:prstGeom prst="roundRect">
-            <a:avLst>
-              <a:gd name="adj" fmla="val 11111"/>
-            </a:avLst>
-          </a:prstGeom>
-          <a:solidFill>
-            <a:srgbClr val="141922"/>
-          </a:solidFill>
-          <a:ln w="12700">
-            <a:solidFill>
-              <a:srgbClr val="232A38"/>
-            </a:solidFill>
-            <a:prstDash val="solid"/>
-          </a:ln>
-        </p:spPr>
-      </p:sp>
-      <p:sp>
-        <p:nvSpPr>
-          <p:cNvPr id="20" name="Text 17"/>
-          <p:cNvSpPr txBox="1"/>
-          <p:nvPr/>
-        </p:nvSpPr>
-        <p:spPr>
-          <a:xfrm>
-            <a:off x="7452360" y="3374136"/>
-            <a:ext cx="960120" cy="493776"/>
-          </a:xfrm>
-          <a:prstGeom prst="rect">
-            <a:avLst/>
-          </a:prstGeom>
-          <a:noFill/>
-          <a:ln/>
-        </p:spPr>
-        <p:txBody>
-          <a:bodyPr wrap="square" lIns="0" tIns="0" rIns="0" bIns="0" rtlCol="0" anchor="ctr"/>
-          <a:lstStyle/>
-          <a:p>
-            <a:pPr indent="0" marL="0">
-              <a:buNone/>
-            </a:pPr>
-            <a:r>
-              <a:rPr lang="en-US" sz="1300" b="1" dirty="0">
-                <a:solidFill>
-                  <a:srgbClr val="FFFFFF"/>
-                </a:solidFill>
-                <a:latin typeface="Arial" pitchFamily="34" charset="0"/>
-                <a:ea typeface="Arial" pitchFamily="34" charset="-122"/>
-                <a:cs typeface="Arial" pitchFamily="34" charset="-120"/>
-              </a:rPr>
-              <a:t>Sep 3</a:t>
-            </a:r>
-            <a:endParaRPr lang="en-US" sz="1300" dirty="0"/>
-          </a:p>
-        </p:txBody>
-      </p:sp>
-      <p:sp>
-        <p:nvSpPr>
-          <p:cNvPr id="21" name="Text 18"/>
-          <p:cNvSpPr txBox="1"/>
-          <p:nvPr/>
-        </p:nvSpPr>
-        <p:spPr>
-          <a:xfrm>
-            <a:off x="8412480" y="3374136"/>
-            <a:ext cx="1325880" cy="493776"/>
-          </a:xfrm>
-          <a:prstGeom prst="rect">
-            <a:avLst/>
-          </a:prstGeom>
-          <a:noFill/>
-          <a:ln/>
-        </p:spPr>
-        <p:txBody>
-          <a:bodyPr wrap="square" lIns="0" tIns="0" rIns="0" bIns="0" rtlCol="0" anchor="ctr"/>
-          <a:lstStyle/>
-          <a:p>
-            <a:pPr algn="r" indent="0" marL="0">
-              <a:buNone/>
-            </a:pPr>
-            <a:r>
-              <a:rPr lang="en-US" sz="1300" b="1" dirty="0">
-                <a:solidFill>
-                  <a:srgbClr val="F0B429"/>
-                </a:solidFill>
-                <a:latin typeface="Courier New" pitchFamily="34" charset="0"/>
-                <a:ea typeface="Courier New" pitchFamily="34" charset="-122"/>
-                <a:cs typeface="Courier New" pitchFamily="34" charset="-120"/>
-              </a:rPr>
-              <a:t>+$71,400</a:t>
-            </a:r>
-            <a:endParaRPr lang="en-US" sz="1300" dirty="0"/>
-          </a:p>
-        </p:txBody>
-      </p:sp>
-      <p:sp>
-        <p:nvSpPr>
-          <p:cNvPr id="22" name="Text 19"/>
-          <p:cNvSpPr txBox="1"/>
-          <p:nvPr/>
-        </p:nvSpPr>
-        <p:spPr>
-          <a:xfrm>
-            <a:off x="9829800" y="3374136"/>
-            <a:ext cx="914400" cy="493776"/>
-          </a:xfrm>
-          <a:prstGeom prst="rect">
-            <a:avLst/>
-          </a:prstGeom>
-          <a:noFill/>
-          <a:ln/>
-        </p:spPr>
-        <p:txBody>
-          <a:bodyPr wrap="square" lIns="0" tIns="0" rIns="0" bIns="0" rtlCol="0" anchor="ctr"/>
-          <a:lstStyle/>
-          <a:p>
-            <a:pPr algn="r" indent="0" marL="0">
-              <a:buNone/>
-            </a:pPr>
-            <a:r>
-              <a:rPr lang="en-US" sz="1100" dirty="0">
-                <a:solidFill>
-                  <a:srgbClr val="A1A8B5"/>
-                </a:solidFill>
-                <a:latin typeface="Arial" pitchFamily="34" charset="0"/>
-                <a:ea typeface="Arial" pitchFamily="34" charset="-122"/>
-                <a:cs typeface="Arial" pitchFamily="34" charset="-120"/>
-              </a:rPr>
-              <a:t>13 closes</a:t>
-            </a:r>
-            <a:endParaRPr lang="en-US" sz="1100" dirty="0"/>
-          </a:p>
-        </p:txBody>
-      </p:sp>
-      <p:sp>
-        <p:nvSpPr>
-          <p:cNvPr id="23" name="Text 20"/>
-          <p:cNvSpPr txBox="1"/>
-          <p:nvPr/>
-        </p:nvSpPr>
-        <p:spPr>
-          <a:xfrm>
-            <a:off x="10744200" y="3374136"/>
-            <a:ext cx="777240" cy="493776"/>
-          </a:xfrm>
-          <a:prstGeom prst="rect">
-            <a:avLst/>
-          </a:prstGeom>
-          <a:noFill/>
-          <a:ln/>
-        </p:spPr>
-        <p:txBody>
-          <a:bodyPr wrap="square" lIns="0" tIns="0" rIns="0" bIns="0" rtlCol="0" anchor="ctr"/>
-          <a:lstStyle/>
-          <a:p>
-            <a:pPr algn="r" indent="0" marL="0">
-              <a:buNone/>
-            </a:pPr>
-            <a:r>
-              <a:rPr lang="en-US" sz="1100" dirty="0">
-                <a:solidFill>
-                  <a:srgbClr val="A1A8B5"/>
-                </a:solidFill>
-                <a:latin typeface="Arial" pitchFamily="34" charset="0"/>
-                <a:ea typeface="Arial" pitchFamily="34" charset="-122"/>
-                <a:cs typeface="Arial" pitchFamily="34" charset="-120"/>
-              </a:rPr>
-              <a:t>76.9% win</a:t>
-            </a:r>
-            <a:endParaRPr lang="en-US" sz="1100" dirty="0"/>
-          </a:p>
-        </p:txBody>
-      </p:sp>
-      <p:sp>
-        <p:nvSpPr>
-          <p:cNvPr id="24" name="Shape 21"/>
-          <p:cNvSpPr/>
-          <p:nvPr/>
-        </p:nvSpPr>
-        <p:spPr>
-          <a:xfrm>
-            <a:off x="7269480" y="4041648"/>
-            <a:ext cx="4370832" cy="896112"/>
-          </a:xfrm>
-          <a:prstGeom prst="roundRect">
-            <a:avLst>
-              <a:gd name="adj" fmla="val 8163"/>
-            </a:avLst>
-          </a:prstGeom>
-          <a:solidFill>
-            <a:srgbClr val="141922"/>
-          </a:solidFill>
-          <a:ln w="12700">
-            <a:solidFill>
-              <a:srgbClr val="232A38"/>
-            </a:solidFill>
-            <a:prstDash val="solid"/>
-          </a:ln>
-        </p:spPr>
-      </p:sp>
-      <p:sp>
-        <p:nvSpPr>
-          <p:cNvPr id="25" name="Text 22"/>
-          <p:cNvSpPr txBox="1"/>
-          <p:nvPr/>
-        </p:nvSpPr>
-        <p:spPr>
-          <a:xfrm>
-            <a:off x="7562088" y="4242816"/>
-            <a:ext cx="3785616" cy="219456"/>
-          </a:xfrm>
-          <a:prstGeom prst="rect">
-            <a:avLst/>
-          </a:prstGeom>
-          <a:noFill/>
-          <a:ln/>
-        </p:spPr>
-        <p:txBody>
-          <a:bodyPr wrap="square" lIns="0" tIns="0" rIns="0" bIns="0" rtlCol="0" anchor="ctr"/>
-          <a:lstStyle/>
-          <a:p>
-            <a:pPr indent="0" marL="0">
-              <a:buNone/>
-            </a:pPr>
-            <a:r>
-              <a:rPr lang="en-US" sz="1000" spc="140" kern="0" dirty="0">
-                <a:solidFill>
-                  <a:srgbClr val="6B7686"/>
-                </a:solidFill>
-                <a:latin typeface="Courier New" pitchFamily="34" charset="0"/>
-                <a:ea typeface="Courier New" pitchFamily="34" charset="-122"/>
-                <a:cs typeface="Courier New" pitchFamily="34" charset="-120"/>
-              </a:rPr>
-              <a:t>NET, LIVE</a:t>
-            </a:r>
-            <a:endParaRPr lang="en-US" sz="1000" dirty="0"/>
-          </a:p>
-        </p:txBody>
-      </p:sp>
-      <p:sp>
-        <p:nvSpPr>
-          <p:cNvPr id="26" name="Text 23"/>
-          <p:cNvSpPr txBox="1"/>
-          <p:nvPr/>
-        </p:nvSpPr>
-        <p:spPr>
-          <a:xfrm>
-            <a:off x="7562088" y="4535424"/>
-            <a:ext cx="3785616" cy="384048"/>
-          </a:xfrm>
-          <a:prstGeom prst="rect">
-            <a:avLst/>
-          </a:prstGeom>
-          <a:noFill/>
-          <a:ln/>
-        </p:spPr>
-        <p:txBody>
-          <a:bodyPr wrap="square" lIns="0" tIns="0" rIns="0" bIns="0" rtlCol="0" anchor="ctr"/>
-          <a:lstStyle/>
-          <a:p>
-            <a:pPr indent="0" marL="0">
-              <a:buNone/>
-            </a:pPr>
-            <a:r>
-              <a:rPr lang="en-US" sz="2100" b="1" dirty="0">
-                <a:solidFill>
-                  <a:srgbClr val="F0B429"/>
-                </a:solidFill>
-                <a:latin typeface="Arial" pitchFamily="34" charset="0"/>
-                <a:ea typeface="Arial" pitchFamily="34" charset="-122"/>
-                <a:cs typeface="Arial" pitchFamily="34" charset="-120"/>
-              </a:rPr>
-              <a:t>+83.3%  ·  $183,298</a:t>
-            </a:r>
-            <a:endParaRPr lang="en-US" sz="2100" dirty="0"/>
-          </a:p>
-        </p:txBody>
-      </p:sp>
-      <p:sp>
-        <p:nvSpPr>
-          <p:cNvPr id="27" name="Shape 24"/>
-          <p:cNvSpPr/>
-          <p:nvPr/>
-        </p:nvSpPr>
-        <p:spPr>
-          <a:xfrm>
-            <a:off x="548640" y="5138928"/>
-            <a:ext cx="11091672" cy="960120"/>
-          </a:xfrm>
-          <a:prstGeom prst="roundRect">
-            <a:avLst>
-              <a:gd name="adj" fmla="val 7619"/>
-            </a:avLst>
-          </a:prstGeom>
-          <a:solidFill>
-            <a:srgbClr val="141922"/>
-          </a:solidFill>
-          <a:ln w="12700">
-            <a:solidFill>
-              <a:srgbClr val="E5484D"/>
-            </a:solidFill>
-            <a:prstDash val="solid"/>
-          </a:ln>
-        </p:spPr>
-      </p:sp>
-      <p:sp>
-        <p:nvSpPr>
-          <p:cNvPr id="28" name="Text 25"/>
-          <p:cNvSpPr txBox="1"/>
-          <p:nvPr/>
-        </p:nvSpPr>
-        <p:spPr>
-          <a:xfrm>
-            <a:off x="822960" y="5138928"/>
-            <a:ext cx="10515600" cy="960120"/>
-          </a:xfrm>
-          <a:prstGeom prst="rect">
-            <a:avLst/>
-          </a:prstGeom>
-          <a:noFill/>
-          <a:ln/>
-        </p:spPr>
-        <p:txBody>
-          <a:bodyPr wrap="square" lIns="0" tIns="0" rIns="0" bIns="0" rtlCol="0" anchor="ctr"/>
-          <a:lstStyle/>
-          <a:p>
-            <a:pPr indent="0" marL="0">
-              <a:lnSpc>
-                <a:spcPct val="125000"/>
-              </a:lnSpc>
-              <a:buNone/>
-            </a:pPr>
-            <a:r>
-              <a:rPr lang="en-US" sz="1300" b="1" dirty="0">
-                <a:solidFill>
-                  <a:srgbClr val="FFFFFF"/>
-                </a:solidFill>
-                <a:latin typeface="Arial" pitchFamily="34" charset="0"/>
-                <a:ea typeface="Arial" pitchFamily="34" charset="-122"/>
-                <a:cs typeface="Arial" pitchFamily="34" charset="-120"/>
-              </a:rPr>
-              <a:t>We won't call that edge.  </a:t>
-            </a:r>
-            <a:pPr indent="0" marL="0">
-              <a:lnSpc>
-                <a:spcPct val="125000"/>
-              </a:lnSpc>
-              <a:buNone/>
-            </a:pPr>
-            <a:r>
-              <a:rPr lang="en-US" sz="1300" dirty="0">
-                <a:solidFill>
-                  <a:srgbClr val="A1A8B5"/>
-                </a:solidFill>
-                <a:latin typeface="Arial" pitchFamily="34" charset="0"/>
-                <a:ea typeface="Arial" pitchFamily="34" charset="-122"/>
-                <a:cs typeface="Arial" pitchFamily="34" charset="-120"/>
-              </a:rPr>
-              <a:t>Our own data says this signal has none, one session supplies most of the gain, and the same distribution handed us −10.7% on day one. Four sessions is not a sample — it is an anecdote with a good outcome.</a:t>
+              <a:t>logs/ in the repo carries 14 journal records across 2 session files - clone it and check any decision against the record.</a:t>
             </a:r>
             <a:endParaRPr lang="en-US" sz="1300" dirty="0"/>
           </a:p>
@@ -8457,7 +8289,7 @@
                 <a:ea typeface="Courier New" pitchFamily="34" charset="-122"/>
                 <a:cs typeface="Courier New" pitchFamily="34" charset="-120"/>
               </a:rPr>
-              <a:t>What we are actually claiming</a:t>
+              <a:t>Every trade provable. Every loss capped.</a:t>
             </a:r>
             <a:endParaRPr lang="en-US" sz="1100" dirty="0"/>
           </a:p>
@@ -8496,7 +8328,7 @@
                 <a:ea typeface="Courier New" pitchFamily="34" charset="-122"/>
                 <a:cs typeface="Courier New" pitchFamily="34" charset="-120"/>
               </a:rPr>
-              <a:t>github.com/KIBA0993/defined-risk-0dte-agent</a:t>
+              <a:t>github.com/KIBA0993/Alpaca-Hackathon</a:t>
             </a:r>
             <a:endParaRPr lang="en-US" sz="900" dirty="0"/>
           </a:p>
@@ -8538,7 +8370,7 @@
                 <a:ea typeface="Arial" pitchFamily="34" charset="-122"/>
                 <a:cs typeface="Arial" pitchFamily="34" charset="-120"/>
               </a:rPr>
-              <a:t>The equity curve is just</a:t>
+              <a:t>A fresh $100,000 account,</a:t>
             </a:r>
             <a:endParaRPr lang="en-US" sz="4600" dirty="0"/>
           </a:p>
@@ -8558,7 +8390,7 @@
                 <a:ea typeface="Arial" pitchFamily="34" charset="-122"/>
                 <a:cs typeface="Arial" pitchFamily="34" charset="-120"/>
               </a:rPr>
-              <a:t>what happened this week.</a:t>
+              <a:t>3 sessions, +79.1%.</a:t>
             </a:r>
             <a:endParaRPr lang="en-US" sz="4600" dirty="0"/>
           </a:p>
@@ -8636,7 +8468,7 @@
                 <a:ea typeface="Arial" pitchFamily="34" charset="-122"/>
                 <a:cs typeface="Arial" pitchFamily="34" charset="-120"/>
               </a:rPr>
-              <a:t>Max loss fixed by the instrument</a:t>
+              <a:t>Max loss capped by the instrument</a:t>
             </a:r>
             <a:pPr indent="0" marL="0">
               <a:buNone/>
@@ -8728,7 +8560,7 @@
                 <a:ea typeface="Arial" pitchFamily="34" charset="-122"/>
                 <a:cs typeface="Arial" pitchFamily="34" charset="-120"/>
               </a:rPr>
-              <a:t>An AI that is only allowed to say no</a:t>
+              <a:t>An AI that can only remove risk</a:t>
             </a:r>
             <a:pPr indent="0" marL="0">
               <a:buNone/>
@@ -8742,7 +8574,7 @@
                 <a:ea typeface="Arial" pitchFamily="34" charset="-122"/>
                 <a:cs typeface="Arial" pitchFamily="34" charset="-120"/>
               </a:rPr>
-              <a:t>   scoped to what we could actually measure</a:t>
+              <a:t>   structurally unable to add a trade</a:t>
             </a:r>
             <a:endParaRPr lang="en-US" sz="1500" dirty="0"/>
           </a:p>
@@ -8820,7 +8652,7 @@
                 <a:ea typeface="Arial" pitchFamily="34" charset="-122"/>
                 <a:cs typeface="Arial" pitchFamily="34" charset="-120"/>
               </a:rPr>
-              <a:t>Gates that hold when the P&amp;L is ugly</a:t>
+              <a:t>Every order through the Alpaca CLI</a:t>
             </a:r>
             <a:pPr indent="0" marL="0">
               <a:buNone/>
@@ -8834,7 +8666,7 @@
                 <a:ea typeface="Arial" pitchFamily="34" charset="-122"/>
                 <a:cs typeface="Arial" pitchFamily="34" charset="-120"/>
               </a:rPr>
-              <a:t>   they never depend on the signal being right</a:t>
+              <a:t>   P&amp;L is the real broker fill, not a quote</a:t>
             </a:r>
             <a:endParaRPr lang="en-US" sz="1500" dirty="0"/>
           </a:p>
@@ -8912,7 +8744,7 @@
                 <a:ea typeface="Arial" pitchFamily="34" charset="-122"/>
                 <a:cs typeface="Arial" pitchFamily="34" charset="-120"/>
               </a:rPr>
-              <a:t>A journal of every trade it refused</a:t>
+              <a:t>Every decision journaled</a:t>
             </a:r>
             <a:pPr indent="0" marL="0">
               <a:buNone/>
@@ -8926,7 +8758,7 @@
                 <a:ea typeface="Arial" pitchFamily="34" charset="-122"/>
                 <a:cs typeface="Arial" pitchFamily="34" charset="-120"/>
               </a:rPr>
-              <a:t>   the audit trail is the deliverable</a:t>
+              <a:t>   including the ones it refused to take</a:t>
             </a:r>
             <a:endParaRPr lang="en-US" sz="1500" dirty="0"/>
           </a:p>
@@ -8941,7 +8773,7 @@
         <p:spPr>
           <a:xfrm>
             <a:off x="548640" y="6263640"/>
-            <a:ext cx="6400800" cy="274320"/>
+            <a:ext cx="7772400" cy="274320"/>
           </a:xfrm>
           <a:prstGeom prst="rect">
             <a:avLst/>
@@ -8965,7 +8797,7 @@
                 <a:ea typeface="Courier New" pitchFamily="34" charset="-122"/>
                 <a:cs typeface="Courier New" pitchFamily="34" charset="-120"/>
               </a:rPr>
-              <a:t>Paper trading only. Hypothetical results; not investment advice.</a:t>
+              <a:t>Alpaca paper account PA38HG4D9653  ·  paper trading only. Hypothetical results; not investment advice.</a:t>
             </a:r>
             <a:endParaRPr lang="en-US" sz="900" dirty="0"/>
           </a:p>

</xml_diff>

<commit_message>
Ship the one-page write-up as a slide as well as a repo page
The hackathon accepts the write-up as a slide, a section of the project
description, or a repo page. It now exists in all three forms, from one
source of numbers:

- slide 9 of the deck, three columns matching the three mandated topics
- docs/ONE_PAGER.md and docs/ONE_PAGER.pdf
- README header pointing at each

Co-Authored-By: Claude Opus 5 <noreply@anthropic.com>
</commit_message>
<xml_diff>
--- a/assets/deck.pptx
+++ b/assets/deck.pptx
@@ -13,9 +13,10 @@
     <p:sldId id="261" r:id="rId7"/>
     <p:sldId id="262" r:id="rId8"/>
     <p:sldId id="263" r:id="rId9"/>
+    <p:sldId id="264" r:id="rId10"/>
   </p:sldIdLst>
   <p:notesMasterIdLst>
-    <p:notesMasterId r:id="rId10"/>
+    <p:notesMasterId r:id="rId11"/>
   </p:notesMasterIdLst>
   <p:sldSz cx="12192000" cy="6858000"/>
   <p:notesSz cx="6858000" cy="12192000"/>
@@ -1420,6 +1421,94 @@
             <a:fld id="{F7021451-1387-4CA6-816F-3879F97B5CBC}" type="slidenum">
               <a:rPr lang="en-US"/>
               <a:t>8</a:t>
+            </a:fld>
+            <a:endParaRPr lang="en-US"/>
+          </a:p>
+        </p:txBody>
+      </p:sp>
+    </p:spTree>
+    <p:extLst>
+      <p:ext uri="{BB962C8B-B14F-4D97-AF65-F5344CB8AC3E}">
+        <p14:creationId xmlns:p14="http://schemas.microsoft.com/office/powerpoint/2010/main" val="1024086991"/>
+      </p:ext>
+    </p:extLst>
+  </p:cSld>
+  <p:clrMapOvr>
+    <a:masterClrMapping/>
+  </p:clrMapOvr>
+</p:notes>
+</file>
+
+<file path=ppt/notesSlides/notesSlide9.xml><?xml version="1.0" encoding="utf-8"?>
+<p:notes xmlns:a="http://schemas.openxmlformats.org/drawingml/2006/main" xmlns:r="http://schemas.openxmlformats.org/officeDocument/2006/relationships" xmlns:p="http://schemas.openxmlformats.org/presentationml/2006/main">
+  <p:cSld>
+    <p:spTree>
+      <p:nvGrpSpPr>
+        <p:cNvPr id="1" name=""/>
+        <p:cNvGrpSpPr/>
+        <p:nvPr/>
+      </p:nvGrpSpPr>
+      <p:grpSpPr>
+        <a:xfrm>
+          <a:off x="0" y="0"/>
+          <a:ext cx="0" cy="0"/>
+          <a:chOff x="0" y="0"/>
+          <a:chExt cx="0" cy="0"/>
+        </a:xfrm>
+      </p:grpSpPr>
+      <p:sp>
+        <p:nvSpPr>
+          <p:cNvPr id="2" name="Slide Image Placeholder 1"/>
+          <p:cNvSpPr>
+            <a:spLocks noGrp="1" noRot="1" noChangeAspect="1"/>
+          </p:cNvSpPr>
+          <p:nvPr>
+            <p:ph type="sldImg"/>
+          </p:nvPr>
+        </p:nvSpPr>
+        <p:spPr/>
+      </p:sp>
+      <p:sp>
+        <p:nvSpPr>
+          <p:cNvPr id="3" name="Notes Placeholder 2"/>
+          <p:cNvSpPr>
+            <a:spLocks noGrp="1"/>
+          </p:cNvSpPr>
+          <p:nvPr>
+            <p:ph type="body" idx="1"/>
+          </p:nvPr>
+        </p:nvSpPr>
+        <p:spPr/>
+        <p:txBody>
+          <a:bodyPr/>
+          <a:lstStyle/>
+          <a:p>
+            <a:r>
+              <a:rPr lang="en-US" dirty="0"/>
+              <a:t>This slide is the hackathon's required one-page write-up. The same content ships as docs/ONE_PAGER.md and docs/ONE_PAGER.pdf in the repo.</a:t>
+            </a:r>
+            <a:endParaRPr lang="en-US" dirty="0"/>
+          </a:p>
+        </p:txBody>
+      </p:sp>
+      <p:sp>
+        <p:nvSpPr>
+          <p:cNvPr id="4" name="Slide Number Placeholder 3"/>
+          <p:cNvSpPr>
+            <a:spLocks noGrp="1"/>
+          </p:cNvSpPr>
+          <p:nvPr>
+            <p:ph type="sldNum" sz="quarter" idx="10"/>
+          </p:nvPr>
+        </p:nvSpPr>
+        <p:spPr/>
+        <p:txBody>
+          <a:bodyPr/>
+          <a:lstStyle/>
+          <a:p>
+            <a:fld id="{F7021451-1387-4CA6-816F-3879F97B5CBC}" type="slidenum">
+              <a:rPr lang="en-US"/>
+              <a:t>9</a:t>
             </a:fld>
             <a:endParaRPr lang="en-US"/>
           </a:p>
@@ -8811,6 +8900,1003 @@
 </p:sld>
 </file>
 
+<file path=ppt/slides/slide9.xml><?xml version="1.0" encoding="utf-8"?>
+<p:sld xmlns:a="http://schemas.openxmlformats.org/drawingml/2006/main" xmlns:r="http://schemas.openxmlformats.org/officeDocument/2006/relationships" xmlns:p="http://schemas.openxmlformats.org/presentationml/2006/main">
+  <p:cSld name="Slide 9">
+    <p:bg>
+      <p:bgPr>
+        <a:solidFill>
+          <a:srgbClr val="0B0E14"/>
+        </a:solidFill>
+      </p:bgPr>
+    </p:bg>
+    <p:spTree>
+      <p:nvGrpSpPr>
+        <p:cNvPr id="1" name=""/>
+        <p:cNvGrpSpPr/>
+        <p:nvPr/>
+      </p:nvGrpSpPr>
+      <p:grpSpPr>
+        <a:xfrm>
+          <a:off x="0" y="0"/>
+          <a:ext cx="0" cy="0"/>
+          <a:chOff x="0" y="0"/>
+          <a:chExt cx="0" cy="0"/>
+        </a:xfrm>
+      </p:grpSpPr>
+      <p:sp>
+        <p:nvSpPr>
+          <p:cNvPr id="2" name="Text 0"/>
+          <p:cNvSpPr txBox="1"/>
+          <p:nvPr/>
+        </p:nvSpPr>
+        <p:spPr>
+          <a:xfrm>
+            <a:off x="548640" y="384048"/>
+            <a:ext cx="7315200" cy="274320"/>
+          </a:xfrm>
+          <a:prstGeom prst="rect">
+            <a:avLst/>
+          </a:prstGeom>
+          <a:noFill/>
+          <a:ln/>
+        </p:spPr>
+        <p:txBody>
+          <a:bodyPr wrap="square" rtlCol="0" anchor="ctr"/>
+          <a:lstStyle/>
+          <a:p>
+            <a:pPr indent="0" marL="0">
+              <a:buNone/>
+            </a:pPr>
+            <a:r>
+              <a:rPr lang="en-US" sz="1100" spc="200" kern="0" dirty="0">
+                <a:solidFill>
+                  <a:srgbClr val="6B7686"/>
+                </a:solidFill>
+                <a:latin typeface="Courier New" pitchFamily="34" charset="0"/>
+                <a:ea typeface="Courier New" pitchFamily="34" charset="-122"/>
+                <a:cs typeface="Courier New" pitchFamily="34" charset="-120"/>
+              </a:rPr>
+              <a:t>Required one-page write-up</a:t>
+            </a:r>
+            <a:endParaRPr lang="en-US" sz="1100" dirty="0"/>
+          </a:p>
+        </p:txBody>
+      </p:sp>
+      <p:sp>
+        <p:nvSpPr>
+          <p:cNvPr id="3" name="Text 1"/>
+          <p:cNvSpPr txBox="1"/>
+          <p:nvPr/>
+        </p:nvSpPr>
+        <p:spPr>
+          <a:xfrm>
+            <a:off x="7315200" y="6263640"/>
+            <a:ext cx="4325112" cy="274320"/>
+          </a:xfrm>
+          <a:prstGeom prst="rect">
+            <a:avLst/>
+          </a:prstGeom>
+          <a:noFill/>
+          <a:ln/>
+        </p:spPr>
+        <p:txBody>
+          <a:bodyPr wrap="square" rtlCol="0" anchor="ctr"/>
+          <a:lstStyle/>
+          <a:p>
+            <a:pPr algn="r" indent="0" marL="0">
+              <a:buNone/>
+            </a:pPr>
+            <a:r>
+              <a:rPr lang="en-US" sz="900" dirty="0">
+                <a:solidFill>
+                  <a:srgbClr val="6B7686"/>
+                </a:solidFill>
+                <a:latin typeface="Courier New" pitchFamily="34" charset="0"/>
+                <a:ea typeface="Courier New" pitchFamily="34" charset="-122"/>
+                <a:cs typeface="Courier New" pitchFamily="34" charset="-120"/>
+              </a:rPr>
+              <a:t>github.com/KIBA0993/Alpaca-Hackathon</a:t>
+            </a:r>
+            <a:endParaRPr lang="en-US" sz="900" dirty="0"/>
+          </a:p>
+        </p:txBody>
+      </p:sp>
+      <p:sp>
+        <p:nvSpPr>
+          <p:cNvPr id="4" name="Text 2"/>
+          <p:cNvSpPr txBox="1"/>
+          <p:nvPr/>
+        </p:nvSpPr>
+        <p:spPr>
+          <a:xfrm>
+            <a:off x="548640" y="868680"/>
+            <a:ext cx="11064240" cy="777240"/>
+          </a:xfrm>
+          <a:prstGeom prst="rect">
+            <a:avLst/>
+          </a:prstGeom>
+          <a:noFill/>
+          <a:ln/>
+        </p:spPr>
+        <p:txBody>
+          <a:bodyPr wrap="square" lIns="0" tIns="0" rIns="0" bIns="0" rtlCol="0" anchor="ctr"/>
+          <a:lstStyle/>
+          <a:p>
+            <a:pPr indent="0" marL="0">
+              <a:buNone/>
+            </a:pPr>
+            <a:r>
+              <a:rPr lang="en-US" sz="3400" b="1" dirty="0">
+                <a:solidFill>
+                  <a:srgbClr val="FFFFFF"/>
+                </a:solidFill>
+                <a:latin typeface="Arial" pitchFamily="34" charset="0"/>
+                <a:ea typeface="Arial" pitchFamily="34" charset="-122"/>
+                <a:cs typeface="Arial" pitchFamily="34" charset="-120"/>
+              </a:rPr>
+              <a:t>AI logic  ·  Risk gates  ·  Alpaca infrastructure</a:t>
+            </a:r>
+            <a:endParaRPr lang="en-US" sz="3400" dirty="0"/>
+          </a:p>
+        </p:txBody>
+      </p:sp>
+      <p:sp>
+        <p:nvSpPr>
+          <p:cNvPr id="5" name="Shape 3"/>
+          <p:cNvSpPr/>
+          <p:nvPr/>
+        </p:nvSpPr>
+        <p:spPr>
+          <a:xfrm>
+            <a:off x="548640" y="1664208"/>
+            <a:ext cx="11091672" cy="548640"/>
+          </a:xfrm>
+          <a:prstGeom prst="roundRect">
+            <a:avLst>
+              <a:gd name="adj" fmla="val 13333"/>
+            </a:avLst>
+          </a:prstGeom>
+          <a:solidFill>
+            <a:srgbClr val="141922"/>
+          </a:solidFill>
+          <a:ln w="12700">
+            <a:solidFill>
+              <a:srgbClr val="F0B429"/>
+            </a:solidFill>
+            <a:prstDash val="solid"/>
+          </a:ln>
+        </p:spPr>
+      </p:sp>
+      <p:sp>
+        <p:nvSpPr>
+          <p:cNvPr id="6" name="Text 4"/>
+          <p:cNvSpPr txBox="1"/>
+          <p:nvPr/>
+        </p:nvSpPr>
+        <p:spPr>
+          <a:xfrm>
+            <a:off x="822960" y="1664208"/>
+            <a:ext cx="10515600" cy="548640"/>
+          </a:xfrm>
+          <a:prstGeom prst="rect">
+            <a:avLst/>
+          </a:prstGeom>
+          <a:noFill/>
+          <a:ln/>
+        </p:spPr>
+        <p:txBody>
+          <a:bodyPr wrap="square" lIns="0" tIns="0" rIns="0" bIns="0" rtlCol="0" anchor="ctr"/>
+          <a:lstStyle/>
+          <a:p>
+            <a:pPr indent="0" marL="0">
+              <a:buNone/>
+            </a:pPr>
+            <a:r>
+              <a:rPr lang="en-US" sz="1200" dirty="0">
+                <a:solidFill>
+                  <a:srgbClr val="A1A8B5"/>
+                </a:solidFill>
+                <a:latin typeface="Arial" pitchFamily="34" charset="0"/>
+                <a:ea typeface="Arial" pitchFamily="34" charset="-122"/>
+                <a:cs typeface="Arial" pitchFamily="34" charset="-120"/>
+              </a:rPr>
+              <a:t>Alpaca paper PA38HG4D9653  ·  single-leg long 0DTE on SPY / QQQ / IWM  ·  </a:t>
+            </a:r>
+            <a:pPr indent="0" marL="0">
+              <a:buNone/>
+            </a:pPr>
+            <a:r>
+              <a:rPr lang="en-US" sz="1200" b="1" dirty="0">
+                <a:solidFill>
+                  <a:srgbClr val="FFFFFF"/>
+                </a:solidFill>
+                <a:latin typeface="Arial" pitchFamily="34" charset="0"/>
+                <a:ea typeface="Arial" pitchFamily="34" charset="-122"/>
+                <a:cs typeface="Arial" pitchFamily="34" charset="-120"/>
+              </a:rPr>
+              <a:t>$100,000 → $179,087 (+79.1%) across 3 sessions, 34 entries / 43 exits</a:t>
+            </a:r>
+            <a:endParaRPr lang="en-US" sz="1200" dirty="0"/>
+          </a:p>
+        </p:txBody>
+      </p:sp>
+      <p:sp>
+        <p:nvSpPr>
+          <p:cNvPr id="7" name="Shape 5"/>
+          <p:cNvSpPr/>
+          <p:nvPr/>
+        </p:nvSpPr>
+        <p:spPr>
+          <a:xfrm>
+            <a:off x="548640" y="2395728"/>
+            <a:ext cx="3538728" cy="3703320"/>
+          </a:xfrm>
+          <a:prstGeom prst="roundRect">
+            <a:avLst>
+              <a:gd name="adj" fmla="val 2067"/>
+            </a:avLst>
+          </a:prstGeom>
+          <a:solidFill>
+            <a:srgbClr val="141922"/>
+          </a:solidFill>
+          <a:ln w="12700">
+            <a:solidFill>
+              <a:srgbClr val="232A38"/>
+            </a:solidFill>
+            <a:prstDash val="solid"/>
+          </a:ln>
+        </p:spPr>
+      </p:sp>
+      <p:sp>
+        <p:nvSpPr>
+          <p:cNvPr id="8" name="Text 6"/>
+          <p:cNvSpPr txBox="1"/>
+          <p:nvPr/>
+        </p:nvSpPr>
+        <p:spPr>
+          <a:xfrm>
+            <a:off x="804672" y="2578608"/>
+            <a:ext cx="3026664" cy="274320"/>
+          </a:xfrm>
+          <a:prstGeom prst="rect">
+            <a:avLst/>
+          </a:prstGeom>
+          <a:noFill/>
+          <a:ln/>
+        </p:spPr>
+        <p:txBody>
+          <a:bodyPr wrap="square" lIns="0" tIns="0" rIns="0" bIns="0" rtlCol="0" anchor="ctr"/>
+          <a:lstStyle/>
+          <a:p>
+            <a:pPr indent="0" marL="0">
+              <a:buNone/>
+            </a:pPr>
+            <a:r>
+              <a:rPr lang="en-US" sz="1500" b="1" dirty="0">
+                <a:solidFill>
+                  <a:srgbClr val="F0B429"/>
+                </a:solidFill>
+                <a:latin typeface="Arial" pitchFamily="34" charset="0"/>
+                <a:ea typeface="Arial" pitchFamily="34" charset="-122"/>
+                <a:cs typeface="Arial" pitchFamily="34" charset="-120"/>
+              </a:rPr>
+              <a:t>1 · AI logic</a:t>
+            </a:r>
+            <a:endParaRPr lang="en-US" sz="1500" dirty="0"/>
+          </a:p>
+        </p:txBody>
+      </p:sp>
+      <p:sp>
+        <p:nvSpPr>
+          <p:cNvPr id="9" name="Text 7"/>
+          <p:cNvSpPr txBox="1"/>
+          <p:nvPr/>
+        </p:nvSpPr>
+        <p:spPr>
+          <a:xfrm>
+            <a:off x="804672" y="2962656"/>
+            <a:ext cx="3026664" cy="2953512"/>
+          </a:xfrm>
+          <a:prstGeom prst="rect">
+            <a:avLst/>
+          </a:prstGeom>
+          <a:noFill/>
+          <a:ln/>
+        </p:spPr>
+        <p:txBody>
+          <a:bodyPr wrap="square" lIns="0" tIns="0" rIns="0" bIns="0" rtlCol="0" anchor="t"/>
+          <a:lstStyle/>
+          <a:p>
+            <a:pPr marL="342900" indent="-342900">
+              <a:lnSpc>
+                <a:spcPct val="114000"/>
+              </a:lnSpc>
+              <a:spcAft>
+                <a:spcPts val="400"/>
+              </a:spcAft>
+              <a:buSzPct val="100000"/>
+              <a:buChar char="•"/>
+            </a:pPr>
+            <a:r>
+              <a:rPr lang="en-US" sz="950" dirty="0">
+                <a:solidFill>
+                  <a:srgbClr val="A1A8B5"/>
+                </a:solidFill>
+                <a:latin typeface="Arial" pitchFamily="34" charset="0"/>
+                <a:ea typeface="Arial" pitchFamily="34" charset="-122"/>
+                <a:cs typeface="Arial" pitchFamily="34" charset="-120"/>
+              </a:rPr>
+              <a:t>Scorer reduces Alpaca 5m bars to one number: VWAP position, opening-range break, RSI, EMA stack, relative volume - plus a proposed direction.</a:t>
+            </a:r>
+            <a:endParaRPr lang="en-US" sz="950" dirty="0"/>
+          </a:p>
+          <a:p>
+            <a:pPr marL="342900" indent="-342900">
+              <a:lnSpc>
+                <a:spcPct val="114000"/>
+              </a:lnSpc>
+              <a:spcAft>
+                <a:spcPts val="400"/>
+              </a:spcAft>
+              <a:buSzPct val="100000"/>
+              <a:buChar char="•"/>
+            </a:pPr>
+            <a:r>
+              <a:rPr lang="en-US" sz="950" dirty="0">
+                <a:solidFill>
+                  <a:srgbClr val="A1A8B5"/>
+                </a:solidFill>
+                <a:latin typeface="Arial" pitchFamily="34" charset="0"/>
+                <a:ea typeface="Arial" pitchFamily="34" charset="-122"/>
+                <a:cs typeface="Arial" pitchFamily="34" charset="-120"/>
+              </a:rPr>
+              <a:t>Half-opening-range noise band: is the break larger than the symbol's own morning noise?</a:t>
+            </a:r>
+            <a:endParaRPr lang="en-US" sz="950" dirty="0"/>
+          </a:p>
+          <a:p>
+            <a:pPr marL="342900" indent="-342900">
+              <a:lnSpc>
+                <a:spcPct val="114000"/>
+              </a:lnSpc>
+              <a:spcAft>
+                <a:spcPts val="400"/>
+              </a:spcAft>
+              <a:buSzPct val="100000"/>
+              <a:buChar char="•"/>
+            </a:pPr>
+            <a:r>
+              <a:rPr lang="en-US" sz="950" dirty="0">
+                <a:solidFill>
+                  <a:srgbClr val="A1A8B5"/>
+                </a:solidFill>
+                <a:latin typeface="Arial" pitchFamily="34" charset="0"/>
+                <a:ea typeface="Arial" pitchFamily="34" charset="-122"/>
+                <a:cs typeface="Arial" pitchFamily="34" charset="-120"/>
+              </a:rPr>
+              <a:t>Leader breadth: 5 of 8 mega-caps above their 20-day average as of the last completed session. Only ever removes the opposed side.</a:t>
+            </a:r>
+            <a:endParaRPr lang="en-US" sz="950" dirty="0"/>
+          </a:p>
+          <a:p>
+            <a:pPr marL="342900" indent="-342900">
+              <a:lnSpc>
+                <a:spcPct val="114000"/>
+              </a:lnSpc>
+              <a:spcAft>
+                <a:spcPts val="400"/>
+              </a:spcAft>
+              <a:buSzPct val="100000"/>
+              <a:buChar char="•"/>
+            </a:pPr>
+            <a:r>
+              <a:rPr lang="en-US" sz="950" dirty="0">
+                <a:solidFill>
+                  <a:srgbClr val="A1A8B5"/>
+                </a:solidFill>
+                <a:latin typeface="Arial" pitchFamily="34" charset="0"/>
+                <a:ea typeface="Arial" pitchFamily="34" charset="-122"/>
+                <a:cs typeface="Arial" pitchFamily="34" charset="-120"/>
+              </a:rPr>
+              <a:t>A Claude layer argues bull and bear over the scored facts and returns strict JSON - and can only turn a go into a no-go.</a:t>
+            </a:r>
+            <a:endParaRPr lang="en-US" sz="950" dirty="0"/>
+          </a:p>
+          <a:p>
+            <a:pPr marL="342900" indent="-342900">
+              <a:lnSpc>
+                <a:spcPct val="114000"/>
+              </a:lnSpc>
+              <a:spcAft>
+                <a:spcPts val="400"/>
+              </a:spcAft>
+              <a:buSzPct val="100000"/>
+              <a:buChar char="•"/>
+            </a:pPr>
+            <a:r>
+              <a:rPr lang="en-US" sz="950" dirty="0">
+                <a:solidFill>
+                  <a:srgbClr val="A1A8B5"/>
+                </a:solidFill>
+                <a:latin typeface="Arial" pitchFamily="34" charset="0"/>
+                <a:ea typeface="Arial" pitchFamily="34" charset="-122"/>
+                <a:cs typeface="Arial" pitchFamily="34" charset="-120"/>
+              </a:rPr>
+              <a:t>It can never resurrect a rejected trade, so the deterministic path is a strict subset of the AI path.</a:t>
+            </a:r>
+            <a:endParaRPr lang="en-US" sz="950" dirty="0"/>
+          </a:p>
+          <a:p>
+            <a:pPr marL="342900" indent="-342900">
+              <a:lnSpc>
+                <a:spcPct val="114000"/>
+              </a:lnSpc>
+              <a:spcAft>
+                <a:spcPts val="400"/>
+              </a:spcAft>
+              <a:buSzPct val="100000"/>
+              <a:buChar char="•"/>
+            </a:pPr>
+            <a:r>
+              <a:rPr lang="en-US" sz="950" dirty="0">
+                <a:solidFill>
+                  <a:srgbClr val="A1A8B5"/>
+                </a:solidFill>
+                <a:latin typeface="Arial" pitchFamily="34" charset="0"/>
+                <a:ea typeface="Arial" pitchFamily="34" charset="-122"/>
+                <a:cs typeface="Arial" pitchFamily="34" charset="-120"/>
+              </a:rPr>
+              <a:t>A missing key or unparseable reply degrades to the deterministic gate and says so in the journal.</a:t>
+            </a:r>
+            <a:endParaRPr lang="en-US" sz="950" dirty="0"/>
+          </a:p>
+        </p:txBody>
+      </p:sp>
+      <p:sp>
+        <p:nvSpPr>
+          <p:cNvPr id="10" name="Shape 8"/>
+          <p:cNvSpPr/>
+          <p:nvPr/>
+        </p:nvSpPr>
+        <p:spPr>
+          <a:xfrm>
+            <a:off x="4325112" y="2395728"/>
+            <a:ext cx="3538728" cy="3703320"/>
+          </a:xfrm>
+          <a:prstGeom prst="roundRect">
+            <a:avLst>
+              <a:gd name="adj" fmla="val 2067"/>
+            </a:avLst>
+          </a:prstGeom>
+          <a:solidFill>
+            <a:srgbClr val="141922"/>
+          </a:solidFill>
+          <a:ln w="12700">
+            <a:solidFill>
+              <a:srgbClr val="232A38"/>
+            </a:solidFill>
+            <a:prstDash val="solid"/>
+          </a:ln>
+        </p:spPr>
+      </p:sp>
+      <p:sp>
+        <p:nvSpPr>
+          <p:cNvPr id="11" name="Text 9"/>
+          <p:cNvSpPr txBox="1"/>
+          <p:nvPr/>
+        </p:nvSpPr>
+        <p:spPr>
+          <a:xfrm>
+            <a:off x="4581144" y="2578608"/>
+            <a:ext cx="3026664" cy="274320"/>
+          </a:xfrm>
+          <a:prstGeom prst="rect">
+            <a:avLst/>
+          </a:prstGeom>
+          <a:noFill/>
+          <a:ln/>
+        </p:spPr>
+        <p:txBody>
+          <a:bodyPr wrap="square" lIns="0" tIns="0" rIns="0" bIns="0" rtlCol="0" anchor="ctr"/>
+          <a:lstStyle/>
+          <a:p>
+            <a:pPr indent="0" marL="0">
+              <a:buNone/>
+            </a:pPr>
+            <a:r>
+              <a:rPr lang="en-US" sz="1500" b="1" dirty="0">
+                <a:solidFill>
+                  <a:srgbClr val="F0B429"/>
+                </a:solidFill>
+                <a:latin typeface="Arial" pitchFamily="34" charset="0"/>
+                <a:ea typeface="Arial" pitchFamily="34" charset="-122"/>
+                <a:cs typeface="Arial" pitchFamily="34" charset="-120"/>
+              </a:rPr>
+              <a:t>2 · Risk gates</a:t>
+            </a:r>
+            <a:endParaRPr lang="en-US" sz="1500" dirty="0"/>
+          </a:p>
+        </p:txBody>
+      </p:sp>
+      <p:sp>
+        <p:nvSpPr>
+          <p:cNvPr id="12" name="Text 10"/>
+          <p:cNvSpPr txBox="1"/>
+          <p:nvPr/>
+        </p:nvSpPr>
+        <p:spPr>
+          <a:xfrm>
+            <a:off x="4581144" y="2962656"/>
+            <a:ext cx="3026664" cy="2953512"/>
+          </a:xfrm>
+          <a:prstGeom prst="rect">
+            <a:avLst/>
+          </a:prstGeom>
+          <a:noFill/>
+          <a:ln/>
+        </p:spPr>
+        <p:txBody>
+          <a:bodyPr wrap="square" lIns="0" tIns="0" rIns="0" bIns="0" rtlCol="0" anchor="t"/>
+          <a:lstStyle/>
+          <a:p>
+            <a:pPr marL="342900" indent="-342900">
+              <a:lnSpc>
+                <a:spcPct val="114000"/>
+              </a:lnSpc>
+              <a:spcAft>
+                <a:spcPts val="400"/>
+              </a:spcAft>
+              <a:buSzPct val="100000"/>
+              <a:buChar char="•"/>
+            </a:pPr>
+            <a:r>
+              <a:rPr lang="en-US" sz="950" dirty="0">
+                <a:solidFill>
+                  <a:srgbClr val="A1A8B5"/>
+                </a:solidFill>
+                <a:latin typeface="Arial" pitchFamily="34" charset="0"/>
+                <a:ea typeface="Arial" pitchFamily="34" charset="-122"/>
+                <a:cs typeface="Arial" pitchFamily="34" charset="-120"/>
+              </a:rPr>
+              <a:t>Single-leg long only: max loss is the premium paid, set by the instrument.</a:t>
+            </a:r>
+            <a:endParaRPr lang="en-US" sz="950" dirty="0"/>
+          </a:p>
+          <a:p>
+            <a:pPr marL="342900" indent="-342900">
+              <a:lnSpc>
+                <a:spcPct val="114000"/>
+              </a:lnSpc>
+              <a:spcAft>
+                <a:spcPts val="400"/>
+              </a:spcAft>
+              <a:buSzPct val="100000"/>
+              <a:buChar char="•"/>
+            </a:pPr>
+            <a:r>
+              <a:rPr lang="en-US" sz="950" dirty="0">
+                <a:solidFill>
+                  <a:srgbClr val="A1A8B5"/>
+                </a:solidFill>
+                <a:latin typeface="Arial" pitchFamily="34" charset="0"/>
+                <a:ea typeface="Arial" pitchFamily="34" charset="-122"/>
+                <a:cs typeface="Arial" pitchFamily="34" charset="-120"/>
+              </a:rPr>
+              <a:t>One open lot per (symbol, direction); one direction per underlying.</a:t>
+            </a:r>
+            <a:endParaRPr lang="en-US" sz="950" dirty="0"/>
+          </a:p>
+          <a:p>
+            <a:pPr marL="342900" indent="-342900">
+              <a:lnSpc>
+                <a:spcPct val="114000"/>
+              </a:lnSpc>
+              <a:spcAft>
+                <a:spcPts val="400"/>
+              </a:spcAft>
+              <a:buSzPct val="100000"/>
+              <a:buChar char="•"/>
+            </a:pPr>
+            <a:r>
+              <a:rPr lang="en-US" sz="950" dirty="0">
+                <a:solidFill>
+                  <a:srgbClr val="A1A8B5"/>
+                </a:solidFill>
+                <a:latin typeface="Arial" pitchFamily="34" charset="0"/>
+                <a:ea typeface="Arial" pitchFamily="34" charset="-122"/>
+                <a:cs typeface="Arial" pitchFamily="34" charset="-120"/>
+              </a:rPr>
+              <a:t>30-minute entry-anchored dedup, so a persistent score cannot stack the same name.</a:t>
+            </a:r>
+            <a:endParaRPr lang="en-US" sz="950" dirty="0"/>
+          </a:p>
+          <a:p>
+            <a:pPr marL="342900" indent="-342900">
+              <a:lnSpc>
+                <a:spcPct val="114000"/>
+              </a:lnSpc>
+              <a:spcAft>
+                <a:spcPts val="400"/>
+              </a:spcAft>
+              <a:buSzPct val="100000"/>
+              <a:buChar char="•"/>
+            </a:pPr>
+            <a:r>
+              <a:rPr lang="en-US" sz="950" dirty="0">
+                <a:solidFill>
+                  <a:srgbClr val="A1A8B5"/>
+                </a:solidFill>
+                <a:latin typeface="Arial" pitchFamily="34" charset="0"/>
+                <a:ea typeface="Arial" pitchFamily="34" charset="-122"/>
+                <a:cs typeface="Arial" pitchFamily="34" charset="-120"/>
+              </a:rPr>
+              <a:t>Sizing trimmed to the account's real options buying power - expensive contracts size down, never reject.</a:t>
+            </a:r>
+            <a:endParaRPr lang="en-US" sz="950" dirty="0"/>
+          </a:p>
+          <a:p>
+            <a:pPr marL="342900" indent="-342900">
+              <a:lnSpc>
+                <a:spcPct val="114000"/>
+              </a:lnSpc>
+              <a:spcAft>
+                <a:spcPts val="400"/>
+              </a:spcAft>
+              <a:buSzPct val="100000"/>
+              <a:buChar char="•"/>
+            </a:pPr>
+            <a:r>
+              <a:rPr lang="en-US" sz="950" dirty="0">
+                <a:solidFill>
+                  <a:srgbClr val="A1A8B5"/>
+                </a:solidFill>
+                <a:latin typeface="Arial" pitchFamily="34" charset="0"/>
+                <a:ea typeface="Arial" pitchFamily="34" charset="-122"/>
+                <a:cs typeface="Arial" pitchFamily="34" charset="-120"/>
+              </a:rPr>
+              <a:t>No entry after 15:00 ET; hard flatten at 15:50, so a 0DTE never reaches expiry.</a:t>
+            </a:r>
+            <a:endParaRPr lang="en-US" sz="950" dirty="0"/>
+          </a:p>
+          <a:p>
+            <a:pPr marL="342900" indent="-342900">
+              <a:lnSpc>
+                <a:spcPct val="114000"/>
+              </a:lnSpc>
+              <a:spcAft>
+                <a:spcPts val="400"/>
+              </a:spcAft>
+              <a:buSzPct val="100000"/>
+              <a:buChar char="•"/>
+            </a:pPr>
+            <a:r>
+              <a:rPr lang="en-US" sz="950" dirty="0">
+                <a:solidFill>
+                  <a:srgbClr val="A1A8B5"/>
+                </a:solidFill>
+                <a:latin typeface="Arial" pitchFamily="34" charset="0"/>
+                <a:ea typeface="Arial" pitchFamily="34" charset="-122"/>
+                <a:cs typeface="Arial" pitchFamily="34" charset="-120"/>
+              </a:rPr>
+              <a:t>Orphan sweep at startup and EOD for positions the agent did not open.</a:t>
+            </a:r>
+            <a:endParaRPr lang="en-US" sz="950" dirty="0"/>
+          </a:p>
+          <a:p>
+            <a:pPr marL="342900" indent="-342900">
+              <a:lnSpc>
+                <a:spcPct val="114000"/>
+              </a:lnSpc>
+              <a:spcAft>
+                <a:spcPts val="400"/>
+              </a:spcAft>
+              <a:buSzPct val="100000"/>
+              <a:buChar char="•"/>
+            </a:pPr>
+            <a:r>
+              <a:rPr lang="en-US" sz="950" dirty="0">
+                <a:solidFill>
+                  <a:srgbClr val="A1A8B5"/>
+                </a:solidFill>
+                <a:latin typeface="Arial" pitchFamily="34" charset="0"/>
+                <a:ea typeface="Arial" pitchFamily="34" charset="-122"/>
+                <a:cs typeface="Arial" pitchFamily="34" charset="-120"/>
+              </a:rPr>
+              <a:t>Exits: +40% sells half and trails the runner; -20% half, -40% the rest; 30-min stop if under water.</a:t>
+            </a:r>
+            <a:endParaRPr lang="en-US" sz="950" dirty="0"/>
+          </a:p>
+          <a:p>
+            <a:pPr marL="342900" indent="-342900">
+              <a:lnSpc>
+                <a:spcPct val="114000"/>
+              </a:lnSpc>
+              <a:spcAft>
+                <a:spcPts val="400"/>
+              </a:spcAft>
+              <a:buSzPct val="100000"/>
+              <a:buChar char="•"/>
+            </a:pPr>
+            <a:r>
+              <a:rPr lang="en-US" sz="950" dirty="0">
+                <a:solidFill>
+                  <a:srgbClr val="A1A8B5"/>
+                </a:solidFill>
+                <a:latin typeface="Arial" pitchFamily="34" charset="0"/>
+                <a:ea typeface="Arial" pitchFamily="34" charset="-122"/>
+                <a:cs typeface="Arial" pitchFamily="34" charset="-120"/>
+              </a:rPr>
+              <a:t>175 network-free tests cover all of it.</a:t>
+            </a:r>
+            <a:endParaRPr lang="en-US" sz="950" dirty="0"/>
+          </a:p>
+        </p:txBody>
+      </p:sp>
+      <p:sp>
+        <p:nvSpPr>
+          <p:cNvPr id="13" name="Shape 11"/>
+          <p:cNvSpPr/>
+          <p:nvPr/>
+        </p:nvSpPr>
+        <p:spPr>
+          <a:xfrm>
+            <a:off x="8101584" y="2395728"/>
+            <a:ext cx="3538728" cy="3703320"/>
+          </a:xfrm>
+          <a:prstGeom prst="roundRect">
+            <a:avLst>
+              <a:gd name="adj" fmla="val 2067"/>
+            </a:avLst>
+          </a:prstGeom>
+          <a:solidFill>
+            <a:srgbClr val="141922"/>
+          </a:solidFill>
+          <a:ln w="12700">
+            <a:solidFill>
+              <a:srgbClr val="232A38"/>
+            </a:solidFill>
+            <a:prstDash val="solid"/>
+          </a:ln>
+        </p:spPr>
+      </p:sp>
+      <p:sp>
+        <p:nvSpPr>
+          <p:cNvPr id="14" name="Text 12"/>
+          <p:cNvSpPr txBox="1"/>
+          <p:nvPr/>
+        </p:nvSpPr>
+        <p:spPr>
+          <a:xfrm>
+            <a:off x="8357616" y="2578608"/>
+            <a:ext cx="3026664" cy="274320"/>
+          </a:xfrm>
+          <a:prstGeom prst="rect">
+            <a:avLst/>
+          </a:prstGeom>
+          <a:noFill/>
+          <a:ln/>
+        </p:spPr>
+        <p:txBody>
+          <a:bodyPr wrap="square" lIns="0" tIns="0" rIns="0" bIns="0" rtlCol="0" anchor="ctr"/>
+          <a:lstStyle/>
+          <a:p>
+            <a:pPr indent="0" marL="0">
+              <a:buNone/>
+            </a:pPr>
+            <a:r>
+              <a:rPr lang="en-US" sz="1500" b="1" dirty="0">
+                <a:solidFill>
+                  <a:srgbClr val="F0B429"/>
+                </a:solidFill>
+                <a:latin typeface="Arial" pitchFamily="34" charset="0"/>
+                <a:ea typeface="Arial" pitchFamily="34" charset="-122"/>
+                <a:cs typeface="Arial" pitchFamily="34" charset="-120"/>
+              </a:rPr>
+              <a:t>3 · Alpaca infrastructure</a:t>
+            </a:r>
+            <a:endParaRPr lang="en-US" sz="1500" dirty="0"/>
+          </a:p>
+        </p:txBody>
+      </p:sp>
+      <p:sp>
+        <p:nvSpPr>
+          <p:cNvPr id="15" name="Text 13"/>
+          <p:cNvSpPr txBox="1"/>
+          <p:nvPr/>
+        </p:nvSpPr>
+        <p:spPr>
+          <a:xfrm>
+            <a:off x="8357616" y="2962656"/>
+            <a:ext cx="3026664" cy="2953512"/>
+          </a:xfrm>
+          <a:prstGeom prst="rect">
+            <a:avLst/>
+          </a:prstGeom>
+          <a:noFill/>
+          <a:ln/>
+        </p:spPr>
+        <p:txBody>
+          <a:bodyPr wrap="square" lIns="0" tIns="0" rIns="0" bIns="0" rtlCol="0" anchor="t"/>
+          <a:lstStyle/>
+          <a:p>
+            <a:pPr marL="342900" indent="-342900">
+              <a:lnSpc>
+                <a:spcPct val="114000"/>
+              </a:lnSpc>
+              <a:spcAft>
+                <a:spcPts val="400"/>
+              </a:spcAft>
+              <a:buSzPct val="100000"/>
+              <a:buChar char="•"/>
+            </a:pPr>
+            <a:r>
+              <a:rPr lang="en-US" sz="950" dirty="0">
+                <a:solidFill>
+                  <a:srgbClr val="A1A8B5"/>
+                </a:solidFill>
+                <a:latin typeface="Arial" pitchFamily="34" charset="0"/>
+                <a:ea typeface="Arial" pitchFamily="34" charset="-122"/>
+                <a:cs typeface="Arial" pitchFamily="34" charset="-120"/>
+              </a:rPr>
+              <a:t>Every order through the Alpaca CLI, not the SDK: `alpaca order submit`, then poll to a terminal state.</a:t>
+            </a:r>
+            <a:endParaRPr lang="en-US" sz="950" dirty="0"/>
+          </a:p>
+          <a:p>
+            <a:pPr marL="342900" indent="-342900">
+              <a:lnSpc>
+                <a:spcPct val="114000"/>
+              </a:lnSpc>
+              <a:spcAft>
+                <a:spcPts val="400"/>
+              </a:spcAft>
+              <a:buSzPct val="100000"/>
+              <a:buChar char="•"/>
+            </a:pPr>
+            <a:r>
+              <a:rPr lang="en-US" sz="950" dirty="0">
+                <a:solidFill>
+                  <a:srgbClr val="A1A8B5"/>
+                </a:solidFill>
+                <a:latin typeface="Arial" pitchFamily="34" charset="0"/>
+                <a:ea typeface="Arial" pitchFamily="34" charset="-122"/>
+                <a:cs typeface="Arial" pitchFamily="34" charset="-120"/>
+              </a:rPr>
+              <a:t>So the agent books the real broker fill, not a quote - cash P&amp;L is buy-fill against sell-fill.</a:t>
+            </a:r>
+            <a:endParaRPr lang="en-US" sz="950" dirty="0"/>
+          </a:p>
+          <a:p>
+            <a:pPr marL="342900" indent="-342900">
+              <a:lnSpc>
+                <a:spcPct val="114000"/>
+              </a:lnSpc>
+              <a:spcAft>
+                <a:spcPts val="400"/>
+              </a:spcAft>
+              <a:buSzPct val="100000"/>
+              <a:buChar char="•"/>
+            </a:pPr>
+            <a:r>
+              <a:rPr lang="en-US" sz="950" dirty="0">
+                <a:solidFill>
+                  <a:srgbClr val="A1A8B5"/>
+                </a:solidFill>
+                <a:latin typeface="Arial" pitchFamily="34" charset="0"/>
+                <a:ea typeface="Arial" pitchFamily="34" charset="-122"/>
+                <a:cs typeface="Arial" pitchFamily="34" charset="-120"/>
+              </a:rPr>
+              <a:t>Refuses to place anything unless `alpaca doctor` resolves paper-api.alpaca.markets.</a:t>
+            </a:r>
+            <a:endParaRPr lang="en-US" sz="950" dirty="0"/>
+          </a:p>
+          <a:p>
+            <a:pPr marL="342900" indent="-342900">
+              <a:lnSpc>
+                <a:spcPct val="114000"/>
+              </a:lnSpc>
+              <a:spcAft>
+                <a:spcPts val="400"/>
+              </a:spcAft>
+              <a:buSzPct val="100000"/>
+              <a:buChar char="•"/>
+            </a:pPr>
+            <a:r>
+              <a:rPr lang="en-US" sz="950" dirty="0">
+                <a:solidFill>
+                  <a:srgbClr val="A1A8B5"/>
+                </a:solidFill>
+                <a:latin typeface="Arial" pitchFamily="34" charset="0"/>
+                <a:ea typeface="Arial" pitchFamily="34" charset="-122"/>
+                <a:cs typeface="Arial" pitchFamily="34" charset="-120"/>
+              </a:rPr>
+              <a:t>An ambiguous submit is reconciled by --client-order-id before it will ever resubmit.</a:t>
+            </a:r>
+            <a:endParaRPr lang="en-US" sz="950" dirty="0"/>
+          </a:p>
+          <a:p>
+            <a:pPr marL="342900" indent="-342900">
+              <a:lnSpc>
+                <a:spcPct val="114000"/>
+              </a:lnSpc>
+              <a:spcAft>
+                <a:spcPts val="400"/>
+              </a:spcAft>
+              <a:buSzPct val="100000"/>
+              <a:buChar char="•"/>
+            </a:pPr>
+            <a:r>
+              <a:rPr lang="en-US" sz="950" dirty="0">
+                <a:solidFill>
+                  <a:srgbClr val="A1A8B5"/>
+                </a:solidFill>
+                <a:latin typeface="Arial" pitchFamily="34" charset="0"/>
+                <a:ea typeface="Arial" pitchFamily="34" charset="-122"/>
+                <a:cs typeface="Arial" pitchFamily="34" charset="-120"/>
+              </a:rPr>
+              <a:t>Market data - bars, contract discovery, ATM quotes - via the Alpaca Market Data API.</a:t>
+            </a:r>
+            <a:endParaRPr lang="en-US" sz="950" dirty="0"/>
+          </a:p>
+          <a:p>
+            <a:pPr marL="342900" indent="-342900">
+              <a:lnSpc>
+                <a:spcPct val="114000"/>
+              </a:lnSpc>
+              <a:spcAft>
+                <a:spcPts val="400"/>
+              </a:spcAft>
+              <a:buSzPct val="100000"/>
+              <a:buChar char="•"/>
+            </a:pPr>
+            <a:r>
+              <a:rPr lang="en-US" sz="950" dirty="0">
+                <a:solidFill>
+                  <a:srgbClr val="A1A8B5"/>
+                </a:solidFill>
+                <a:latin typeface="Arial" pitchFamily="34" charset="0"/>
+                <a:ea typeface="Arial" pitchFamily="34" charset="-122"/>
+                <a:cs typeface="Arial" pitchFamily="34" charset="-120"/>
+              </a:rPr>
+              <a:t>Runs unattended in an isolated Docker container, one session per weekday.</a:t>
+            </a:r>
+            <a:endParaRPr lang="en-US" sz="950" dirty="0"/>
+          </a:p>
+          <a:p>
+            <a:pPr marL="342900" indent="-342900">
+              <a:lnSpc>
+                <a:spcPct val="114000"/>
+              </a:lnSpc>
+              <a:spcAft>
+                <a:spcPts val="400"/>
+              </a:spcAft>
+              <a:buSzPct val="100000"/>
+              <a:buChar char="•"/>
+            </a:pPr>
+            <a:r>
+              <a:rPr lang="en-US" sz="950" dirty="0">
+                <a:solidFill>
+                  <a:srgbClr val="A1A8B5"/>
+                </a:solidFill>
+                <a:latin typeface="Arial" pitchFamily="34" charset="0"/>
+                <a:ea typeface="Arial" pitchFamily="34" charset="-122"/>
+                <a:cs typeface="Arial" pitchFamily="34" charset="-120"/>
+              </a:rPr>
+              <a:t>Every scan appends one JSONL record with the full reasoning to logs/.</a:t>
+            </a:r>
+            <a:endParaRPr lang="en-US" sz="950" dirty="0"/>
+          </a:p>
+        </p:txBody>
+      </p:sp>
+    </p:spTree>
+  </p:cSld>
+  <p:clrMapOvr>
+    <a:masterClrMapping/>
+  </p:clrMapOvr>
+</p:sld>
+</file>
+
 <file path=ppt/theme/theme1.xml><?xml version="1.0" encoding="utf-8"?>
 <a:theme xmlns:a="http://schemas.openxmlformats.org/drawingml/2006/main" name="Office Theme">
   <a:themeElements>

</xml_diff>

<commit_message>
Deck: plainer CLI slide, drop the close slide, drop "required"
Slide 6 now says what the CLI does in ordinary words instead of
implementation jargon ("idempotent submits" -> "never a duplicate
order"), and the line quoting the hackathon requirement is gone.

The close slide is removed; the deck ends on the write-up. Its
paper-trading disclaimer moves onto that slide so the deck still
carries one.

The write-up slide is now titled "One-page write-up". README,
docs/VIDEO.md and build_all.sh follow the new 8-slide numbering, and
the video's close beat returns to slide 1 rather than the slide that
no longer exists.

Co-Authored-By: Claude Opus 5 <noreply@anthropic.com>
</commit_message>
<xml_diff>
--- a/assets/deck.pptx
+++ b/assets/deck.pptx
@@ -13,10 +13,9 @@
     <p:sldId id="261" r:id="rId7"/>
     <p:sldId id="262" r:id="rId8"/>
     <p:sldId id="263" r:id="rId9"/>
-    <p:sldId id="264" r:id="rId10"/>
   </p:sldIdLst>
   <p:notesMasterIdLst>
-    <p:notesMasterId r:id="rId11"/>
+    <p:notesMasterId r:id="rId10"/>
   </p:notesMasterIdLst>
   <p:sldSz cx="12192000" cy="6858000"/>
   <p:notesSz cx="6858000" cy="12192000"/>
@@ -1221,7 +1220,7 @@
           <a:p>
             <a:r>
               <a:rPr lang="en-US" dirty="0"/>
-              <a:t>The CLI is not a box-tick. It is why the P&amp;L two slides back is broker truth rather than a mid-price model.</a:t>
+              <a:t>The CLI is why the profit and loss two slides back is the real fill price from the broker, rather than a number the agent worked out itself.</a:t>
             </a:r>
             <a:endParaRPr lang="en-US" dirty="0"/>
           </a:p>
@@ -1397,7 +1396,7 @@
           <a:p>
             <a:r>
               <a:rPr lang="en-US" dirty="0"/>
-              <a:t>Close on the four claims. Each one is checkable in the repo.</a:t>
+              <a:t>This slide is the one-page write-up. The same content ships as docs/ONE_PAGER.md and docs/ONE_PAGER.pdf in the repo.</a:t>
             </a:r>
             <a:endParaRPr lang="en-US" dirty="0"/>
           </a:p>
@@ -1421,94 +1420,6 @@
             <a:fld id="{F7021451-1387-4CA6-816F-3879F97B5CBC}" type="slidenum">
               <a:rPr lang="en-US"/>
               <a:t>8</a:t>
-            </a:fld>
-            <a:endParaRPr lang="en-US"/>
-          </a:p>
-        </p:txBody>
-      </p:sp>
-    </p:spTree>
-    <p:extLst>
-      <p:ext uri="{BB962C8B-B14F-4D97-AF65-F5344CB8AC3E}">
-        <p14:creationId xmlns:p14="http://schemas.microsoft.com/office/powerpoint/2010/main" val="1024086991"/>
-      </p:ext>
-    </p:extLst>
-  </p:cSld>
-  <p:clrMapOvr>
-    <a:masterClrMapping/>
-  </p:clrMapOvr>
-</p:notes>
-</file>
-
-<file path=ppt/notesSlides/notesSlide9.xml><?xml version="1.0" encoding="utf-8"?>
-<p:notes xmlns:a="http://schemas.openxmlformats.org/drawingml/2006/main" xmlns:r="http://schemas.openxmlformats.org/officeDocument/2006/relationships" xmlns:p="http://schemas.openxmlformats.org/presentationml/2006/main">
-  <p:cSld>
-    <p:spTree>
-      <p:nvGrpSpPr>
-        <p:cNvPr id="1" name=""/>
-        <p:cNvGrpSpPr/>
-        <p:nvPr/>
-      </p:nvGrpSpPr>
-      <p:grpSpPr>
-        <a:xfrm>
-          <a:off x="0" y="0"/>
-          <a:ext cx="0" cy="0"/>
-          <a:chOff x="0" y="0"/>
-          <a:chExt cx="0" cy="0"/>
-        </a:xfrm>
-      </p:grpSpPr>
-      <p:sp>
-        <p:nvSpPr>
-          <p:cNvPr id="2" name="Slide Image Placeholder 1"/>
-          <p:cNvSpPr>
-            <a:spLocks noGrp="1" noRot="1" noChangeAspect="1"/>
-          </p:cNvSpPr>
-          <p:nvPr>
-            <p:ph type="sldImg"/>
-          </p:nvPr>
-        </p:nvSpPr>
-        <p:spPr/>
-      </p:sp>
-      <p:sp>
-        <p:nvSpPr>
-          <p:cNvPr id="3" name="Notes Placeholder 2"/>
-          <p:cNvSpPr>
-            <a:spLocks noGrp="1"/>
-          </p:cNvSpPr>
-          <p:nvPr>
-            <p:ph type="body" idx="1"/>
-          </p:nvPr>
-        </p:nvSpPr>
-        <p:spPr/>
-        <p:txBody>
-          <a:bodyPr/>
-          <a:lstStyle/>
-          <a:p>
-            <a:r>
-              <a:rPr lang="en-US" dirty="0"/>
-              <a:t>This slide is the hackathon's required one-page write-up. The same content ships as docs/ONE_PAGER.md and docs/ONE_PAGER.pdf in the repo.</a:t>
-            </a:r>
-            <a:endParaRPr lang="en-US" dirty="0"/>
-          </a:p>
-        </p:txBody>
-      </p:sp>
-      <p:sp>
-        <p:nvSpPr>
-          <p:cNvPr id="4" name="Slide Number Placeholder 3"/>
-          <p:cNvSpPr>
-            <a:spLocks noGrp="1"/>
-          </p:cNvSpPr>
-          <p:nvPr>
-            <p:ph type="sldNum" sz="quarter" idx="10"/>
-          </p:nvPr>
-        </p:nvSpPr>
-        <p:spPr/>
-        <p:txBody>
-          <a:bodyPr/>
-          <a:lstStyle/>
-          <a:p>
-            <a:fld id="{F7021451-1387-4CA6-816F-3879F97B5CBC}" type="slidenum">
-              <a:rPr lang="en-US"/>
-              <a:t>9</a:t>
             </a:fld>
             <a:endParaRPr lang="en-US"/>
           </a:p>
@@ -7087,7 +6998,7 @@
                 <a:ea typeface="Arial" pitchFamily="34" charset="-122"/>
                 <a:cs typeface="Arial" pitchFamily="34" charset="-120"/>
               </a:rPr>
-              <a:t>Built on Alpaca's CLI, not just the SDK</a:t>
+              <a:t>Every order goes through the Alpaca CLI</a:t>
             </a:r>
             <a:endParaRPr lang="en-US" sz="3400" dirty="0"/>
           </a:p>
@@ -7153,7 +7064,7 @@
                 <a:ea typeface="Courier New" pitchFamily="34" charset="-122"/>
                 <a:cs typeface="Courier New" pitchFamily="34" charset="-120"/>
               </a:rPr>
-              <a:t>ORDERS VIA THE ALPACA CLI</a:t>
+              <a:t>ORDERS PLACED THROUGH THE CLI</a:t>
             </a:r>
             <a:endParaRPr lang="en-US" sz="1000" dirty="0"/>
           </a:p>
@@ -7195,7 +7106,7 @@
                 <a:ea typeface="Arial" pitchFamily="34" charset="-122"/>
                 <a:cs typeface="Arial" pitchFamily="34" charset="-120"/>
               </a:rPr>
-              <a:t>alpaca order submit, then poll to a terminal state. The agent books the real broker fill, not a quote - so cash P&amp;L is buy-fill against sell-fill.</a:t>
+              <a:t>The agent runs `alpaca order submit` and waits for the order to fill. It records the price it actually got, so the profit and loss is real money in and out - not an estimate from a quote.</a:t>
             </a:r>
             <a:endParaRPr lang="en-US" sz="1200" dirty="0"/>
           </a:p>
@@ -7261,7 +7172,7 @@
                 <a:ea typeface="Courier New" pitchFamily="34" charset="-122"/>
                 <a:cs typeface="Courier New" pitchFamily="34" charset="-120"/>
               </a:rPr>
-              <a:t>PAPER ENDPOINT, PROVEN</a:t>
+              <a:t>PAPER ACCOUNT, CHECKED EVERY TIME</a:t>
             </a:r>
             <a:endParaRPr lang="en-US" sz="1000" dirty="0"/>
           </a:p>
@@ -7303,7 +7214,7 @@
                 <a:ea typeface="Arial" pitchFamily="34" charset="-122"/>
                 <a:cs typeface="Arial" pitchFamily="34" charset="-120"/>
               </a:rPr>
-              <a:t>Refuses to place anything unless `alpaca doctor` resolves paper-api.alpaca.markets. The env var alone isn't proof - a profile's live_trade can route live.</a:t>
+              <a:t>Before it places anything, the agent confirms `alpaca doctor` is pointing at the paper endpoint. If it is not, the agent does not trade.</a:t>
             </a:r>
             <a:endParaRPr lang="en-US" sz="1200" dirty="0"/>
           </a:p>
@@ -7369,7 +7280,7 @@
                 <a:ea typeface="Courier New" pitchFamily="34" charset="-122"/>
                 <a:cs typeface="Courier New" pitchFamily="34" charset="-120"/>
               </a:rPr>
-              <a:t>IDEMPOTENT SUBMITS</a:t>
+              <a:t>NEVER A DUPLICATE ORDER</a:t>
             </a:r>
             <a:endParaRPr lang="en-US" sz="1000" dirty="0"/>
           </a:p>
@@ -7411,7 +7322,7 @@
                 <a:ea typeface="Arial" pitchFamily="34" charset="-122"/>
                 <a:cs typeface="Arial" pitchFamily="34" charset="-120"/>
               </a:rPr>
-              <a:t>On an ambiguous failure it reconciles by --client-order-id via `alpaca order get-by-client-id` before ever resubmitting. No duplicate, no orphan.</a:t>
+              <a:t>If a submit times out, the agent looks the order up by its own ID before trying again. The result is one order, or none - never two.</a:t>
             </a:r>
             <a:endParaRPr lang="en-US" sz="1200" dirty="0"/>
           </a:p>
@@ -7477,7 +7388,7 @@
                 <a:ea typeface="Courier New" pitchFamily="34" charset="-122"/>
                 <a:cs typeface="Courier New" pitchFamily="34" charset="-120"/>
               </a:rPr>
-              <a:t>UNATTENDED AND AUDITABLE</a:t>
+              <a:t>RUNS ON ITS OWN, AND LOGS IT</a:t>
             </a:r>
             <a:endParaRPr lang="en-US" sz="1000" dirty="0"/>
           </a:p>
@@ -7519,48 +7430,9 @@
                 <a:ea typeface="Arial" pitchFamily="34" charset="-122"/>
                 <a:cs typeface="Arial" pitchFamily="34" charset="-120"/>
               </a:rPr>
-              <a:t>Market data (5m bars, contract discovery, ATM quotes) via the Alpaca SDK. Isolated Docker container, one session per weekday, JSONL journal per scan.</a:t>
+              <a:t>Prices and contracts come from Alpaca's market data API. It runs in its own container, once each weekday, and writes a log line for every decision.</a:t>
             </a:r>
             <a:endParaRPr lang="en-US" sz="1200" dirty="0"/>
-          </a:p>
-        </p:txBody>
-      </p:sp>
-      <p:sp>
-        <p:nvSpPr>
-          <p:cNvPr id="17" name="Text 15"/>
-          <p:cNvSpPr txBox="1"/>
-          <p:nvPr/>
-        </p:nvSpPr>
-        <p:spPr>
-          <a:xfrm>
-            <a:off x="548640" y="5806440"/>
-            <a:ext cx="11091672" cy="365760"/>
-          </a:xfrm>
-          <a:prstGeom prst="rect">
-            <a:avLst/>
-          </a:prstGeom>
-          <a:noFill/>
-          <a:ln/>
-        </p:spPr>
-        <p:txBody>
-          <a:bodyPr wrap="square" lIns="0" tIns="0" rIns="0" bIns="0" rtlCol="0" anchor="ctr"/>
-          <a:lstStyle/>
-          <a:p>
-            <a:pPr indent="0" marL="0">
-              <a:buNone/>
-            </a:pPr>
-            <a:r>
-              <a:rPr lang="en-US" sz="1100" dirty="0">
-                <a:solidFill>
-                  <a:srgbClr val="F0B429"/>
-                </a:solidFill>
-                <a:latin typeface="Courier New" pitchFamily="34" charset="0"/>
-                <a:ea typeface="Courier New" pitchFamily="34" charset="-122"/>
-                <a:cs typeface="Courier New" pitchFamily="34" charset="-120"/>
-              </a:rPr>
-              <a:t>Requirement: projects must use Alpaca's MCP server or its CLI tools.   —   every order in the book above went through the CLI.</a:t>
-            </a:r>
-            <a:endParaRPr lang="en-US" sz="1100" dirty="0"/>
           </a:p>
         </p:txBody>
       </p:sp>
@@ -8378,586 +8250,7 @@
                 <a:ea typeface="Courier New" pitchFamily="34" charset="-122"/>
                 <a:cs typeface="Courier New" pitchFamily="34" charset="-120"/>
               </a:rPr>
-              <a:t>Every trade provable. Every loss capped.</a:t>
-            </a:r>
-            <a:endParaRPr lang="en-US" sz="1100" dirty="0"/>
-          </a:p>
-        </p:txBody>
-      </p:sp>
-      <p:sp>
-        <p:nvSpPr>
-          <p:cNvPr id="3" name="Text 1"/>
-          <p:cNvSpPr txBox="1"/>
-          <p:nvPr/>
-        </p:nvSpPr>
-        <p:spPr>
-          <a:xfrm>
-            <a:off x="5852160" y="6263640"/>
-            <a:ext cx="5788152" cy="274320"/>
-          </a:xfrm>
-          <a:prstGeom prst="rect">
-            <a:avLst/>
-          </a:prstGeom>
-          <a:noFill/>
-          <a:ln/>
-        </p:spPr>
-        <p:txBody>
-          <a:bodyPr wrap="square" rtlCol="0" anchor="ctr"/>
-          <a:lstStyle/>
-          <a:p>
-            <a:pPr algn="r" indent="0" marL="0">
-              <a:buNone/>
-            </a:pPr>
-            <a:r>
-              <a:rPr lang="en-US" sz="900" dirty="0">
-                <a:solidFill>
-                  <a:srgbClr val="6B7686"/>
-                </a:solidFill>
-                <a:latin typeface="Courier New" pitchFamily="34" charset="0"/>
-                <a:ea typeface="Courier New" pitchFamily="34" charset="-122"/>
-                <a:cs typeface="Courier New" pitchFamily="34" charset="-120"/>
-              </a:rPr>
-              <a:t>every-trade-provable.streamlit.app  ·  github.com/KIBA0993/Alpaca-Hackathon</a:t>
-            </a:r>
-            <a:endParaRPr lang="en-US" sz="900" dirty="0"/>
-          </a:p>
-        </p:txBody>
-      </p:sp>
-      <p:sp>
-        <p:nvSpPr>
-          <p:cNvPr id="4" name="Text 2"/>
-          <p:cNvSpPr txBox="1"/>
-          <p:nvPr/>
-        </p:nvSpPr>
-        <p:spPr>
-          <a:xfrm>
-            <a:off x="548640" y="1371600"/>
-            <a:ext cx="11064240" cy="1737360"/>
-          </a:xfrm>
-          <a:prstGeom prst="rect">
-            <a:avLst/>
-          </a:prstGeom>
-          <a:noFill/>
-          <a:ln/>
-        </p:spPr>
-        <p:txBody>
-          <a:bodyPr wrap="square" lIns="0" tIns="0" rIns="0" bIns="0" rtlCol="0" anchor="ctr"/>
-          <a:lstStyle/>
-          <a:p>
-            <a:pPr indent="0" marL="0">
-              <a:lnSpc>
-                <a:spcPct val="105000"/>
-              </a:lnSpc>
-              <a:buNone/>
-            </a:pPr>
-            <a:r>
-              <a:rPr lang="en-US" sz="4600" b="1" dirty="0">
-                <a:solidFill>
-                  <a:srgbClr val="FFFFFF"/>
-                </a:solidFill>
-                <a:latin typeface="Arial" pitchFamily="34" charset="0"/>
-                <a:ea typeface="Arial" pitchFamily="34" charset="-122"/>
-                <a:cs typeface="Arial" pitchFamily="34" charset="-120"/>
-              </a:rPr>
-              <a:t>A fresh $100,000 account,</a:t>
-            </a:r>
-            <a:endParaRPr lang="en-US" sz="4600" dirty="0"/>
-          </a:p>
-          <a:p>
-            <a:pPr indent="0" marL="0">
-              <a:lnSpc>
-                <a:spcPct val="105000"/>
-              </a:lnSpc>
-              <a:buNone/>
-            </a:pPr>
-            <a:r>
-              <a:rPr lang="en-US" sz="4600" b="1" dirty="0">
-                <a:solidFill>
-                  <a:srgbClr val="F0B429"/>
-                </a:solidFill>
-                <a:latin typeface="Arial" pitchFamily="34" charset="0"/>
-                <a:ea typeface="Arial" pitchFamily="34" charset="-122"/>
-                <a:cs typeface="Arial" pitchFamily="34" charset="-120"/>
-              </a:rPr>
-              <a:t>3 sessions, +79.1%.</a:t>
-            </a:r>
-            <a:endParaRPr lang="en-US" sz="4600" dirty="0"/>
-          </a:p>
-        </p:txBody>
-      </p:sp>
-      <p:sp>
-        <p:nvSpPr>
-          <p:cNvPr id="5" name="Text 3"/>
-          <p:cNvSpPr txBox="1"/>
-          <p:nvPr/>
-        </p:nvSpPr>
-        <p:spPr>
-          <a:xfrm>
-            <a:off x="548640" y="3429000"/>
-            <a:ext cx="320040" cy="365760"/>
-          </a:xfrm>
-          <a:prstGeom prst="rect">
-            <a:avLst/>
-          </a:prstGeom>
-          <a:noFill/>
-          <a:ln/>
-        </p:spPr>
-        <p:txBody>
-          <a:bodyPr wrap="square" lIns="0" tIns="0" rIns="0" bIns="0" rtlCol="0" anchor="ctr"/>
-          <a:lstStyle/>
-          <a:p>
-            <a:pPr indent="0" marL="0">
-              <a:buNone/>
-            </a:pPr>
-            <a:r>
-              <a:rPr lang="en-US" sz="1500" dirty="0">
-                <a:solidFill>
-                  <a:srgbClr val="F0B429"/>
-                </a:solidFill>
-                <a:latin typeface="Arial" pitchFamily="34" charset="0"/>
-                <a:ea typeface="Arial" pitchFamily="34" charset="-122"/>
-                <a:cs typeface="Arial" pitchFamily="34" charset="-120"/>
-              </a:rPr>
-              <a:t>—</a:t>
-            </a:r>
-            <a:endParaRPr lang="en-US" sz="1500" dirty="0"/>
-          </a:p>
-        </p:txBody>
-      </p:sp>
-      <p:sp>
-        <p:nvSpPr>
-          <p:cNvPr id="6" name="Text 4"/>
-          <p:cNvSpPr txBox="1"/>
-          <p:nvPr/>
-        </p:nvSpPr>
-        <p:spPr>
-          <a:xfrm>
-            <a:off x="914400" y="3429000"/>
-            <a:ext cx="10698480" cy="365760"/>
-          </a:xfrm>
-          <a:prstGeom prst="rect">
-            <a:avLst/>
-          </a:prstGeom>
-          <a:noFill/>
-          <a:ln/>
-        </p:spPr>
-        <p:txBody>
-          <a:bodyPr wrap="square" lIns="0" tIns="0" rIns="0" bIns="0" rtlCol="0" anchor="ctr"/>
-          <a:lstStyle/>
-          <a:p>
-            <a:pPr indent="0" marL="0">
-              <a:buNone/>
-            </a:pPr>
-            <a:r>
-              <a:rPr lang="en-US" sz="1500" b="1" dirty="0">
-                <a:solidFill>
-                  <a:srgbClr val="FFFFFF"/>
-                </a:solidFill>
-                <a:latin typeface="Arial" pitchFamily="34" charset="0"/>
-                <a:ea typeface="Arial" pitchFamily="34" charset="-122"/>
-                <a:cs typeface="Arial" pitchFamily="34" charset="-120"/>
-              </a:rPr>
-              <a:t>Max loss capped by the instrument</a:t>
-            </a:r>
-            <a:pPr indent="0" marL="0">
-              <a:buNone/>
-            </a:pPr>
-            <a:r>
-              <a:rPr lang="en-US" sz="1500" dirty="0">
-                <a:solidFill>
-                  <a:srgbClr val="A1A8B5"/>
-                </a:solidFill>
-                <a:latin typeface="Arial" pitchFamily="34" charset="0"/>
-                <a:ea typeface="Arial" pitchFamily="34" charset="-122"/>
-                <a:cs typeface="Arial" pitchFamily="34" charset="-120"/>
-              </a:rPr>
-              <a:t>   not by code that has to remember</a:t>
-            </a:r>
-            <a:endParaRPr lang="en-US" sz="1500" dirty="0"/>
-          </a:p>
-        </p:txBody>
-      </p:sp>
-      <p:sp>
-        <p:nvSpPr>
-          <p:cNvPr id="7" name="Text 5"/>
-          <p:cNvSpPr txBox="1"/>
-          <p:nvPr/>
-        </p:nvSpPr>
-        <p:spPr>
-          <a:xfrm>
-            <a:off x="548640" y="4032504"/>
-            <a:ext cx="320040" cy="365760"/>
-          </a:xfrm>
-          <a:prstGeom prst="rect">
-            <a:avLst/>
-          </a:prstGeom>
-          <a:noFill/>
-          <a:ln/>
-        </p:spPr>
-        <p:txBody>
-          <a:bodyPr wrap="square" lIns="0" tIns="0" rIns="0" bIns="0" rtlCol="0" anchor="ctr"/>
-          <a:lstStyle/>
-          <a:p>
-            <a:pPr indent="0" marL="0">
-              <a:buNone/>
-            </a:pPr>
-            <a:r>
-              <a:rPr lang="en-US" sz="1500" dirty="0">
-                <a:solidFill>
-                  <a:srgbClr val="F0B429"/>
-                </a:solidFill>
-                <a:latin typeface="Arial" pitchFamily="34" charset="0"/>
-                <a:ea typeface="Arial" pitchFamily="34" charset="-122"/>
-                <a:cs typeface="Arial" pitchFamily="34" charset="-120"/>
-              </a:rPr>
-              <a:t>—</a:t>
-            </a:r>
-            <a:endParaRPr lang="en-US" sz="1500" dirty="0"/>
-          </a:p>
-        </p:txBody>
-      </p:sp>
-      <p:sp>
-        <p:nvSpPr>
-          <p:cNvPr id="8" name="Text 6"/>
-          <p:cNvSpPr txBox="1"/>
-          <p:nvPr/>
-        </p:nvSpPr>
-        <p:spPr>
-          <a:xfrm>
-            <a:off x="914400" y="4032504"/>
-            <a:ext cx="10698480" cy="365760"/>
-          </a:xfrm>
-          <a:prstGeom prst="rect">
-            <a:avLst/>
-          </a:prstGeom>
-          <a:noFill/>
-          <a:ln/>
-        </p:spPr>
-        <p:txBody>
-          <a:bodyPr wrap="square" lIns="0" tIns="0" rIns="0" bIns="0" rtlCol="0" anchor="ctr"/>
-          <a:lstStyle/>
-          <a:p>
-            <a:pPr indent="0" marL="0">
-              <a:buNone/>
-            </a:pPr>
-            <a:r>
-              <a:rPr lang="en-US" sz="1500" b="1" dirty="0">
-                <a:solidFill>
-                  <a:srgbClr val="FFFFFF"/>
-                </a:solidFill>
-                <a:latin typeface="Arial" pitchFamily="34" charset="0"/>
-                <a:ea typeface="Arial" pitchFamily="34" charset="-122"/>
-                <a:cs typeface="Arial" pitchFamily="34" charset="-120"/>
-              </a:rPr>
-              <a:t>An AI that can only remove risk</a:t>
-            </a:r>
-            <a:pPr indent="0" marL="0">
-              <a:buNone/>
-            </a:pPr>
-            <a:r>
-              <a:rPr lang="en-US" sz="1500" dirty="0">
-                <a:solidFill>
-                  <a:srgbClr val="A1A8B5"/>
-                </a:solidFill>
-                <a:latin typeface="Arial" pitchFamily="34" charset="0"/>
-                <a:ea typeface="Arial" pitchFamily="34" charset="-122"/>
-                <a:cs typeface="Arial" pitchFamily="34" charset="-120"/>
-              </a:rPr>
-              <a:t>   structurally unable to add a trade</a:t>
-            </a:r>
-            <a:endParaRPr lang="en-US" sz="1500" dirty="0"/>
-          </a:p>
-        </p:txBody>
-      </p:sp>
-      <p:sp>
-        <p:nvSpPr>
-          <p:cNvPr id="9" name="Text 7"/>
-          <p:cNvSpPr txBox="1"/>
-          <p:nvPr/>
-        </p:nvSpPr>
-        <p:spPr>
-          <a:xfrm>
-            <a:off x="548640" y="4636008"/>
-            <a:ext cx="320040" cy="365760"/>
-          </a:xfrm>
-          <a:prstGeom prst="rect">
-            <a:avLst/>
-          </a:prstGeom>
-          <a:noFill/>
-          <a:ln/>
-        </p:spPr>
-        <p:txBody>
-          <a:bodyPr wrap="square" lIns="0" tIns="0" rIns="0" bIns="0" rtlCol="0" anchor="ctr"/>
-          <a:lstStyle/>
-          <a:p>
-            <a:pPr indent="0" marL="0">
-              <a:buNone/>
-            </a:pPr>
-            <a:r>
-              <a:rPr lang="en-US" sz="1500" dirty="0">
-                <a:solidFill>
-                  <a:srgbClr val="F0B429"/>
-                </a:solidFill>
-                <a:latin typeface="Arial" pitchFamily="34" charset="0"/>
-                <a:ea typeface="Arial" pitchFamily="34" charset="-122"/>
-                <a:cs typeface="Arial" pitchFamily="34" charset="-120"/>
-              </a:rPr>
-              <a:t>—</a:t>
-            </a:r>
-            <a:endParaRPr lang="en-US" sz="1500" dirty="0"/>
-          </a:p>
-        </p:txBody>
-      </p:sp>
-      <p:sp>
-        <p:nvSpPr>
-          <p:cNvPr id="10" name="Text 8"/>
-          <p:cNvSpPr txBox="1"/>
-          <p:nvPr/>
-        </p:nvSpPr>
-        <p:spPr>
-          <a:xfrm>
-            <a:off x="914400" y="4636008"/>
-            <a:ext cx="10698480" cy="365760"/>
-          </a:xfrm>
-          <a:prstGeom prst="rect">
-            <a:avLst/>
-          </a:prstGeom>
-          <a:noFill/>
-          <a:ln/>
-        </p:spPr>
-        <p:txBody>
-          <a:bodyPr wrap="square" lIns="0" tIns="0" rIns="0" bIns="0" rtlCol="0" anchor="ctr"/>
-          <a:lstStyle/>
-          <a:p>
-            <a:pPr indent="0" marL="0">
-              <a:buNone/>
-            </a:pPr>
-            <a:r>
-              <a:rPr lang="en-US" sz="1500" b="1" dirty="0">
-                <a:solidFill>
-                  <a:srgbClr val="FFFFFF"/>
-                </a:solidFill>
-                <a:latin typeface="Arial" pitchFamily="34" charset="0"/>
-                <a:ea typeface="Arial" pitchFamily="34" charset="-122"/>
-                <a:cs typeface="Arial" pitchFamily="34" charset="-120"/>
-              </a:rPr>
-              <a:t>Every order through the Alpaca CLI</a:t>
-            </a:r>
-            <a:pPr indent="0" marL="0">
-              <a:buNone/>
-            </a:pPr>
-            <a:r>
-              <a:rPr lang="en-US" sz="1500" dirty="0">
-                <a:solidFill>
-                  <a:srgbClr val="A1A8B5"/>
-                </a:solidFill>
-                <a:latin typeface="Arial" pitchFamily="34" charset="0"/>
-                <a:ea typeface="Arial" pitchFamily="34" charset="-122"/>
-                <a:cs typeface="Arial" pitchFamily="34" charset="-120"/>
-              </a:rPr>
-              <a:t>   P&amp;L is the real broker fill, not a quote</a:t>
-            </a:r>
-            <a:endParaRPr lang="en-US" sz="1500" dirty="0"/>
-          </a:p>
-        </p:txBody>
-      </p:sp>
-      <p:sp>
-        <p:nvSpPr>
-          <p:cNvPr id="11" name="Text 9"/>
-          <p:cNvSpPr txBox="1"/>
-          <p:nvPr/>
-        </p:nvSpPr>
-        <p:spPr>
-          <a:xfrm>
-            <a:off x="548640" y="5239512"/>
-            <a:ext cx="320040" cy="365760"/>
-          </a:xfrm>
-          <a:prstGeom prst="rect">
-            <a:avLst/>
-          </a:prstGeom>
-          <a:noFill/>
-          <a:ln/>
-        </p:spPr>
-        <p:txBody>
-          <a:bodyPr wrap="square" lIns="0" tIns="0" rIns="0" bIns="0" rtlCol="0" anchor="ctr"/>
-          <a:lstStyle/>
-          <a:p>
-            <a:pPr indent="0" marL="0">
-              <a:buNone/>
-            </a:pPr>
-            <a:r>
-              <a:rPr lang="en-US" sz="1500" dirty="0">
-                <a:solidFill>
-                  <a:srgbClr val="F0B429"/>
-                </a:solidFill>
-                <a:latin typeface="Arial" pitchFamily="34" charset="0"/>
-                <a:ea typeface="Arial" pitchFamily="34" charset="-122"/>
-                <a:cs typeface="Arial" pitchFamily="34" charset="-120"/>
-              </a:rPr>
-              <a:t>—</a:t>
-            </a:r>
-            <a:endParaRPr lang="en-US" sz="1500" dirty="0"/>
-          </a:p>
-        </p:txBody>
-      </p:sp>
-      <p:sp>
-        <p:nvSpPr>
-          <p:cNvPr id="12" name="Text 10"/>
-          <p:cNvSpPr txBox="1"/>
-          <p:nvPr/>
-        </p:nvSpPr>
-        <p:spPr>
-          <a:xfrm>
-            <a:off x="914400" y="5239512"/>
-            <a:ext cx="10698480" cy="365760"/>
-          </a:xfrm>
-          <a:prstGeom prst="rect">
-            <a:avLst/>
-          </a:prstGeom>
-          <a:noFill/>
-          <a:ln/>
-        </p:spPr>
-        <p:txBody>
-          <a:bodyPr wrap="square" lIns="0" tIns="0" rIns="0" bIns="0" rtlCol="0" anchor="ctr"/>
-          <a:lstStyle/>
-          <a:p>
-            <a:pPr indent="0" marL="0">
-              <a:buNone/>
-            </a:pPr>
-            <a:r>
-              <a:rPr lang="en-US" sz="1500" b="1" dirty="0">
-                <a:solidFill>
-                  <a:srgbClr val="FFFFFF"/>
-                </a:solidFill>
-                <a:latin typeface="Arial" pitchFamily="34" charset="0"/>
-                <a:ea typeface="Arial" pitchFamily="34" charset="-122"/>
-                <a:cs typeface="Arial" pitchFamily="34" charset="-120"/>
-              </a:rPr>
-              <a:t>Every decision journaled</a:t>
-            </a:r>
-            <a:pPr indent="0" marL="0">
-              <a:buNone/>
-            </a:pPr>
-            <a:r>
-              <a:rPr lang="en-US" sz="1500" dirty="0">
-                <a:solidFill>
-                  <a:srgbClr val="A1A8B5"/>
-                </a:solidFill>
-                <a:latin typeface="Arial" pitchFamily="34" charset="0"/>
-                <a:ea typeface="Arial" pitchFamily="34" charset="-122"/>
-                <a:cs typeface="Arial" pitchFamily="34" charset="-120"/>
-              </a:rPr>
-              <a:t>   including the ones it refused to take</a:t>
-            </a:r>
-            <a:endParaRPr lang="en-US" sz="1500" dirty="0"/>
-          </a:p>
-        </p:txBody>
-      </p:sp>
-      <p:sp>
-        <p:nvSpPr>
-          <p:cNvPr id="13" name="Text 11"/>
-          <p:cNvSpPr txBox="1"/>
-          <p:nvPr/>
-        </p:nvSpPr>
-        <p:spPr>
-          <a:xfrm>
-            <a:off x="548640" y="6263640"/>
-            <a:ext cx="7772400" cy="274320"/>
-          </a:xfrm>
-          <a:prstGeom prst="rect">
-            <a:avLst/>
-          </a:prstGeom>
-          <a:noFill/>
-          <a:ln/>
-        </p:spPr>
-        <p:txBody>
-          <a:bodyPr wrap="square" lIns="0" tIns="0" rIns="0" bIns="0" rtlCol="0" anchor="ctr"/>
-          <a:lstStyle/>
-          <a:p>
-            <a:pPr indent="0" marL="0">
-              <a:buNone/>
-            </a:pPr>
-            <a:r>
-              <a:rPr lang="en-US" sz="900" dirty="0">
-                <a:solidFill>
-                  <a:srgbClr val="6B7686"/>
-                </a:solidFill>
-                <a:latin typeface="Courier New" pitchFamily="34" charset="0"/>
-                <a:ea typeface="Courier New" pitchFamily="34" charset="-122"/>
-                <a:cs typeface="Courier New" pitchFamily="34" charset="-120"/>
-              </a:rPr>
-              <a:t>Alpaca paper account PA38HG4D9653  ·  paper trading only. Hypothetical results; not investment advice.</a:t>
-            </a:r>
-            <a:endParaRPr lang="en-US" sz="900" dirty="0"/>
-          </a:p>
-        </p:txBody>
-      </p:sp>
-    </p:spTree>
-  </p:cSld>
-  <p:clrMapOvr>
-    <a:masterClrMapping/>
-  </p:clrMapOvr>
-</p:sld>
-</file>
-
-<file path=ppt/slides/slide9.xml><?xml version="1.0" encoding="utf-8"?>
-<p:sld xmlns:a="http://schemas.openxmlformats.org/drawingml/2006/main" xmlns:r="http://schemas.openxmlformats.org/officeDocument/2006/relationships" xmlns:p="http://schemas.openxmlformats.org/presentationml/2006/main">
-  <p:cSld name="Slide 9">
-    <p:bg>
-      <p:bgPr>
-        <a:solidFill>
-          <a:srgbClr val="0B0E14"/>
-        </a:solidFill>
-      </p:bgPr>
-    </p:bg>
-    <p:spTree>
-      <p:nvGrpSpPr>
-        <p:cNvPr id="1" name=""/>
-        <p:cNvGrpSpPr/>
-        <p:nvPr/>
-      </p:nvGrpSpPr>
-      <p:grpSpPr>
-        <a:xfrm>
-          <a:off x="0" y="0"/>
-          <a:ext cx="0" cy="0"/>
-          <a:chOff x="0" y="0"/>
-          <a:chExt cx="0" cy="0"/>
-        </a:xfrm>
-      </p:grpSpPr>
-      <p:sp>
-        <p:nvSpPr>
-          <p:cNvPr id="2" name="Text 0"/>
-          <p:cNvSpPr txBox="1"/>
-          <p:nvPr/>
-        </p:nvSpPr>
-        <p:spPr>
-          <a:xfrm>
-            <a:off x="548640" y="384048"/>
-            <a:ext cx="7315200" cy="274320"/>
-          </a:xfrm>
-          <a:prstGeom prst="rect">
-            <a:avLst/>
-          </a:prstGeom>
-          <a:noFill/>
-          <a:ln/>
-        </p:spPr>
-        <p:txBody>
-          <a:bodyPr wrap="square" rtlCol="0" anchor="ctr"/>
-          <a:lstStyle/>
-          <a:p>
-            <a:pPr indent="0" marL="0">
-              <a:buNone/>
-            </a:pPr>
-            <a:r>
-              <a:rPr lang="en-US" sz="1100" spc="200" kern="0" dirty="0">
-                <a:solidFill>
-                  <a:srgbClr val="6B7686"/>
-                </a:solidFill>
-                <a:latin typeface="Courier New" pitchFamily="34" charset="0"/>
-                <a:ea typeface="Courier New" pitchFamily="34" charset="-122"/>
-                <a:cs typeface="Courier New" pitchFamily="34" charset="-120"/>
-              </a:rPr>
-              <a:t>Required one-page write-up</a:t>
+              <a:t>One-page write-up</a:t>
             </a:r>
             <a:endParaRPr lang="en-US" sz="1100" dirty="0"/>
           </a:p>
@@ -9886,6 +9179,45 @@
               <a:t>Every scan appends one JSONL record with the full reasoning to logs/.</a:t>
             </a:r>
             <a:endParaRPr lang="en-US" sz="950" dirty="0"/>
+          </a:p>
+        </p:txBody>
+      </p:sp>
+      <p:sp>
+        <p:nvSpPr>
+          <p:cNvPr id="16" name="Text 14"/>
+          <p:cNvSpPr txBox="1"/>
+          <p:nvPr/>
+        </p:nvSpPr>
+        <p:spPr>
+          <a:xfrm>
+            <a:off x="548640" y="6263640"/>
+            <a:ext cx="5212080" cy="274320"/>
+          </a:xfrm>
+          <a:prstGeom prst="rect">
+            <a:avLst/>
+          </a:prstGeom>
+          <a:noFill/>
+          <a:ln/>
+        </p:spPr>
+        <p:txBody>
+          <a:bodyPr wrap="square" lIns="0" tIns="0" rIns="0" bIns="0" rtlCol="0" anchor="ctr"/>
+          <a:lstStyle/>
+          <a:p>
+            <a:pPr indent="0" marL="0">
+              <a:buNone/>
+            </a:pPr>
+            <a:r>
+              <a:rPr lang="en-US" sz="900" dirty="0">
+                <a:solidFill>
+                  <a:srgbClr val="6B7686"/>
+                </a:solidFill>
+                <a:latin typeface="Courier New" pitchFamily="34" charset="0"/>
+                <a:ea typeface="Courier New" pitchFamily="34" charset="-122"/>
+                <a:cs typeface="Courier New" pitchFamily="34" charset="-120"/>
+              </a:rPr>
+              <a:t>Paper trading only. Hypothetical results; not investment advice.</a:t>
+            </a:r>
+            <a:endParaRPr lang="en-US" sz="900" dirty="0"/>
           </a:p>
         </p:txBody>
       </p:sp>

</xml_diff>

<commit_message>
Deck: drop the Claude veto from the pipeline slide, swap slides 4 and 5
The veto has never run: config.json is rules_only on every arm, and all
942 gate records in the live journal say "source": "rules_only". The
slide presented it as part of the pipeline that produced the result.

Removing it took the slide's title, both cards and its footnote with it,
since all three existed to describe the veto. The slide is now built on
the three tests that did run - score, half-opening-range noise band and
leader-breadth regime - which also expands the single "GATE" box from
the how-it-works slide rather than repeating it.

Decision logic is now slide 4 (kicker 03) and risk gates slide 5 (04).

Co-Authored-By: Claude Opus 5 <noreply@anthropic.com>
</commit_message>
<xml_diff>
--- a/assets/deck.pptx
+++ b/assets/deck.pptx
@@ -1044,7 +1044,7 @@
           <a:p>
             <a:r>
               <a:rPr lang="en-US" dirty="0"/>
-              <a:t>174 network-free tests cover the scorer, these gates, the sizing maths and the execution path.</a:t>
+              <a:t>The three tests are independent of each other, so they fail for different reasons. The band is the one worth pausing on: the threshold comes from that morning's own range, not from a constant someone tuned.</a:t>
             </a:r>
             <a:endParaRPr lang="en-US" dirty="0"/>
           </a:p>
@@ -1132,7 +1132,7 @@
           <a:p>
             <a:r>
               <a:rPr lang="en-US" dirty="0"/>
-              <a:t>Most submissions say 'LLM proposes, code decides'. This goes further: the model is wired so it cannot increase exposure even if it wanted to.</a:t>
+              <a:t>174 network-free tests cover the scorer, these gates, the sizing maths and the execution path.</a:t>
             </a:r>
             <a:endParaRPr lang="en-US" dirty="0"/>
           </a:p>
@@ -4893,7 +4893,7 @@
                 <a:ea typeface="Courier New" pitchFamily="34" charset="-122"/>
                 <a:cs typeface="Courier New" pitchFamily="34" charset="-120"/>
               </a:rPr>
-              <a:t>03  ·  Risk gates</a:t>
+              <a:t>03  ·  Decision logic</a:t>
             </a:r>
             <a:endParaRPr lang="en-US" sz="1100" dirty="0"/>
           </a:p>
@@ -4971,7 +4971,7 @@
                 <a:ea typeface="Arial" pitchFamily="34" charset="-122"/>
                 <a:cs typeface="Arial" pitchFamily="34" charset="-120"/>
               </a:rPr>
-              <a:t>Risk is structural before it is procedural</a:t>
+              <a:t>Three independent tests. A trade needs all three.</a:t>
             </a:r>
             <a:endParaRPr lang="en-US" sz="3400" dirty="0"/>
           </a:p>
@@ -4985,12 +4985,179 @@
         </p:nvSpPr>
         <p:spPr>
           <a:xfrm>
-            <a:off x="548640" y="1719072"/>
-            <a:ext cx="11091672" cy="713232"/>
+            <a:off x="548640" y="1874520"/>
+            <a:ext cx="2622042" cy="1417320"/>
           </a:xfrm>
           <a:prstGeom prst="roundRect">
             <a:avLst>
-              <a:gd name="adj" fmla="val 10256"/>
+              <a:gd name="adj" fmla="val 5161"/>
+            </a:avLst>
+          </a:prstGeom>
+          <a:solidFill>
+            <a:srgbClr val="141922"/>
+          </a:solidFill>
+          <a:ln w="12700">
+            <a:solidFill>
+              <a:srgbClr val="232A38"/>
+            </a:solidFill>
+            <a:prstDash val="solid"/>
+          </a:ln>
+        </p:spPr>
+      </p:sp>
+      <p:sp>
+        <p:nvSpPr>
+          <p:cNvPr id="6" name="Text 4"/>
+          <p:cNvSpPr txBox="1"/>
+          <p:nvPr/>
+        </p:nvSpPr>
+        <p:spPr>
+          <a:xfrm>
+            <a:off x="548640" y="2039112"/>
+            <a:ext cx="2622042" cy="274320"/>
+          </a:xfrm>
+          <a:prstGeom prst="rect">
+            <a:avLst/>
+          </a:prstGeom>
+          <a:noFill/>
+          <a:ln/>
+        </p:spPr>
+        <p:txBody>
+          <a:bodyPr wrap="square" rtlCol="0" anchor="ctr"/>
+          <a:lstStyle/>
+          <a:p>
+            <a:pPr algn="ctr" indent="0" marL="0">
+              <a:buNone/>
+            </a:pPr>
+            <a:r>
+              <a:rPr lang="en-US" sz="1200" b="1" dirty="0">
+                <a:solidFill>
+                  <a:srgbClr val="FFFFFF"/>
+                </a:solidFill>
+                <a:latin typeface="Courier New" pitchFamily="34" charset="0"/>
+                <a:ea typeface="Courier New" pitchFamily="34" charset="-122"/>
+                <a:cs typeface="Courier New" pitchFamily="34" charset="-120"/>
+              </a:rPr>
+              <a:t>SCORED SIGNAL</a:t>
+            </a:r>
+            <a:endParaRPr lang="en-US" sz="1200" dirty="0"/>
+          </a:p>
+        </p:txBody>
+      </p:sp>
+      <p:sp>
+        <p:nvSpPr>
+          <p:cNvPr id="7" name="Text 5"/>
+          <p:cNvSpPr txBox="1"/>
+          <p:nvPr/>
+        </p:nvSpPr>
+        <p:spPr>
+          <a:xfrm>
+            <a:off x="640080" y="2368296"/>
+            <a:ext cx="2439162" cy="795528"/>
+          </a:xfrm>
+          <a:prstGeom prst="rect">
+            <a:avLst/>
+          </a:prstGeom>
+          <a:noFill/>
+          <a:ln/>
+        </p:spPr>
+        <p:txBody>
+          <a:bodyPr wrap="square" rtlCol="0" anchor="ctr"/>
+          <a:lstStyle/>
+          <a:p>
+            <a:pPr algn="ctr" indent="0" marL="0">
+              <a:lnSpc>
+                <a:spcPct val="120000"/>
+              </a:lnSpc>
+              <a:buNone/>
+            </a:pPr>
+            <a:r>
+              <a:rPr lang="en-US" sz="1000" dirty="0">
+                <a:solidFill>
+                  <a:srgbClr val="A1A8B5"/>
+                </a:solidFill>
+                <a:latin typeface="Arial" pitchFamily="34" charset="0"/>
+                <a:ea typeface="Arial" pitchFamily="34" charset="-122"/>
+                <a:cs typeface="Arial" pitchFamily="34" charset="-120"/>
+              </a:rPr>
+              <a:t>VWAP, OR break, RSI,</a:t>
+            </a:r>
+            <a:endParaRPr lang="en-US" sz="1000" dirty="0"/>
+          </a:p>
+          <a:p>
+            <a:pPr algn="ctr" indent="0" marL="0">
+              <a:lnSpc>
+                <a:spcPct val="120000"/>
+              </a:lnSpc>
+              <a:buNone/>
+            </a:pPr>
+            <a:r>
+              <a:rPr lang="en-US" sz="1000" dirty="0">
+                <a:solidFill>
+                  <a:srgbClr val="A1A8B5"/>
+                </a:solidFill>
+                <a:latin typeface="Arial" pitchFamily="34" charset="0"/>
+                <a:ea typeface="Arial" pitchFamily="34" charset="-122"/>
+                <a:cs typeface="Arial" pitchFamily="34" charset="-120"/>
+              </a:rPr>
+              <a:t>EMA, relative volume</a:t>
+            </a:r>
+            <a:endParaRPr lang="en-US" sz="1000" dirty="0"/>
+          </a:p>
+        </p:txBody>
+      </p:sp>
+      <p:sp>
+        <p:nvSpPr>
+          <p:cNvPr id="8" name="Text 6"/>
+          <p:cNvSpPr txBox="1"/>
+          <p:nvPr/>
+        </p:nvSpPr>
+        <p:spPr>
+          <a:xfrm>
+            <a:off x="3170682" y="2400300"/>
+            <a:ext cx="201168" cy="365760"/>
+          </a:xfrm>
+          <a:prstGeom prst="rect">
+            <a:avLst/>
+          </a:prstGeom>
+          <a:noFill/>
+          <a:ln/>
+        </p:spPr>
+        <p:txBody>
+          <a:bodyPr wrap="square" rtlCol="0" anchor="ctr"/>
+          <a:lstStyle/>
+          <a:p>
+            <a:pPr algn="ctr" indent="0" marL="0">
+              <a:buNone/>
+            </a:pPr>
+            <a:r>
+              <a:rPr lang="en-US" sz="1600" dirty="0">
+                <a:solidFill>
+                  <a:srgbClr val="6B7686"/>
+                </a:solidFill>
+                <a:latin typeface="Arial" pitchFamily="34" charset="0"/>
+                <a:ea typeface="Arial" pitchFamily="34" charset="-122"/>
+                <a:cs typeface="Arial" pitchFamily="34" charset="-120"/>
+              </a:rPr>
+              <a:t>›</a:t>
+            </a:r>
+            <a:endParaRPr lang="en-US" sz="1600" dirty="0"/>
+          </a:p>
+        </p:txBody>
+      </p:sp>
+      <p:sp>
+        <p:nvSpPr>
+          <p:cNvPr id="9" name="Shape 7"/>
+          <p:cNvSpPr/>
+          <p:nvPr/>
+        </p:nvSpPr>
+        <p:spPr>
+          <a:xfrm>
+            <a:off x="3371850" y="1874520"/>
+            <a:ext cx="2622042" cy="1417320"/>
+          </a:xfrm>
+          <a:prstGeom prst="roundRect">
+            <a:avLst>
+              <a:gd name="adj" fmla="val 5161"/>
             </a:avLst>
           </a:prstGeom>
           <a:solidFill>
@@ -5006,44 +5173,72 @@
       </p:sp>
       <p:sp>
         <p:nvSpPr>
-          <p:cNvPr id="6" name="Text 4"/>
-          <p:cNvSpPr txBox="1"/>
-          <p:nvPr/>
-        </p:nvSpPr>
-        <p:spPr>
-          <a:xfrm>
-            <a:off x="822960" y="1719072"/>
-            <a:ext cx="10515600" cy="713232"/>
-          </a:xfrm>
-          <a:prstGeom prst="rect">
-            <a:avLst/>
-          </a:prstGeom>
-          <a:noFill/>
-          <a:ln/>
-        </p:spPr>
-        <p:txBody>
-          <a:bodyPr wrap="square" lIns="0" tIns="0" rIns="0" bIns="0" rtlCol="0" anchor="ctr"/>
-          <a:lstStyle/>
-          <a:p>
-            <a:pPr indent="0" marL="0">
-              <a:buNone/>
-            </a:pPr>
-            <a:r>
-              <a:rPr lang="en-US" sz="1400" b="1" dirty="0">
-                <a:solidFill>
-                  <a:srgbClr val="FFFFFF"/>
-                </a:solidFill>
-                <a:latin typeface="Arial" pitchFamily="34" charset="0"/>
-                <a:ea typeface="Arial" pitchFamily="34" charset="-122"/>
-                <a:cs typeface="Arial" pitchFamily="34" charset="-120"/>
-              </a:rPr>
-              <a:t>Single-leg long options only.  </a:t>
-            </a:r>
-            <a:pPr indent="0" marL="0">
-              <a:buNone/>
-            </a:pPr>
-            <a:r>
-              <a:rPr lang="en-US" sz="1400" dirty="0">
+          <p:cNvPr id="10" name="Text 8"/>
+          <p:cNvSpPr txBox="1"/>
+          <p:nvPr/>
+        </p:nvSpPr>
+        <p:spPr>
+          <a:xfrm>
+            <a:off x="3371850" y="2039112"/>
+            <a:ext cx="2622042" cy="274320"/>
+          </a:xfrm>
+          <a:prstGeom prst="rect">
+            <a:avLst/>
+          </a:prstGeom>
+          <a:noFill/>
+          <a:ln/>
+        </p:spPr>
+        <p:txBody>
+          <a:bodyPr wrap="square" rtlCol="0" anchor="ctr"/>
+          <a:lstStyle/>
+          <a:p>
+            <a:pPr algn="ctr" indent="0" marL="0">
+              <a:buNone/>
+            </a:pPr>
+            <a:r>
+              <a:rPr lang="en-US" sz="1200" b="1" dirty="0">
+                <a:solidFill>
+                  <a:srgbClr val="F0B429"/>
+                </a:solidFill>
+                <a:latin typeface="Courier New" pitchFamily="34" charset="0"/>
+                <a:ea typeface="Courier New" pitchFamily="34" charset="-122"/>
+                <a:cs typeface="Courier New" pitchFamily="34" charset="-120"/>
+              </a:rPr>
+              <a:t>NOISE BAND</a:t>
+            </a:r>
+            <a:endParaRPr lang="en-US" sz="1200" dirty="0"/>
+          </a:p>
+        </p:txBody>
+      </p:sp>
+      <p:sp>
+        <p:nvSpPr>
+          <p:cNvPr id="11" name="Text 9"/>
+          <p:cNvSpPr txBox="1"/>
+          <p:nvPr/>
+        </p:nvSpPr>
+        <p:spPr>
+          <a:xfrm>
+            <a:off x="3463290" y="2368296"/>
+            <a:ext cx="2439162" cy="795528"/>
+          </a:xfrm>
+          <a:prstGeom prst="rect">
+            <a:avLst/>
+          </a:prstGeom>
+          <a:noFill/>
+          <a:ln/>
+        </p:spPr>
+        <p:txBody>
+          <a:bodyPr wrap="square" rtlCol="0" anchor="ctr"/>
+          <a:lstStyle/>
+          <a:p>
+            <a:pPr algn="ctr" indent="0" marL="0">
+              <a:lnSpc>
+                <a:spcPct val="120000"/>
+              </a:lnSpc>
+              <a:buNone/>
+            </a:pPr>
+            <a:r>
+              <a:rPr lang="en-US" sz="1000" dirty="0">
                 <a:solidFill>
                   <a:srgbClr val="A1A8B5"/>
                 </a:solidFill>
@@ -5051,26 +5246,85 @@
                 <a:ea typeface="Arial" pitchFamily="34" charset="-122"/>
                 <a:cs typeface="Arial" pitchFamily="34" charset="-120"/>
               </a:rPr>
-              <a:t>Maximum loss is the premium paid - enforced by the instrument, not by code that has to remember.</a:t>
-            </a:r>
-            <a:endParaRPr lang="en-US" sz="1400" dirty="0"/>
-          </a:p>
-        </p:txBody>
-      </p:sp>
-      <p:sp>
-        <p:nvSpPr>
-          <p:cNvPr id="7" name="Shape 5"/>
+              <a:t>is the break bigger than</a:t>
+            </a:r>
+            <a:endParaRPr lang="en-US" sz="1000" dirty="0"/>
+          </a:p>
+          <a:p>
+            <a:pPr algn="ctr" indent="0" marL="0">
+              <a:lnSpc>
+                <a:spcPct val="120000"/>
+              </a:lnSpc>
+              <a:buNone/>
+            </a:pPr>
+            <a:r>
+              <a:rPr lang="en-US" sz="1000" dirty="0">
+                <a:solidFill>
+                  <a:srgbClr val="A1A8B5"/>
+                </a:solidFill>
+                <a:latin typeface="Arial" pitchFamily="34" charset="0"/>
+                <a:ea typeface="Arial" pitchFamily="34" charset="-122"/>
+                <a:cs typeface="Arial" pitchFamily="34" charset="-120"/>
+              </a:rPr>
+              <a:t>the symbol's own noise?</a:t>
+            </a:r>
+            <a:endParaRPr lang="en-US" sz="1000" dirty="0"/>
+          </a:p>
+        </p:txBody>
+      </p:sp>
+      <p:sp>
+        <p:nvSpPr>
+          <p:cNvPr id="12" name="Text 10"/>
+          <p:cNvSpPr txBox="1"/>
+          <p:nvPr/>
+        </p:nvSpPr>
+        <p:spPr>
+          <a:xfrm>
+            <a:off x="5993892" y="2400300"/>
+            <a:ext cx="201168" cy="365760"/>
+          </a:xfrm>
+          <a:prstGeom prst="rect">
+            <a:avLst/>
+          </a:prstGeom>
+          <a:noFill/>
+          <a:ln/>
+        </p:spPr>
+        <p:txBody>
+          <a:bodyPr wrap="square" rtlCol="0" anchor="ctr"/>
+          <a:lstStyle/>
+          <a:p>
+            <a:pPr algn="ctr" indent="0" marL="0">
+              <a:buNone/>
+            </a:pPr>
+            <a:r>
+              <a:rPr lang="en-US" sz="1600" dirty="0">
+                <a:solidFill>
+                  <a:srgbClr val="6B7686"/>
+                </a:solidFill>
+                <a:latin typeface="Arial" pitchFamily="34" charset="0"/>
+                <a:ea typeface="Arial" pitchFamily="34" charset="-122"/>
+                <a:cs typeface="Arial" pitchFamily="34" charset="-120"/>
+              </a:rPr>
+              <a:t>›</a:t>
+            </a:r>
+            <a:endParaRPr lang="en-US" sz="1600" dirty="0"/>
+          </a:p>
+        </p:txBody>
+      </p:sp>
+      <p:sp>
+        <p:nvSpPr>
+          <p:cNvPr id="13" name="Shape 11"/>
           <p:cNvSpPr/>
           <p:nvPr/>
         </p:nvSpPr>
         <p:spPr>
           <a:xfrm>
-            <a:off x="548640" y="2670048"/>
-            <a:ext cx="3557016" cy="1389888"/>
+            <a:off x="6195060" y="1874520"/>
+            <a:ext cx="2622042" cy="1417320"/>
           </a:xfrm>
           <a:prstGeom prst="roundRect">
             <a:avLst>
-              <a:gd name="adj" fmla="val 5263"/>
+              <a:gd name="adj" fmla="val 5161"/>
             </a:avLst>
           </a:prstGeom>
           <a:solidFill>
@@ -5086,72 +5340,72 @@
       </p:sp>
       <p:sp>
         <p:nvSpPr>
-          <p:cNvPr id="8" name="Text 6"/>
-          <p:cNvSpPr txBox="1"/>
-          <p:nvPr/>
-        </p:nvSpPr>
-        <p:spPr>
-          <a:xfrm>
-            <a:off x="841248" y="2871216"/>
-            <a:ext cx="2971800" cy="219456"/>
-          </a:xfrm>
-          <a:prstGeom prst="rect">
-            <a:avLst/>
-          </a:prstGeom>
-          <a:noFill/>
-          <a:ln/>
-        </p:spPr>
-        <p:txBody>
-          <a:bodyPr wrap="square" lIns="0" tIns="0" rIns="0" bIns="0" rtlCol="0" anchor="ctr"/>
-          <a:lstStyle/>
-          <a:p>
-            <a:pPr indent="0" marL="0">
-              <a:buNone/>
-            </a:pPr>
-            <a:r>
-              <a:rPr lang="en-US" sz="1000" spc="140" kern="0" dirty="0">
-                <a:solidFill>
-                  <a:srgbClr val="6B7686"/>
+          <p:cNvPr id="14" name="Text 12"/>
+          <p:cNvSpPr txBox="1"/>
+          <p:nvPr/>
+        </p:nvSpPr>
+        <p:spPr>
+          <a:xfrm>
+            <a:off x="6195060" y="2039112"/>
+            <a:ext cx="2622042" cy="274320"/>
+          </a:xfrm>
+          <a:prstGeom prst="rect">
+            <a:avLst/>
+          </a:prstGeom>
+          <a:noFill/>
+          <a:ln/>
+        </p:spPr>
+        <p:txBody>
+          <a:bodyPr wrap="square" rtlCol="0" anchor="ctr"/>
+          <a:lstStyle/>
+          <a:p>
+            <a:pPr algn="ctr" indent="0" marL="0">
+              <a:buNone/>
+            </a:pPr>
+            <a:r>
+              <a:rPr lang="en-US" sz="1200" b="1" dirty="0">
+                <a:solidFill>
+                  <a:srgbClr val="FFFFFF"/>
                 </a:solidFill>
                 <a:latin typeface="Courier New" pitchFamily="34" charset="0"/>
                 <a:ea typeface="Courier New" pitchFamily="34" charset="-122"/>
                 <a:cs typeface="Courier New" pitchFamily="34" charset="-120"/>
               </a:rPr>
-              <a:t>ONE-LOT GUARD</a:t>
-            </a:r>
-            <a:endParaRPr lang="en-US" sz="1000" dirty="0"/>
-          </a:p>
-        </p:txBody>
-      </p:sp>
-      <p:sp>
-        <p:nvSpPr>
-          <p:cNvPr id="9" name="Text 7"/>
-          <p:cNvSpPr txBox="1"/>
-          <p:nvPr/>
-        </p:nvSpPr>
-        <p:spPr>
-          <a:xfrm>
-            <a:off x="841248" y="3163824"/>
-            <a:ext cx="2971800" cy="731520"/>
-          </a:xfrm>
-          <a:prstGeom prst="rect">
-            <a:avLst/>
-          </a:prstGeom>
-          <a:noFill/>
-          <a:ln/>
-        </p:spPr>
-        <p:txBody>
-          <a:bodyPr wrap="square" lIns="0" tIns="0" rIns="0" bIns="0" rtlCol="0" anchor="t"/>
-          <a:lstStyle/>
-          <a:p>
-            <a:pPr indent="0" marL="0">
+              <a:t>LEADER REGIME</a:t>
+            </a:r>
+            <a:endParaRPr lang="en-US" sz="1200" dirty="0"/>
+          </a:p>
+        </p:txBody>
+      </p:sp>
+      <p:sp>
+        <p:nvSpPr>
+          <p:cNvPr id="15" name="Text 13"/>
+          <p:cNvSpPr txBox="1"/>
+          <p:nvPr/>
+        </p:nvSpPr>
+        <p:spPr>
+          <a:xfrm>
+            <a:off x="6286500" y="2368296"/>
+            <a:ext cx="2439162" cy="795528"/>
+          </a:xfrm>
+          <a:prstGeom prst="rect">
+            <a:avLst/>
+          </a:prstGeom>
+          <a:noFill/>
+          <a:ln/>
+        </p:spPr>
+        <p:txBody>
+          <a:bodyPr wrap="square" rtlCol="0" anchor="ctr"/>
+          <a:lstStyle/>
+          <a:p>
+            <a:pPr algn="ctr" indent="0" marL="0">
               <a:lnSpc>
                 <a:spcPct val="120000"/>
               </a:lnSpc>
               <a:buNone/>
             </a:pPr>
             <a:r>
-              <a:rPr lang="en-US" sz="1100" dirty="0">
+              <a:rPr lang="en-US" sz="1000" dirty="0">
                 <a:solidFill>
                   <a:srgbClr val="A1A8B5"/>
                 </a:solidFill>
@@ -5159,26 +5413,85 @@
                 <a:ea typeface="Arial" pitchFamily="34" charset="-122"/>
                 <a:cs typeface="Arial" pitchFamily="34" charset="-120"/>
               </a:rPr>
-              <a:t>Never a second open lot on a (symbol, direction) already held.</a:t>
-            </a:r>
-            <a:endParaRPr lang="en-US" sz="1100" dirty="0"/>
-          </a:p>
-        </p:txBody>
-      </p:sp>
-      <p:sp>
-        <p:nvSpPr>
-          <p:cNvPr id="10" name="Shape 8"/>
+              <a:t>5 of 8 mega-caps above</a:t>
+            </a:r>
+            <a:endParaRPr lang="en-US" sz="1000" dirty="0"/>
+          </a:p>
+          <a:p>
+            <a:pPr algn="ctr" indent="0" marL="0">
+              <a:lnSpc>
+                <a:spcPct val="120000"/>
+              </a:lnSpc>
+              <a:buNone/>
+            </a:pPr>
+            <a:r>
+              <a:rPr lang="en-US" sz="1000" dirty="0">
+                <a:solidFill>
+                  <a:srgbClr val="A1A8B5"/>
+                </a:solidFill>
+                <a:latin typeface="Arial" pitchFamily="34" charset="0"/>
+                <a:ea typeface="Arial" pitchFamily="34" charset="-122"/>
+                <a:cs typeface="Arial" pitchFamily="34" charset="-120"/>
+              </a:rPr>
+              <a:t>their 20-day average</a:t>
+            </a:r>
+            <a:endParaRPr lang="en-US" sz="1000" dirty="0"/>
+          </a:p>
+        </p:txBody>
+      </p:sp>
+      <p:sp>
+        <p:nvSpPr>
+          <p:cNvPr id="16" name="Text 14"/>
+          <p:cNvSpPr txBox="1"/>
+          <p:nvPr/>
+        </p:nvSpPr>
+        <p:spPr>
+          <a:xfrm>
+            <a:off x="8817102" y="2400300"/>
+            <a:ext cx="201168" cy="365760"/>
+          </a:xfrm>
+          <a:prstGeom prst="rect">
+            <a:avLst/>
+          </a:prstGeom>
+          <a:noFill/>
+          <a:ln/>
+        </p:spPr>
+        <p:txBody>
+          <a:bodyPr wrap="square" rtlCol="0" anchor="ctr"/>
+          <a:lstStyle/>
+          <a:p>
+            <a:pPr algn="ctr" indent="0" marL="0">
+              <a:buNone/>
+            </a:pPr>
+            <a:r>
+              <a:rPr lang="en-US" sz="1600" dirty="0">
+                <a:solidFill>
+                  <a:srgbClr val="6B7686"/>
+                </a:solidFill>
+                <a:latin typeface="Arial" pitchFamily="34" charset="0"/>
+                <a:ea typeface="Arial" pitchFamily="34" charset="-122"/>
+                <a:cs typeface="Arial" pitchFamily="34" charset="-120"/>
+              </a:rPr>
+              <a:t>›</a:t>
+            </a:r>
+            <a:endParaRPr lang="en-US" sz="1600" dirty="0"/>
+          </a:p>
+        </p:txBody>
+      </p:sp>
+      <p:sp>
+        <p:nvSpPr>
+          <p:cNvPr id="17" name="Shape 15"/>
           <p:cNvSpPr/>
           <p:nvPr/>
         </p:nvSpPr>
         <p:spPr>
           <a:xfrm>
-            <a:off x="4315968" y="2670048"/>
-            <a:ext cx="3557016" cy="1389888"/>
+            <a:off x="9018270" y="1874520"/>
+            <a:ext cx="2622042" cy="1417320"/>
           </a:xfrm>
           <a:prstGeom prst="roundRect">
             <a:avLst>
-              <a:gd name="adj" fmla="val 5263"/>
+              <a:gd name="adj" fmla="val 5161"/>
             </a:avLst>
           </a:prstGeom>
           <a:solidFill>
@@ -5194,72 +5507,72 @@
       </p:sp>
       <p:sp>
         <p:nvSpPr>
-          <p:cNvPr id="11" name="Text 9"/>
-          <p:cNvSpPr txBox="1"/>
-          <p:nvPr/>
-        </p:nvSpPr>
-        <p:spPr>
-          <a:xfrm>
-            <a:off x="4608576" y="2871216"/>
-            <a:ext cx="2971800" cy="219456"/>
-          </a:xfrm>
-          <a:prstGeom prst="rect">
-            <a:avLst/>
-          </a:prstGeom>
-          <a:noFill/>
-          <a:ln/>
-        </p:spPr>
-        <p:txBody>
-          <a:bodyPr wrap="square" lIns="0" tIns="0" rIns="0" bIns="0" rtlCol="0" anchor="ctr"/>
-          <a:lstStyle/>
-          <a:p>
-            <a:pPr indent="0" marL="0">
-              <a:buNone/>
-            </a:pPr>
-            <a:r>
-              <a:rPr lang="en-US" sz="1000" spc="140" kern="0" dirty="0">
-                <a:solidFill>
-                  <a:srgbClr val="6B7686"/>
+          <p:cNvPr id="18" name="Text 16"/>
+          <p:cNvSpPr txBox="1"/>
+          <p:nvPr/>
+        </p:nvSpPr>
+        <p:spPr>
+          <a:xfrm>
+            <a:off x="9018270" y="2039112"/>
+            <a:ext cx="2622042" cy="274320"/>
+          </a:xfrm>
+          <a:prstGeom prst="rect">
+            <a:avLst/>
+          </a:prstGeom>
+          <a:noFill/>
+          <a:ln/>
+        </p:spPr>
+        <p:txBody>
+          <a:bodyPr wrap="square" rtlCol="0" anchor="ctr"/>
+          <a:lstStyle/>
+          <a:p>
+            <a:pPr algn="ctr" indent="0" marL="0">
+              <a:buNone/>
+            </a:pPr>
+            <a:r>
+              <a:rPr lang="en-US" sz="1200" b="1" dirty="0">
+                <a:solidFill>
+                  <a:srgbClr val="FFFFFF"/>
                 </a:solidFill>
                 <a:latin typeface="Courier New" pitchFamily="34" charset="0"/>
                 <a:ea typeface="Courier New" pitchFamily="34" charset="-122"/>
                 <a:cs typeface="Courier New" pitchFamily="34" charset="-120"/>
               </a:rPr>
-              <a:t>ONE DIRECTION / UNDERLYING</a:t>
-            </a:r>
-            <a:endParaRPr lang="en-US" sz="1000" dirty="0"/>
-          </a:p>
-        </p:txBody>
-      </p:sp>
-      <p:sp>
-        <p:nvSpPr>
-          <p:cNvPr id="12" name="Text 10"/>
-          <p:cNvSpPr txBox="1"/>
-          <p:nvPr/>
-        </p:nvSpPr>
-        <p:spPr>
-          <a:xfrm>
-            <a:off x="4608576" y="3163824"/>
-            <a:ext cx="2971800" cy="731520"/>
-          </a:xfrm>
-          <a:prstGeom prst="rect">
-            <a:avLst/>
-          </a:prstGeom>
-          <a:noFill/>
-          <a:ln/>
-        </p:spPr>
-        <p:txBody>
-          <a:bodyPr wrap="square" lIns="0" tIns="0" rIns="0" bIns="0" rtlCol="0" anchor="t"/>
-          <a:lstStyle/>
-          <a:p>
-            <a:pPr indent="0" marL="0">
+              <a:t>ORDER</a:t>
+            </a:r>
+            <a:endParaRPr lang="en-US" sz="1200" dirty="0"/>
+          </a:p>
+        </p:txBody>
+      </p:sp>
+      <p:sp>
+        <p:nvSpPr>
+          <p:cNvPr id="19" name="Text 17"/>
+          <p:cNvSpPr txBox="1"/>
+          <p:nvPr/>
+        </p:nvSpPr>
+        <p:spPr>
+          <a:xfrm>
+            <a:off x="9109710" y="2368296"/>
+            <a:ext cx="2439162" cy="795528"/>
+          </a:xfrm>
+          <a:prstGeom prst="rect">
+            <a:avLst/>
+          </a:prstGeom>
+          <a:noFill/>
+          <a:ln/>
+        </p:spPr>
+        <p:txBody>
+          <a:bodyPr wrap="square" rtlCol="0" anchor="ctr"/>
+          <a:lstStyle/>
+          <a:p>
+            <a:pPr algn="ctr" indent="0" marL="0">
               <a:lnSpc>
                 <a:spcPct val="120000"/>
               </a:lnSpc>
               <a:buNone/>
             </a:pPr>
             <a:r>
-              <a:rPr lang="en-US" sz="1100" dirty="0">
+              <a:rPr lang="en-US" sz="1000" dirty="0">
                 <a:solidFill>
                   <a:srgbClr val="A1A8B5"/>
                 </a:solidFill>
@@ -5267,26 +5580,46 @@
                 <a:ea typeface="Arial" pitchFamily="34" charset="-122"/>
                 <a:cs typeface="Arial" pitchFamily="34" charset="-120"/>
               </a:rPr>
-              <a:t>No simultaneous call and put on the same symbol.</a:t>
-            </a:r>
-            <a:endParaRPr lang="en-US" sz="1100" dirty="0"/>
-          </a:p>
-        </p:txBody>
-      </p:sp>
-      <p:sp>
-        <p:nvSpPr>
-          <p:cNvPr id="13" name="Shape 11"/>
+              <a:t>ATM long via the</a:t>
+            </a:r>
+            <a:endParaRPr lang="en-US" sz="1000" dirty="0"/>
+          </a:p>
+          <a:p>
+            <a:pPr algn="ctr" indent="0" marL="0">
+              <a:lnSpc>
+                <a:spcPct val="120000"/>
+              </a:lnSpc>
+              <a:buNone/>
+            </a:pPr>
+            <a:r>
+              <a:rPr lang="en-US" sz="1000" dirty="0">
+                <a:solidFill>
+                  <a:srgbClr val="A1A8B5"/>
+                </a:solidFill>
+                <a:latin typeface="Arial" pitchFamily="34" charset="0"/>
+                <a:ea typeface="Arial" pitchFamily="34" charset="-122"/>
+                <a:cs typeface="Arial" pitchFamily="34" charset="-120"/>
+              </a:rPr>
+              <a:t>Alpaca CLI</a:t>
+            </a:r>
+            <a:endParaRPr lang="en-US" sz="1000" dirty="0"/>
+          </a:p>
+        </p:txBody>
+      </p:sp>
+      <p:sp>
+        <p:nvSpPr>
+          <p:cNvPr id="20" name="Shape 18"/>
           <p:cNvSpPr/>
           <p:nvPr/>
         </p:nvSpPr>
         <p:spPr>
           <a:xfrm>
-            <a:off x="8083296" y="2670048"/>
-            <a:ext cx="3557016" cy="1389888"/>
+            <a:off x="548640" y="3611880"/>
+            <a:ext cx="5440680" cy="1691640"/>
           </a:xfrm>
           <a:prstGeom prst="roundRect">
             <a:avLst>
-              <a:gd name="adj" fmla="val 5263"/>
+              <a:gd name="adj" fmla="val 4324"/>
             </a:avLst>
           </a:prstGeom>
           <a:solidFill>
@@ -5302,14 +5635,14 @@
       </p:sp>
       <p:sp>
         <p:nvSpPr>
-          <p:cNvPr id="14" name="Text 12"/>
-          <p:cNvSpPr txBox="1"/>
-          <p:nvPr/>
-        </p:nvSpPr>
-        <p:spPr>
-          <a:xfrm>
-            <a:off x="8375904" y="2871216"/>
-            <a:ext cx="2971800" cy="219456"/>
+          <p:cNvPr id="21" name="Text 19"/>
+          <p:cNvSpPr txBox="1"/>
+          <p:nvPr/>
+        </p:nvSpPr>
+        <p:spPr>
+          <a:xfrm>
+            <a:off x="841248" y="3813048"/>
+            <a:ext cx="4855464" cy="219456"/>
           </a:xfrm>
           <a:prstGeom prst="rect">
             <a:avLst/>
@@ -5333,7 +5666,7 @@
                 <a:ea typeface="Courier New" pitchFamily="34" charset="-122"/>
                 <a:cs typeface="Courier New" pitchFamily="34" charset="-120"/>
               </a:rPr>
-              <a:t>ENTRY DEDUP · 30 MIN</a:t>
+              <a:t>THE HALF-OPENING-RANGE BAND</a:t>
             </a:r>
             <a:endParaRPr lang="en-US" sz="1000" dirty="0"/>
           </a:p>
@@ -5341,14 +5674,53 @@
       </p:sp>
       <p:sp>
         <p:nvSpPr>
-          <p:cNvPr id="15" name="Text 13"/>
-          <p:cNvSpPr txBox="1"/>
-          <p:nvPr/>
-        </p:nvSpPr>
-        <p:spPr>
-          <a:xfrm>
-            <a:off x="8375904" y="3163824"/>
-            <a:ext cx="2971800" cy="731520"/>
+          <p:cNvPr id="22" name="Text 20"/>
+          <p:cNvSpPr txBox="1"/>
+          <p:nvPr/>
+        </p:nvSpPr>
+        <p:spPr>
+          <a:xfrm>
+            <a:off x="841248" y="4105656"/>
+            <a:ext cx="4855464" cy="411480"/>
+          </a:xfrm>
+          <a:prstGeom prst="rect">
+            <a:avLst/>
+          </a:prstGeom>
+          <a:noFill/>
+          <a:ln/>
+        </p:spPr>
+        <p:txBody>
+          <a:bodyPr wrap="square" lIns="0" tIns="0" rIns="0" bIns="0" rtlCol="0" anchor="ctr"/>
+          <a:lstStyle/>
+          <a:p>
+            <a:pPr indent="0" marL="0">
+              <a:buNone/>
+            </a:pPr>
+            <a:r>
+              <a:rPr lang="en-US" sz="2200" b="1" dirty="0">
+                <a:solidFill>
+                  <a:srgbClr val="F0B429"/>
+                </a:solidFill>
+                <a:latin typeface="Arial" pitchFamily="34" charset="0"/>
+                <a:ea typeface="Arial" pitchFamily="34" charset="-122"/>
+                <a:cs typeface="Arial" pitchFamily="34" charset="-120"/>
+              </a:rPr>
+              <a:t>noise, not signal</a:t>
+            </a:r>
+            <a:endParaRPr lang="en-US" sz="2200" dirty="0"/>
+          </a:p>
+        </p:txBody>
+      </p:sp>
+      <p:sp>
+        <p:nvSpPr>
+          <p:cNvPr id="23" name="Text 21"/>
+          <p:cNvSpPr txBox="1"/>
+          <p:nvPr/>
+        </p:nvSpPr>
+        <p:spPr>
+          <a:xfrm>
+            <a:off x="841248" y="4572000"/>
+            <a:ext cx="4855464" cy="566928"/>
           </a:xfrm>
           <a:prstGeom prst="rect">
             <a:avLst/>
@@ -5375,7 +5747,7 @@
                 <a:ea typeface="Arial" pitchFamily="34" charset="-122"/>
                 <a:cs typeface="Arial" pitchFamily="34" charset="-120"/>
               </a:rPr>
-              <a:t>Entry-anchored, so a persistent score cannot stack the same name.</a:t>
+              <a:t>A break only counts if it clears half of that symbol's own opening range. The bar is set by the morning's actual behaviour rather than a fixed number, so a quiet SPY and a wild IWM are not judged the same way.</a:t>
             </a:r>
             <a:endParaRPr lang="en-US" sz="1100" dirty="0"/>
           </a:p>
@@ -5383,18 +5755,18 @@
       </p:sp>
       <p:sp>
         <p:nvSpPr>
-          <p:cNvPr id="16" name="Shape 14"/>
+          <p:cNvPr id="24" name="Shape 22"/>
           <p:cNvSpPr/>
           <p:nvPr/>
         </p:nvSpPr>
         <p:spPr>
           <a:xfrm>
-            <a:off x="548640" y="4242816"/>
-            <a:ext cx="3557016" cy="1389888"/>
+            <a:off x="6199632" y="3611880"/>
+            <a:ext cx="5440680" cy="1691640"/>
           </a:xfrm>
           <a:prstGeom prst="roundRect">
             <a:avLst>
-              <a:gd name="adj" fmla="val 5263"/>
+              <a:gd name="adj" fmla="val 4324"/>
             </a:avLst>
           </a:prstGeom>
           <a:solidFill>
@@ -5410,14 +5782,14 @@
       </p:sp>
       <p:sp>
         <p:nvSpPr>
-          <p:cNvPr id="17" name="Text 15"/>
-          <p:cNvSpPr txBox="1"/>
-          <p:nvPr/>
-        </p:nvSpPr>
-        <p:spPr>
-          <a:xfrm>
-            <a:off x="841248" y="4443984"/>
-            <a:ext cx="2971800" cy="219456"/>
+          <p:cNvPr id="25" name="Text 23"/>
+          <p:cNvSpPr txBox="1"/>
+          <p:nvPr/>
+        </p:nvSpPr>
+        <p:spPr>
+          <a:xfrm>
+            <a:off x="6492240" y="3813048"/>
+            <a:ext cx="4855464" cy="219456"/>
           </a:xfrm>
           <a:prstGeom prst="rect">
             <a:avLst/>
@@ -5441,7 +5813,7 @@
                 <a:ea typeface="Courier New" pitchFamily="34" charset="-122"/>
                 <a:cs typeface="Courier New" pitchFamily="34" charset="-120"/>
               </a:rPr>
-              <a:t>ADAPTIVE SIZING</a:t>
+              <a:t>LEADER BREADTH</a:t>
             </a:r>
             <a:endParaRPr lang="en-US" sz="1000" dirty="0"/>
           </a:p>
@@ -5449,14 +5821,53 @@
       </p:sp>
       <p:sp>
         <p:nvSpPr>
-          <p:cNvPr id="18" name="Text 16"/>
-          <p:cNvSpPr txBox="1"/>
-          <p:nvPr/>
-        </p:nvSpPr>
-        <p:spPr>
-          <a:xfrm>
-            <a:off x="841248" y="4736592"/>
-            <a:ext cx="2971800" cy="731520"/>
+          <p:cNvPr id="26" name="Text 24"/>
+          <p:cNvSpPr txBox="1"/>
+          <p:nvPr/>
+        </p:nvSpPr>
+        <p:spPr>
+          <a:xfrm>
+            <a:off x="6492240" y="4105656"/>
+            <a:ext cx="4855464" cy="411480"/>
+          </a:xfrm>
+          <a:prstGeom prst="rect">
+            <a:avLst/>
+          </a:prstGeom>
+          <a:noFill/>
+          <a:ln/>
+        </p:spPr>
+        <p:txBody>
+          <a:bodyPr wrap="square" lIns="0" tIns="0" rIns="0" bIns="0" rtlCol="0" anchor="ctr"/>
+          <a:lstStyle/>
+          <a:p>
+            <a:pPr indent="0" marL="0">
+              <a:buNone/>
+            </a:pPr>
+            <a:r>
+              <a:rPr lang="en-US" sz="2000" b="1" dirty="0">
+                <a:solidFill>
+                  <a:srgbClr val="FFFFFF"/>
+                </a:solidFill>
+                <a:latin typeface="Arial" pitchFamily="34" charset="0"/>
+                <a:ea typeface="Arial" pitchFamily="34" charset="-122"/>
+                <a:cs typeface="Arial" pitchFamily="34" charset="-120"/>
+              </a:rPr>
+              <a:t>removes, never adds</a:t>
+            </a:r>
+            <a:endParaRPr lang="en-US" sz="2000" dirty="0"/>
+          </a:p>
+        </p:txBody>
+      </p:sp>
+      <p:sp>
+        <p:nvSpPr>
+          <p:cNvPr id="27" name="Text 25"/>
+          <p:cNvSpPr txBox="1"/>
+          <p:nvPr/>
+        </p:nvSpPr>
+        <p:spPr>
+          <a:xfrm>
+            <a:off x="6492240" y="4572000"/>
+            <a:ext cx="4855464" cy="566928"/>
           </a:xfrm>
           <a:prstGeom prst="rect">
             <a:avLst/>
@@ -5483,7 +5894,7 @@
                 <a:ea typeface="Arial" pitchFamily="34" charset="-122"/>
                 <a:cs typeface="Arial" pitchFamily="34" charset="-120"/>
               </a:rPr>
-              <a:t>Trimmed to the account's real options buying power - an expensive contract sizes down, never rejects.</a:t>
+              <a:t>5 of 8 mega-caps above their 20-day average as of the last completed session. The regime can only rule out the opposed direction - it never creates a trade the score did not already propose.</a:t>
             </a:r>
             <a:endParaRPr lang="en-US" sz="1100" dirty="0"/>
           </a:p>
@@ -5491,41 +5902,14 @@
       </p:sp>
       <p:sp>
         <p:nvSpPr>
-          <p:cNvPr id="19" name="Shape 17"/>
-          <p:cNvSpPr/>
-          <p:nvPr/>
-        </p:nvSpPr>
-        <p:spPr>
-          <a:xfrm>
-            <a:off x="4315968" y="4242816"/>
-            <a:ext cx="3557016" cy="1389888"/>
-          </a:xfrm>
-          <a:prstGeom prst="roundRect">
-            <a:avLst>
-              <a:gd name="adj" fmla="val 5263"/>
-            </a:avLst>
-          </a:prstGeom>
-          <a:solidFill>
-            <a:srgbClr val="141922"/>
-          </a:solidFill>
-          <a:ln w="12700">
-            <a:solidFill>
-              <a:srgbClr val="232A38"/>
-            </a:solidFill>
-            <a:prstDash val="solid"/>
-          </a:ln>
-        </p:spPr>
-      </p:sp>
-      <p:sp>
-        <p:nvSpPr>
-          <p:cNvPr id="20" name="Text 18"/>
-          <p:cNvSpPr txBox="1"/>
-          <p:nvPr/>
-        </p:nvSpPr>
-        <p:spPr>
-          <a:xfrm>
-            <a:off x="4608576" y="4443984"/>
-            <a:ext cx="2971800" cy="219456"/>
+          <p:cNvPr id="28" name="Text 26"/>
+          <p:cNvSpPr txBox="1"/>
+          <p:nvPr/>
+        </p:nvSpPr>
+        <p:spPr>
+          <a:xfrm>
+            <a:off x="548640" y="5486400"/>
+            <a:ext cx="11091672" cy="365760"/>
           </a:xfrm>
           <a:prstGeom prst="rect">
             <a:avLst/>
@@ -5541,49 +5925,7 @@
               <a:buNone/>
             </a:pPr>
             <a:r>
-              <a:rPr lang="en-US" sz="1000" spc="140" kern="0" dirty="0">
-                <a:solidFill>
-                  <a:srgbClr val="6B7686"/>
-                </a:solidFill>
-                <a:latin typeface="Courier New" pitchFamily="34" charset="0"/>
-                <a:ea typeface="Courier New" pitchFamily="34" charset="-122"/>
-                <a:cs typeface="Courier New" pitchFamily="34" charset="-120"/>
-              </a:rPr>
-              <a:t>SESSION WINDOW</a:t>
-            </a:r>
-            <a:endParaRPr lang="en-US" sz="1000" dirty="0"/>
-          </a:p>
-        </p:txBody>
-      </p:sp>
-      <p:sp>
-        <p:nvSpPr>
-          <p:cNvPr id="21" name="Text 19"/>
-          <p:cNvSpPr txBox="1"/>
-          <p:nvPr/>
-        </p:nvSpPr>
-        <p:spPr>
-          <a:xfrm>
-            <a:off x="4608576" y="4736592"/>
-            <a:ext cx="2971800" cy="731520"/>
-          </a:xfrm>
-          <a:prstGeom prst="rect">
-            <a:avLst/>
-          </a:prstGeom>
-          <a:noFill/>
-          <a:ln/>
-        </p:spPr>
-        <p:txBody>
-          <a:bodyPr wrap="square" lIns="0" tIns="0" rIns="0" bIns="0" rtlCol="0" anchor="t"/>
-          <a:lstStyle/>
-          <a:p>
-            <a:pPr indent="0" marL="0">
-              <a:lnSpc>
-                <a:spcPct val="120000"/>
-              </a:lnSpc>
-              <a:buNone/>
-            </a:pPr>
-            <a:r>
-              <a:rPr lang="en-US" sz="1100" dirty="0">
+              <a:rPr lang="en-US" sz="1200" dirty="0">
                 <a:solidFill>
                   <a:srgbClr val="A1A8B5"/>
                 </a:solidFill>
@@ -5591,156 +5933,9 @@
                 <a:ea typeface="Arial" pitchFamily="34" charset="-122"/>
                 <a:cs typeface="Arial" pitchFamily="34" charset="-120"/>
               </a:rPr>
-              <a:t>No entry after 15:00 ET. Hard flatten at 15:50 - a 0DTE never reaches expiry.</a:t>
-            </a:r>
-            <a:endParaRPr lang="en-US" sz="1100" dirty="0"/>
-          </a:p>
-        </p:txBody>
-      </p:sp>
-      <p:sp>
-        <p:nvSpPr>
-          <p:cNvPr id="22" name="Shape 20"/>
-          <p:cNvSpPr/>
-          <p:nvPr/>
-        </p:nvSpPr>
-        <p:spPr>
-          <a:xfrm>
-            <a:off x="8083296" y="4242816"/>
-            <a:ext cx="3557016" cy="1389888"/>
-          </a:xfrm>
-          <a:prstGeom prst="roundRect">
-            <a:avLst>
-              <a:gd name="adj" fmla="val 5263"/>
-            </a:avLst>
-          </a:prstGeom>
-          <a:solidFill>
-            <a:srgbClr val="141922"/>
-          </a:solidFill>
-          <a:ln w="12700">
-            <a:solidFill>
-              <a:srgbClr val="232A38"/>
-            </a:solidFill>
-            <a:prstDash val="solid"/>
-          </a:ln>
-        </p:spPr>
-      </p:sp>
-      <p:sp>
-        <p:nvSpPr>
-          <p:cNvPr id="23" name="Text 21"/>
-          <p:cNvSpPr txBox="1"/>
-          <p:nvPr/>
-        </p:nvSpPr>
-        <p:spPr>
-          <a:xfrm>
-            <a:off x="8375904" y="4443984"/>
-            <a:ext cx="2971800" cy="219456"/>
-          </a:xfrm>
-          <a:prstGeom prst="rect">
-            <a:avLst/>
-          </a:prstGeom>
-          <a:noFill/>
-          <a:ln/>
-        </p:spPr>
-        <p:txBody>
-          <a:bodyPr wrap="square" lIns="0" tIns="0" rIns="0" bIns="0" rtlCol="0" anchor="ctr"/>
-          <a:lstStyle/>
-          <a:p>
-            <a:pPr indent="0" marL="0">
-              <a:buNone/>
-            </a:pPr>
-            <a:r>
-              <a:rPr lang="en-US" sz="1000" spc="140" kern="0" dirty="0">
-                <a:solidFill>
-                  <a:srgbClr val="6B7686"/>
-                </a:solidFill>
-                <a:latin typeface="Courier New" pitchFamily="34" charset="0"/>
-                <a:ea typeface="Courier New" pitchFamily="34" charset="-122"/>
-                <a:cs typeface="Courier New" pitchFamily="34" charset="-120"/>
-              </a:rPr>
-              <a:t>ORPHAN SWEEP</a:t>
-            </a:r>
-            <a:endParaRPr lang="en-US" sz="1000" dirty="0"/>
-          </a:p>
-        </p:txBody>
-      </p:sp>
-      <p:sp>
-        <p:nvSpPr>
-          <p:cNvPr id="24" name="Text 22"/>
-          <p:cNvSpPr txBox="1"/>
-          <p:nvPr/>
-        </p:nvSpPr>
-        <p:spPr>
-          <a:xfrm>
-            <a:off x="8375904" y="4736592"/>
-            <a:ext cx="2971800" cy="731520"/>
-          </a:xfrm>
-          <a:prstGeom prst="rect">
-            <a:avLst/>
-          </a:prstGeom>
-          <a:noFill/>
-          <a:ln/>
-        </p:spPr>
-        <p:txBody>
-          <a:bodyPr wrap="square" lIns="0" tIns="0" rIns="0" bIns="0" rtlCol="0" anchor="t"/>
-          <a:lstStyle/>
-          <a:p>
-            <a:pPr indent="0" marL="0">
-              <a:lnSpc>
-                <a:spcPct val="120000"/>
-              </a:lnSpc>
-              <a:buNone/>
-            </a:pPr>
-            <a:r>
-              <a:rPr lang="en-US" sz="1100" dirty="0">
-                <a:solidFill>
-                  <a:srgbClr val="A1A8B5"/>
-                </a:solidFill>
-                <a:latin typeface="Arial" pitchFamily="34" charset="0"/>
-                <a:ea typeface="Arial" pitchFamily="34" charset="-122"/>
-                <a:cs typeface="Arial" pitchFamily="34" charset="-120"/>
-              </a:rPr>
-              <a:t>Any option position the agent did not open is flattened at startup and at EOD.</a:t>
-            </a:r>
-            <a:endParaRPr lang="en-US" sz="1100" dirty="0"/>
-          </a:p>
-        </p:txBody>
-      </p:sp>
-      <p:sp>
-        <p:nvSpPr>
-          <p:cNvPr id="25" name="Text 23"/>
-          <p:cNvSpPr txBox="1"/>
-          <p:nvPr/>
-        </p:nvSpPr>
-        <p:spPr>
-          <a:xfrm>
-            <a:off x="548640" y="5870448"/>
-            <a:ext cx="11091672" cy="365760"/>
-          </a:xfrm>
-          <a:prstGeom prst="rect">
-            <a:avLst/>
-          </a:prstGeom>
-          <a:noFill/>
-          <a:ln/>
-        </p:spPr>
-        <p:txBody>
-          <a:bodyPr wrap="square" lIns="0" tIns="0" rIns="0" bIns="0" rtlCol="0" anchor="ctr"/>
-          <a:lstStyle/>
-          <a:p>
-            <a:pPr indent="0" marL="0">
-              <a:buNone/>
-            </a:pPr>
-            <a:r>
-              <a:rPr lang="en-US" sz="1100" dirty="0">
-                <a:solidFill>
-                  <a:srgbClr val="A1A8B5"/>
-                </a:solidFill>
-                <a:latin typeface="Arial" pitchFamily="34" charset="0"/>
-                <a:ea typeface="Arial" pitchFamily="34" charset="-122"/>
-                <a:cs typeface="Arial" pitchFamily="34" charset="-120"/>
-              </a:rPr>
-              <a:t>Exits ladder in both directions:  +40% scales out half and trails the runner by 40% of its peak gain  ·  -20% sells half, -40% the rest  ·  a 30-minute stop closes anything still under water  ·  15:50 flatten.</a:t>
-            </a:r>
-            <a:endParaRPr lang="en-US" sz="1100" dirty="0"/>
+              <a:t>A trade needs the score at or above 0.70, price outside the band, and the direction agreeing with the regime. Any one of the three says no and nothing is placed.</a:t>
+            </a:r>
+            <a:endParaRPr lang="en-US" sz="1200" dirty="0"/>
           </a:p>
         </p:txBody>
       </p:sp>
@@ -5809,7 +6004,7 @@
                 <a:ea typeface="Courier New" pitchFamily="34" charset="-122"/>
                 <a:cs typeface="Courier New" pitchFamily="34" charset="-120"/>
               </a:rPr>
-              <a:t>04  ·  AI logic</a:t>
+              <a:t>04  ·  Risk gates</a:t>
             </a:r>
             <a:endParaRPr lang="en-US" sz="1100" dirty="0"/>
           </a:p>
@@ -5887,7 +6082,7 @@
                 <a:ea typeface="Arial" pitchFamily="34" charset="-122"/>
                 <a:cs typeface="Arial" pitchFamily="34" charset="-120"/>
               </a:rPr>
-              <a:t>An AI that is structurally incapable of adding risk</a:t>
+              <a:t>Risk is structural before it is procedural</a:t>
             </a:r>
             <a:endParaRPr lang="en-US" sz="3400" dirty="0"/>
           </a:p>
@@ -5901,12 +6096,92 @@
         </p:nvSpPr>
         <p:spPr>
           <a:xfrm>
-            <a:off x="548640" y="1874520"/>
-            <a:ext cx="2622042" cy="1417320"/>
+            <a:off x="548640" y="1719072"/>
+            <a:ext cx="11091672" cy="713232"/>
           </a:xfrm>
           <a:prstGeom prst="roundRect">
             <a:avLst>
-              <a:gd name="adj" fmla="val 5161"/>
+              <a:gd name="adj" fmla="val 10256"/>
+            </a:avLst>
+          </a:prstGeom>
+          <a:solidFill>
+            <a:srgbClr val="141922"/>
+          </a:solidFill>
+          <a:ln w="12700">
+            <a:solidFill>
+              <a:srgbClr val="F0B429"/>
+            </a:solidFill>
+            <a:prstDash val="solid"/>
+          </a:ln>
+        </p:spPr>
+      </p:sp>
+      <p:sp>
+        <p:nvSpPr>
+          <p:cNvPr id="6" name="Text 4"/>
+          <p:cNvSpPr txBox="1"/>
+          <p:nvPr/>
+        </p:nvSpPr>
+        <p:spPr>
+          <a:xfrm>
+            <a:off x="822960" y="1719072"/>
+            <a:ext cx="10515600" cy="713232"/>
+          </a:xfrm>
+          <a:prstGeom prst="rect">
+            <a:avLst/>
+          </a:prstGeom>
+          <a:noFill/>
+          <a:ln/>
+        </p:spPr>
+        <p:txBody>
+          <a:bodyPr wrap="square" lIns="0" tIns="0" rIns="0" bIns="0" rtlCol="0" anchor="ctr"/>
+          <a:lstStyle/>
+          <a:p>
+            <a:pPr indent="0" marL="0">
+              <a:buNone/>
+            </a:pPr>
+            <a:r>
+              <a:rPr lang="en-US" sz="1400" b="1" dirty="0">
+                <a:solidFill>
+                  <a:srgbClr val="FFFFFF"/>
+                </a:solidFill>
+                <a:latin typeface="Arial" pitchFamily="34" charset="0"/>
+                <a:ea typeface="Arial" pitchFamily="34" charset="-122"/>
+                <a:cs typeface="Arial" pitchFamily="34" charset="-120"/>
+              </a:rPr>
+              <a:t>Single-leg long options only.  </a:t>
+            </a:r>
+            <a:pPr indent="0" marL="0">
+              <a:buNone/>
+            </a:pPr>
+            <a:r>
+              <a:rPr lang="en-US" sz="1400" dirty="0">
+                <a:solidFill>
+                  <a:srgbClr val="A1A8B5"/>
+                </a:solidFill>
+                <a:latin typeface="Arial" pitchFamily="34" charset="0"/>
+                <a:ea typeface="Arial" pitchFamily="34" charset="-122"/>
+                <a:cs typeface="Arial" pitchFamily="34" charset="-120"/>
+              </a:rPr>
+              <a:t>Maximum loss is the premium paid - enforced by the instrument, not by code that has to remember.</a:t>
+            </a:r>
+            <a:endParaRPr lang="en-US" sz="1400" dirty="0"/>
+          </a:p>
+        </p:txBody>
+      </p:sp>
+      <p:sp>
+        <p:nvSpPr>
+          <p:cNvPr id="7" name="Shape 5"/>
+          <p:cNvSpPr/>
+          <p:nvPr/>
+        </p:nvSpPr>
+        <p:spPr>
+          <a:xfrm>
+            <a:off x="548640" y="2670048"/>
+            <a:ext cx="3557016" cy="1389888"/>
+          </a:xfrm>
+          <a:prstGeom prst="roundRect">
+            <a:avLst>
+              <a:gd name="adj" fmla="val 5263"/>
             </a:avLst>
           </a:prstGeom>
           <a:solidFill>
@@ -5922,72 +6197,72 @@
       </p:sp>
       <p:sp>
         <p:nvSpPr>
-          <p:cNvPr id="6" name="Text 4"/>
-          <p:cNvSpPr txBox="1"/>
-          <p:nvPr/>
-        </p:nvSpPr>
-        <p:spPr>
-          <a:xfrm>
-            <a:off x="548640" y="2039112"/>
-            <a:ext cx="2622042" cy="274320"/>
-          </a:xfrm>
-          <a:prstGeom prst="rect">
-            <a:avLst/>
-          </a:prstGeom>
-          <a:noFill/>
-          <a:ln/>
-        </p:spPr>
-        <p:txBody>
-          <a:bodyPr wrap="square" rtlCol="0" anchor="ctr"/>
-          <a:lstStyle/>
-          <a:p>
-            <a:pPr algn="ctr" indent="0" marL="0">
-              <a:buNone/>
-            </a:pPr>
-            <a:r>
-              <a:rPr lang="en-US" sz="1200" b="1" dirty="0">
-                <a:solidFill>
-                  <a:srgbClr val="FFFFFF"/>
+          <p:cNvPr id="8" name="Text 6"/>
+          <p:cNvSpPr txBox="1"/>
+          <p:nvPr/>
+        </p:nvSpPr>
+        <p:spPr>
+          <a:xfrm>
+            <a:off x="841248" y="2871216"/>
+            <a:ext cx="2971800" cy="219456"/>
+          </a:xfrm>
+          <a:prstGeom prst="rect">
+            <a:avLst/>
+          </a:prstGeom>
+          <a:noFill/>
+          <a:ln/>
+        </p:spPr>
+        <p:txBody>
+          <a:bodyPr wrap="square" lIns="0" tIns="0" rIns="0" bIns="0" rtlCol="0" anchor="ctr"/>
+          <a:lstStyle/>
+          <a:p>
+            <a:pPr indent="0" marL="0">
+              <a:buNone/>
+            </a:pPr>
+            <a:r>
+              <a:rPr lang="en-US" sz="1000" spc="140" kern="0" dirty="0">
+                <a:solidFill>
+                  <a:srgbClr val="6B7686"/>
                 </a:solidFill>
                 <a:latin typeface="Courier New" pitchFamily="34" charset="0"/>
                 <a:ea typeface="Courier New" pitchFamily="34" charset="-122"/>
                 <a:cs typeface="Courier New" pitchFamily="34" charset="-120"/>
               </a:rPr>
-              <a:t>SCORED SIGNAL</a:t>
-            </a:r>
-            <a:endParaRPr lang="en-US" sz="1200" dirty="0"/>
-          </a:p>
-        </p:txBody>
-      </p:sp>
-      <p:sp>
-        <p:nvSpPr>
-          <p:cNvPr id="7" name="Text 5"/>
-          <p:cNvSpPr txBox="1"/>
-          <p:nvPr/>
-        </p:nvSpPr>
-        <p:spPr>
-          <a:xfrm>
-            <a:off x="640080" y="2368296"/>
-            <a:ext cx="2439162" cy="795528"/>
-          </a:xfrm>
-          <a:prstGeom prst="rect">
-            <a:avLst/>
-          </a:prstGeom>
-          <a:noFill/>
-          <a:ln/>
-        </p:spPr>
-        <p:txBody>
-          <a:bodyPr wrap="square" rtlCol="0" anchor="ctr"/>
-          <a:lstStyle/>
-          <a:p>
-            <a:pPr algn="ctr" indent="0" marL="0">
+              <a:t>ONE-LOT GUARD</a:t>
+            </a:r>
+            <a:endParaRPr lang="en-US" sz="1000" dirty="0"/>
+          </a:p>
+        </p:txBody>
+      </p:sp>
+      <p:sp>
+        <p:nvSpPr>
+          <p:cNvPr id="9" name="Text 7"/>
+          <p:cNvSpPr txBox="1"/>
+          <p:nvPr/>
+        </p:nvSpPr>
+        <p:spPr>
+          <a:xfrm>
+            <a:off x="841248" y="3163824"/>
+            <a:ext cx="2971800" cy="731520"/>
+          </a:xfrm>
+          <a:prstGeom prst="rect">
+            <a:avLst/>
+          </a:prstGeom>
+          <a:noFill/>
+          <a:ln/>
+        </p:spPr>
+        <p:txBody>
+          <a:bodyPr wrap="square" lIns="0" tIns="0" rIns="0" bIns="0" rtlCol="0" anchor="t"/>
+          <a:lstStyle/>
+          <a:p>
+            <a:pPr indent="0" marL="0">
               <a:lnSpc>
                 <a:spcPct val="120000"/>
               </a:lnSpc>
               <a:buNone/>
             </a:pPr>
             <a:r>
-              <a:rPr lang="en-US" sz="1000" dirty="0">
+              <a:rPr lang="en-US" sz="1100" dirty="0">
                 <a:solidFill>
                   <a:srgbClr val="A1A8B5"/>
                 </a:solidFill>
@@ -5995,85 +6270,26 @@
                 <a:ea typeface="Arial" pitchFamily="34" charset="-122"/>
                 <a:cs typeface="Arial" pitchFamily="34" charset="-120"/>
               </a:rPr>
-              <a:t>VWAP, OR break, RSI,</a:t>
-            </a:r>
-            <a:endParaRPr lang="en-US" sz="1000" dirty="0"/>
-          </a:p>
-          <a:p>
-            <a:pPr algn="ctr" indent="0" marL="0">
-              <a:lnSpc>
-                <a:spcPct val="120000"/>
-              </a:lnSpc>
-              <a:buNone/>
-            </a:pPr>
-            <a:r>
-              <a:rPr lang="en-US" sz="1000" dirty="0">
-                <a:solidFill>
-                  <a:srgbClr val="A1A8B5"/>
-                </a:solidFill>
-                <a:latin typeface="Arial" pitchFamily="34" charset="0"/>
-                <a:ea typeface="Arial" pitchFamily="34" charset="-122"/>
-                <a:cs typeface="Arial" pitchFamily="34" charset="-120"/>
-              </a:rPr>
-              <a:t>EMA, relative volume</a:t>
-            </a:r>
-            <a:endParaRPr lang="en-US" sz="1000" dirty="0"/>
-          </a:p>
-        </p:txBody>
-      </p:sp>
-      <p:sp>
-        <p:nvSpPr>
-          <p:cNvPr id="8" name="Text 6"/>
-          <p:cNvSpPr txBox="1"/>
-          <p:nvPr/>
-        </p:nvSpPr>
-        <p:spPr>
-          <a:xfrm>
-            <a:off x="3170682" y="2400300"/>
-            <a:ext cx="201168" cy="365760"/>
-          </a:xfrm>
-          <a:prstGeom prst="rect">
-            <a:avLst/>
-          </a:prstGeom>
-          <a:noFill/>
-          <a:ln/>
-        </p:spPr>
-        <p:txBody>
-          <a:bodyPr wrap="square" rtlCol="0" anchor="ctr"/>
-          <a:lstStyle/>
-          <a:p>
-            <a:pPr algn="ctr" indent="0" marL="0">
-              <a:buNone/>
-            </a:pPr>
-            <a:r>
-              <a:rPr lang="en-US" sz="1600" dirty="0">
-                <a:solidFill>
-                  <a:srgbClr val="6B7686"/>
-                </a:solidFill>
-                <a:latin typeface="Arial" pitchFamily="34" charset="0"/>
-                <a:ea typeface="Arial" pitchFamily="34" charset="-122"/>
-                <a:cs typeface="Arial" pitchFamily="34" charset="-120"/>
-              </a:rPr>
-              <a:t>›</a:t>
-            </a:r>
-            <a:endParaRPr lang="en-US" sz="1600" dirty="0"/>
-          </a:p>
-        </p:txBody>
-      </p:sp>
-      <p:sp>
-        <p:nvSpPr>
-          <p:cNvPr id="9" name="Shape 7"/>
+              <a:t>Never a second open lot on a (symbol, direction) already held.</a:t>
+            </a:r>
+            <a:endParaRPr lang="en-US" sz="1100" dirty="0"/>
+          </a:p>
+        </p:txBody>
+      </p:sp>
+      <p:sp>
+        <p:nvSpPr>
+          <p:cNvPr id="10" name="Shape 8"/>
           <p:cNvSpPr/>
           <p:nvPr/>
         </p:nvSpPr>
         <p:spPr>
           <a:xfrm>
-            <a:off x="3371850" y="1874520"/>
-            <a:ext cx="2622042" cy="1417320"/>
+            <a:off x="4315968" y="2670048"/>
+            <a:ext cx="3557016" cy="1389888"/>
           </a:xfrm>
           <a:prstGeom prst="roundRect">
             <a:avLst>
-              <a:gd name="adj" fmla="val 5161"/>
+              <a:gd name="adj" fmla="val 5263"/>
             </a:avLst>
           </a:prstGeom>
           <a:solidFill>
@@ -6089,72 +6305,72 @@
       </p:sp>
       <p:sp>
         <p:nvSpPr>
-          <p:cNvPr id="10" name="Text 8"/>
-          <p:cNvSpPr txBox="1"/>
-          <p:nvPr/>
-        </p:nvSpPr>
-        <p:spPr>
-          <a:xfrm>
-            <a:off x="3371850" y="2039112"/>
-            <a:ext cx="2622042" cy="274320"/>
-          </a:xfrm>
-          <a:prstGeom prst="rect">
-            <a:avLst/>
-          </a:prstGeom>
-          <a:noFill/>
-          <a:ln/>
-        </p:spPr>
-        <p:txBody>
-          <a:bodyPr wrap="square" rtlCol="0" anchor="ctr"/>
-          <a:lstStyle/>
-          <a:p>
-            <a:pPr algn="ctr" indent="0" marL="0">
-              <a:buNone/>
-            </a:pPr>
-            <a:r>
-              <a:rPr lang="en-US" sz="1200" b="1" dirty="0">
-                <a:solidFill>
-                  <a:srgbClr val="FFFFFF"/>
+          <p:cNvPr id="11" name="Text 9"/>
+          <p:cNvSpPr txBox="1"/>
+          <p:nvPr/>
+        </p:nvSpPr>
+        <p:spPr>
+          <a:xfrm>
+            <a:off x="4608576" y="2871216"/>
+            <a:ext cx="2971800" cy="219456"/>
+          </a:xfrm>
+          <a:prstGeom prst="rect">
+            <a:avLst/>
+          </a:prstGeom>
+          <a:noFill/>
+          <a:ln/>
+        </p:spPr>
+        <p:txBody>
+          <a:bodyPr wrap="square" lIns="0" tIns="0" rIns="0" bIns="0" rtlCol="0" anchor="ctr"/>
+          <a:lstStyle/>
+          <a:p>
+            <a:pPr indent="0" marL="0">
+              <a:buNone/>
+            </a:pPr>
+            <a:r>
+              <a:rPr lang="en-US" sz="1000" spc="140" kern="0" dirty="0">
+                <a:solidFill>
+                  <a:srgbClr val="6B7686"/>
                 </a:solidFill>
                 <a:latin typeface="Courier New" pitchFamily="34" charset="0"/>
                 <a:ea typeface="Courier New" pitchFamily="34" charset="-122"/>
                 <a:cs typeface="Courier New" pitchFamily="34" charset="-120"/>
               </a:rPr>
-              <a:t>RULES GATE</a:t>
-            </a:r>
-            <a:endParaRPr lang="en-US" sz="1200" dirty="0"/>
-          </a:p>
-        </p:txBody>
-      </p:sp>
-      <p:sp>
-        <p:nvSpPr>
-          <p:cNvPr id="11" name="Text 9"/>
-          <p:cNvSpPr txBox="1"/>
-          <p:nvPr/>
-        </p:nvSpPr>
-        <p:spPr>
-          <a:xfrm>
-            <a:off x="3463290" y="2368296"/>
-            <a:ext cx="2439162" cy="795528"/>
-          </a:xfrm>
-          <a:prstGeom prst="rect">
-            <a:avLst/>
-          </a:prstGeom>
-          <a:noFill/>
-          <a:ln/>
-        </p:spPr>
-        <p:txBody>
-          <a:bodyPr wrap="square" rtlCol="0" anchor="ctr"/>
-          <a:lstStyle/>
-          <a:p>
-            <a:pPr algn="ctr" indent="0" marL="0">
+              <a:t>ONE DIRECTION / UNDERLYING</a:t>
+            </a:r>
+            <a:endParaRPr lang="en-US" sz="1000" dirty="0"/>
+          </a:p>
+        </p:txBody>
+      </p:sp>
+      <p:sp>
+        <p:nvSpPr>
+          <p:cNvPr id="12" name="Text 10"/>
+          <p:cNvSpPr txBox="1"/>
+          <p:nvPr/>
+        </p:nvSpPr>
+        <p:spPr>
+          <a:xfrm>
+            <a:off x="4608576" y="3163824"/>
+            <a:ext cx="2971800" cy="731520"/>
+          </a:xfrm>
+          <a:prstGeom prst="rect">
+            <a:avLst/>
+          </a:prstGeom>
+          <a:noFill/>
+          <a:ln/>
+        </p:spPr>
+        <p:txBody>
+          <a:bodyPr wrap="square" lIns="0" tIns="0" rIns="0" bIns="0" rtlCol="0" anchor="t"/>
+          <a:lstStyle/>
+          <a:p>
+            <a:pPr indent="0" marL="0">
               <a:lnSpc>
                 <a:spcPct val="120000"/>
               </a:lnSpc>
               <a:buNone/>
             </a:pPr>
             <a:r>
-              <a:rPr lang="en-US" sz="1000" dirty="0">
+              <a:rPr lang="en-US" sz="1100" dirty="0">
                 <a:solidFill>
                   <a:srgbClr val="A1A8B5"/>
                 </a:solidFill>
@@ -6162,68 +6378,9 @@
                 <a:ea typeface="Arial" pitchFamily="34" charset="-122"/>
                 <a:cs typeface="Arial" pitchFamily="34" charset="-120"/>
               </a:rPr>
-              <a:t>score ≥ 0.70, outside the</a:t>
-            </a:r>
-            <a:endParaRPr lang="en-US" sz="1000" dirty="0"/>
-          </a:p>
-          <a:p>
-            <a:pPr algn="ctr" indent="0" marL="0">
-              <a:lnSpc>
-                <a:spcPct val="120000"/>
-              </a:lnSpc>
-              <a:buNone/>
-            </a:pPr>
-            <a:r>
-              <a:rPr lang="en-US" sz="1000" dirty="0">
-                <a:solidFill>
-                  <a:srgbClr val="A1A8B5"/>
-                </a:solidFill>
-                <a:latin typeface="Arial" pitchFamily="34" charset="0"/>
-                <a:ea typeface="Arial" pitchFamily="34" charset="-122"/>
-                <a:cs typeface="Arial" pitchFamily="34" charset="-120"/>
-              </a:rPr>
-              <a:t>half-OR band, regime agrees</a:t>
-            </a:r>
-            <a:endParaRPr lang="en-US" sz="1000" dirty="0"/>
-          </a:p>
-        </p:txBody>
-      </p:sp>
-      <p:sp>
-        <p:nvSpPr>
-          <p:cNvPr id="12" name="Text 10"/>
-          <p:cNvSpPr txBox="1"/>
-          <p:nvPr/>
-        </p:nvSpPr>
-        <p:spPr>
-          <a:xfrm>
-            <a:off x="5993892" y="2400300"/>
-            <a:ext cx="201168" cy="365760"/>
-          </a:xfrm>
-          <a:prstGeom prst="rect">
-            <a:avLst/>
-          </a:prstGeom>
-          <a:noFill/>
-          <a:ln/>
-        </p:spPr>
-        <p:txBody>
-          <a:bodyPr wrap="square" rtlCol="0" anchor="ctr"/>
-          <a:lstStyle/>
-          <a:p>
-            <a:pPr algn="ctr" indent="0" marL="0">
-              <a:buNone/>
-            </a:pPr>
-            <a:r>
-              <a:rPr lang="en-US" sz="1600" dirty="0">
-                <a:solidFill>
-                  <a:srgbClr val="6B7686"/>
-                </a:solidFill>
-                <a:latin typeface="Arial" pitchFamily="34" charset="0"/>
-                <a:ea typeface="Arial" pitchFamily="34" charset="-122"/>
-                <a:cs typeface="Arial" pitchFamily="34" charset="-120"/>
-              </a:rPr>
-              <a:t>›</a:t>
-            </a:r>
-            <a:endParaRPr lang="en-US" sz="1600" dirty="0"/>
+              <a:t>No simultaneous call and put on the same symbol.</a:t>
+            </a:r>
+            <a:endParaRPr lang="en-US" sz="1100" dirty="0"/>
           </a:p>
         </p:txBody>
       </p:sp>
@@ -6235,179 +6392,12 @@
         </p:nvSpPr>
         <p:spPr>
           <a:xfrm>
-            <a:off x="6195060" y="1874520"/>
-            <a:ext cx="2622042" cy="1417320"/>
+            <a:off x="8083296" y="2670048"/>
+            <a:ext cx="3557016" cy="1389888"/>
           </a:xfrm>
           <a:prstGeom prst="roundRect">
             <a:avLst>
-              <a:gd name="adj" fmla="val 5161"/>
-            </a:avLst>
-          </a:prstGeom>
-          <a:solidFill>
-            <a:srgbClr val="141922"/>
-          </a:solidFill>
-          <a:ln w="12700">
-            <a:solidFill>
-              <a:srgbClr val="F0B429"/>
-            </a:solidFill>
-            <a:prstDash val="solid"/>
-          </a:ln>
-        </p:spPr>
-      </p:sp>
-      <p:sp>
-        <p:nvSpPr>
-          <p:cNvPr id="14" name="Text 12"/>
-          <p:cNvSpPr txBox="1"/>
-          <p:nvPr/>
-        </p:nvSpPr>
-        <p:spPr>
-          <a:xfrm>
-            <a:off x="6195060" y="2039112"/>
-            <a:ext cx="2622042" cy="274320"/>
-          </a:xfrm>
-          <a:prstGeom prst="rect">
-            <a:avLst/>
-          </a:prstGeom>
-          <a:noFill/>
-          <a:ln/>
-        </p:spPr>
-        <p:txBody>
-          <a:bodyPr wrap="square" rtlCol="0" anchor="ctr"/>
-          <a:lstStyle/>
-          <a:p>
-            <a:pPr algn="ctr" indent="0" marL="0">
-              <a:buNone/>
-            </a:pPr>
-            <a:r>
-              <a:rPr lang="en-US" sz="1200" b="1" dirty="0">
-                <a:solidFill>
-                  <a:srgbClr val="F0B429"/>
-                </a:solidFill>
-                <a:latin typeface="Courier New" pitchFamily="34" charset="0"/>
-                <a:ea typeface="Courier New" pitchFamily="34" charset="-122"/>
-                <a:cs typeface="Courier New" pitchFamily="34" charset="-120"/>
-              </a:rPr>
-              <a:t>CLAUDE VETO</a:t>
-            </a:r>
-            <a:endParaRPr lang="en-US" sz="1200" dirty="0"/>
-          </a:p>
-        </p:txBody>
-      </p:sp>
-      <p:sp>
-        <p:nvSpPr>
-          <p:cNvPr id="15" name="Text 13"/>
-          <p:cNvSpPr txBox="1"/>
-          <p:nvPr/>
-        </p:nvSpPr>
-        <p:spPr>
-          <a:xfrm>
-            <a:off x="6286500" y="2368296"/>
-            <a:ext cx="2439162" cy="795528"/>
-          </a:xfrm>
-          <a:prstGeom prst="rect">
-            <a:avLst/>
-          </a:prstGeom>
-          <a:noFill/>
-          <a:ln/>
-        </p:spPr>
-        <p:txBody>
-          <a:bodyPr wrap="square" rtlCol="0" anchor="ctr"/>
-          <a:lstStyle/>
-          <a:p>
-            <a:pPr algn="ctr" indent="0" marL="0">
-              <a:lnSpc>
-                <a:spcPct val="120000"/>
-              </a:lnSpc>
-              <a:buNone/>
-            </a:pPr>
-            <a:r>
-              <a:rPr lang="en-US" sz="1000" dirty="0">
-                <a:solidFill>
-                  <a:srgbClr val="A1A8B5"/>
-                </a:solidFill>
-                <a:latin typeface="Arial" pitchFamily="34" charset="0"/>
-                <a:ea typeface="Arial" pitchFamily="34" charset="-122"/>
-                <a:cs typeface="Arial" pitchFamily="34" charset="-120"/>
-              </a:rPr>
-              <a:t>bull / bear debate,</a:t>
-            </a:r>
-            <a:endParaRPr lang="en-US" sz="1000" dirty="0"/>
-          </a:p>
-          <a:p>
-            <a:pPr algn="ctr" indent="0" marL="0">
-              <a:lnSpc>
-                <a:spcPct val="120000"/>
-              </a:lnSpc>
-              <a:buNone/>
-            </a:pPr>
-            <a:r>
-              <a:rPr lang="en-US" sz="1000" dirty="0">
-                <a:solidFill>
-                  <a:srgbClr val="A1A8B5"/>
-                </a:solidFill>
-                <a:latin typeface="Arial" pitchFamily="34" charset="0"/>
-                <a:ea typeface="Arial" pitchFamily="34" charset="-122"/>
-                <a:cs typeface="Arial" pitchFamily="34" charset="-120"/>
-              </a:rPr>
-              <a:t>regime read - no-go only</a:t>
-            </a:r>
-            <a:endParaRPr lang="en-US" sz="1000" dirty="0"/>
-          </a:p>
-        </p:txBody>
-      </p:sp>
-      <p:sp>
-        <p:nvSpPr>
-          <p:cNvPr id="16" name="Text 14"/>
-          <p:cNvSpPr txBox="1"/>
-          <p:nvPr/>
-        </p:nvSpPr>
-        <p:spPr>
-          <a:xfrm>
-            <a:off x="8817102" y="2400300"/>
-            <a:ext cx="201168" cy="365760"/>
-          </a:xfrm>
-          <a:prstGeom prst="rect">
-            <a:avLst/>
-          </a:prstGeom>
-          <a:noFill/>
-          <a:ln/>
-        </p:spPr>
-        <p:txBody>
-          <a:bodyPr wrap="square" rtlCol="0" anchor="ctr"/>
-          <a:lstStyle/>
-          <a:p>
-            <a:pPr algn="ctr" indent="0" marL="0">
-              <a:buNone/>
-            </a:pPr>
-            <a:r>
-              <a:rPr lang="en-US" sz="1600" dirty="0">
-                <a:solidFill>
-                  <a:srgbClr val="6B7686"/>
-                </a:solidFill>
-                <a:latin typeface="Arial" pitchFamily="34" charset="0"/>
-                <a:ea typeface="Arial" pitchFamily="34" charset="-122"/>
-                <a:cs typeface="Arial" pitchFamily="34" charset="-120"/>
-              </a:rPr>
-              <a:t>›</a:t>
-            </a:r>
-            <a:endParaRPr lang="en-US" sz="1600" dirty="0"/>
-          </a:p>
-        </p:txBody>
-      </p:sp>
-      <p:sp>
-        <p:nvSpPr>
-          <p:cNvPr id="17" name="Shape 15"/>
-          <p:cNvSpPr/>
-          <p:nvPr/>
-        </p:nvSpPr>
-        <p:spPr>
-          <a:xfrm>
-            <a:off x="9018270" y="1874520"/>
-            <a:ext cx="2622042" cy="1417320"/>
-          </a:xfrm>
-          <a:prstGeom prst="roundRect">
-            <a:avLst>
-              <a:gd name="adj" fmla="val 5161"/>
+              <a:gd name="adj" fmla="val 5263"/>
             </a:avLst>
           </a:prstGeom>
           <a:solidFill>
@@ -6423,72 +6413,72 @@
       </p:sp>
       <p:sp>
         <p:nvSpPr>
-          <p:cNvPr id="18" name="Text 16"/>
-          <p:cNvSpPr txBox="1"/>
-          <p:nvPr/>
-        </p:nvSpPr>
-        <p:spPr>
-          <a:xfrm>
-            <a:off x="9018270" y="2039112"/>
-            <a:ext cx="2622042" cy="274320"/>
-          </a:xfrm>
-          <a:prstGeom prst="rect">
-            <a:avLst/>
-          </a:prstGeom>
-          <a:noFill/>
-          <a:ln/>
-        </p:spPr>
-        <p:txBody>
-          <a:bodyPr wrap="square" rtlCol="0" anchor="ctr"/>
-          <a:lstStyle/>
-          <a:p>
-            <a:pPr algn="ctr" indent="0" marL="0">
-              <a:buNone/>
-            </a:pPr>
-            <a:r>
-              <a:rPr lang="en-US" sz="1200" b="1" dirty="0">
-                <a:solidFill>
-                  <a:srgbClr val="FFFFFF"/>
+          <p:cNvPr id="14" name="Text 12"/>
+          <p:cNvSpPr txBox="1"/>
+          <p:nvPr/>
+        </p:nvSpPr>
+        <p:spPr>
+          <a:xfrm>
+            <a:off x="8375904" y="2871216"/>
+            <a:ext cx="2971800" cy="219456"/>
+          </a:xfrm>
+          <a:prstGeom prst="rect">
+            <a:avLst/>
+          </a:prstGeom>
+          <a:noFill/>
+          <a:ln/>
+        </p:spPr>
+        <p:txBody>
+          <a:bodyPr wrap="square" lIns="0" tIns="0" rIns="0" bIns="0" rtlCol="0" anchor="ctr"/>
+          <a:lstStyle/>
+          <a:p>
+            <a:pPr indent="0" marL="0">
+              <a:buNone/>
+            </a:pPr>
+            <a:r>
+              <a:rPr lang="en-US" sz="1000" spc="140" kern="0" dirty="0">
+                <a:solidFill>
+                  <a:srgbClr val="6B7686"/>
                 </a:solidFill>
                 <a:latin typeface="Courier New" pitchFamily="34" charset="0"/>
                 <a:ea typeface="Courier New" pitchFamily="34" charset="-122"/>
                 <a:cs typeface="Courier New" pitchFamily="34" charset="-120"/>
               </a:rPr>
-              <a:t>ORDER</a:t>
-            </a:r>
-            <a:endParaRPr lang="en-US" sz="1200" dirty="0"/>
-          </a:p>
-        </p:txBody>
-      </p:sp>
-      <p:sp>
-        <p:nvSpPr>
-          <p:cNvPr id="19" name="Text 17"/>
-          <p:cNvSpPr txBox="1"/>
-          <p:nvPr/>
-        </p:nvSpPr>
-        <p:spPr>
-          <a:xfrm>
-            <a:off x="9109710" y="2368296"/>
-            <a:ext cx="2439162" cy="795528"/>
-          </a:xfrm>
-          <a:prstGeom prst="rect">
-            <a:avLst/>
-          </a:prstGeom>
-          <a:noFill/>
-          <a:ln/>
-        </p:spPr>
-        <p:txBody>
-          <a:bodyPr wrap="square" rtlCol="0" anchor="ctr"/>
-          <a:lstStyle/>
-          <a:p>
-            <a:pPr algn="ctr" indent="0" marL="0">
+              <a:t>ENTRY DEDUP · 30 MIN</a:t>
+            </a:r>
+            <a:endParaRPr lang="en-US" sz="1000" dirty="0"/>
+          </a:p>
+        </p:txBody>
+      </p:sp>
+      <p:sp>
+        <p:nvSpPr>
+          <p:cNvPr id="15" name="Text 13"/>
+          <p:cNvSpPr txBox="1"/>
+          <p:nvPr/>
+        </p:nvSpPr>
+        <p:spPr>
+          <a:xfrm>
+            <a:off x="8375904" y="3163824"/>
+            <a:ext cx="2971800" cy="731520"/>
+          </a:xfrm>
+          <a:prstGeom prst="rect">
+            <a:avLst/>
+          </a:prstGeom>
+          <a:noFill/>
+          <a:ln/>
+        </p:spPr>
+        <p:txBody>
+          <a:bodyPr wrap="square" lIns="0" tIns="0" rIns="0" bIns="0" rtlCol="0" anchor="t"/>
+          <a:lstStyle/>
+          <a:p>
+            <a:pPr indent="0" marL="0">
               <a:lnSpc>
                 <a:spcPct val="120000"/>
               </a:lnSpc>
               <a:buNone/>
             </a:pPr>
             <a:r>
-              <a:rPr lang="en-US" sz="1000" dirty="0">
+              <a:rPr lang="en-US" sz="1100" dirty="0">
                 <a:solidFill>
                   <a:srgbClr val="A1A8B5"/>
                 </a:solidFill>
@@ -6496,46 +6486,26 @@
                 <a:ea typeface="Arial" pitchFamily="34" charset="-122"/>
                 <a:cs typeface="Arial" pitchFamily="34" charset="-120"/>
               </a:rPr>
-              <a:t>ATM long via the</a:t>
-            </a:r>
-            <a:endParaRPr lang="en-US" sz="1000" dirty="0"/>
-          </a:p>
-          <a:p>
-            <a:pPr algn="ctr" indent="0" marL="0">
-              <a:lnSpc>
-                <a:spcPct val="120000"/>
-              </a:lnSpc>
-              <a:buNone/>
-            </a:pPr>
-            <a:r>
-              <a:rPr lang="en-US" sz="1000" dirty="0">
-                <a:solidFill>
-                  <a:srgbClr val="A1A8B5"/>
-                </a:solidFill>
-                <a:latin typeface="Arial" pitchFamily="34" charset="0"/>
-                <a:ea typeface="Arial" pitchFamily="34" charset="-122"/>
-                <a:cs typeface="Arial" pitchFamily="34" charset="-120"/>
-              </a:rPr>
-              <a:t>Alpaca CLI</a:t>
-            </a:r>
-            <a:endParaRPr lang="en-US" sz="1000" dirty="0"/>
-          </a:p>
-        </p:txBody>
-      </p:sp>
-      <p:sp>
-        <p:nvSpPr>
-          <p:cNvPr id="20" name="Shape 18"/>
+              <a:t>Entry-anchored, so a persistent score cannot stack the same name.</a:t>
+            </a:r>
+            <a:endParaRPr lang="en-US" sz="1100" dirty="0"/>
+          </a:p>
+        </p:txBody>
+      </p:sp>
+      <p:sp>
+        <p:nvSpPr>
+          <p:cNvPr id="16" name="Shape 14"/>
           <p:cNvSpPr/>
           <p:nvPr/>
         </p:nvSpPr>
         <p:spPr>
           <a:xfrm>
-            <a:off x="548640" y="3611880"/>
-            <a:ext cx="5440680" cy="1691640"/>
+            <a:off x="548640" y="4242816"/>
+            <a:ext cx="3557016" cy="1389888"/>
           </a:xfrm>
           <a:prstGeom prst="roundRect">
             <a:avLst>
-              <a:gd name="adj" fmla="val 4324"/>
+              <a:gd name="adj" fmla="val 5263"/>
             </a:avLst>
           </a:prstGeom>
           <a:solidFill>
@@ -6551,14 +6521,14 @@
       </p:sp>
       <p:sp>
         <p:nvSpPr>
-          <p:cNvPr id="21" name="Text 19"/>
-          <p:cNvSpPr txBox="1"/>
-          <p:nvPr/>
-        </p:nvSpPr>
-        <p:spPr>
-          <a:xfrm>
-            <a:off x="841248" y="3813048"/>
-            <a:ext cx="4855464" cy="219456"/>
+          <p:cNvPr id="17" name="Text 15"/>
+          <p:cNvSpPr txBox="1"/>
+          <p:nvPr/>
+        </p:nvSpPr>
+        <p:spPr>
+          <a:xfrm>
+            <a:off x="841248" y="4443984"/>
+            <a:ext cx="2971800" cy="219456"/>
           </a:xfrm>
           <a:prstGeom prst="rect">
             <a:avLst/>
@@ -6582,7 +6552,7 @@
                 <a:ea typeface="Courier New" pitchFamily="34" charset="-122"/>
                 <a:cs typeface="Courier New" pitchFamily="34" charset="-120"/>
               </a:rPr>
-              <a:t>THE ONE-WAY RULE</a:t>
+              <a:t>ADAPTIVE SIZING</a:t>
             </a:r>
             <a:endParaRPr lang="en-US" sz="1000" dirty="0"/>
           </a:p>
@@ -6590,53 +6560,14 @@
       </p:sp>
       <p:sp>
         <p:nvSpPr>
-          <p:cNvPr id="22" name="Text 20"/>
-          <p:cNvSpPr txBox="1"/>
-          <p:nvPr/>
-        </p:nvSpPr>
-        <p:spPr>
-          <a:xfrm>
-            <a:off x="841248" y="4105656"/>
-            <a:ext cx="4855464" cy="411480"/>
-          </a:xfrm>
-          <a:prstGeom prst="rect">
-            <a:avLst/>
-          </a:prstGeom>
-          <a:noFill/>
-          <a:ln/>
-        </p:spPr>
-        <p:txBody>
-          <a:bodyPr wrap="square" lIns="0" tIns="0" rIns="0" bIns="0" rtlCol="0" anchor="ctr"/>
-          <a:lstStyle/>
-          <a:p>
-            <a:pPr indent="0" marL="0">
-              <a:buNone/>
-            </a:pPr>
-            <a:r>
-              <a:rPr lang="en-US" sz="2200" b="1" dirty="0">
-                <a:solidFill>
-                  <a:srgbClr val="F0B429"/>
-                </a:solidFill>
-                <a:latin typeface="Arial" pitchFamily="34" charset="0"/>
-                <a:ea typeface="Arial" pitchFamily="34" charset="-122"/>
-                <a:cs typeface="Arial" pitchFamily="34" charset="-120"/>
-              </a:rPr>
-              <a:t>go → no-go only</a:t>
-            </a:r>
-            <a:endParaRPr lang="en-US" sz="2200" dirty="0"/>
-          </a:p>
-        </p:txBody>
-      </p:sp>
-      <p:sp>
-        <p:nvSpPr>
-          <p:cNvPr id="23" name="Text 21"/>
-          <p:cNvSpPr txBox="1"/>
-          <p:nvPr/>
-        </p:nvSpPr>
-        <p:spPr>
-          <a:xfrm>
-            <a:off x="841248" y="4572000"/>
-            <a:ext cx="4855464" cy="566928"/>
+          <p:cNvPr id="18" name="Text 16"/>
+          <p:cNvSpPr txBox="1"/>
+          <p:nvPr/>
+        </p:nvSpPr>
+        <p:spPr>
+          <a:xfrm>
+            <a:off x="841248" y="4736592"/>
+            <a:ext cx="2971800" cy="731520"/>
           </a:xfrm>
           <a:prstGeom prst="rect">
             <a:avLst/>
@@ -6663,7 +6594,7 @@
                 <a:ea typeface="Arial" pitchFamily="34" charset="-122"/>
                 <a:cs typeface="Arial" pitchFamily="34" charset="-120"/>
               </a:rPr>
-              <a:t>The model can remove a trade the rules approved. It can never resurrect one they rejected, so the deterministic path is a strict subset of the AI path - and both are auditable against each other.</a:t>
+              <a:t>Trimmed to the account's real options buying power - an expensive contract sizes down, never rejects.</a:t>
             </a:r>
             <a:endParaRPr lang="en-US" sz="1100" dirty="0"/>
           </a:p>
@@ -6671,18 +6602,18 @@
       </p:sp>
       <p:sp>
         <p:nvSpPr>
-          <p:cNvPr id="24" name="Shape 22"/>
+          <p:cNvPr id="19" name="Shape 17"/>
           <p:cNvSpPr/>
           <p:nvPr/>
         </p:nvSpPr>
         <p:spPr>
           <a:xfrm>
-            <a:off x="6199632" y="3611880"/>
-            <a:ext cx="5440680" cy="1691640"/>
+            <a:off x="4315968" y="4242816"/>
+            <a:ext cx="3557016" cy="1389888"/>
           </a:xfrm>
           <a:prstGeom prst="roundRect">
             <a:avLst>
-              <a:gd name="adj" fmla="val 4324"/>
+              <a:gd name="adj" fmla="val 5263"/>
             </a:avLst>
           </a:prstGeom>
           <a:solidFill>
@@ -6698,14 +6629,14 @@
       </p:sp>
       <p:sp>
         <p:nvSpPr>
-          <p:cNvPr id="25" name="Text 23"/>
-          <p:cNvSpPr txBox="1"/>
-          <p:nvPr/>
-        </p:nvSpPr>
-        <p:spPr>
-          <a:xfrm>
-            <a:off x="6492240" y="3813048"/>
-            <a:ext cx="4855464" cy="219456"/>
+          <p:cNvPr id="20" name="Text 18"/>
+          <p:cNvSpPr txBox="1"/>
+          <p:nvPr/>
+        </p:nvSpPr>
+        <p:spPr>
+          <a:xfrm>
+            <a:off x="4608576" y="4443984"/>
+            <a:ext cx="2971800" cy="219456"/>
           </a:xfrm>
           <a:prstGeom prst="rect">
             <a:avLst/>
@@ -6729,7 +6660,7 @@
                 <a:ea typeface="Courier New" pitchFamily="34" charset="-122"/>
                 <a:cs typeface="Courier New" pitchFamily="34" charset="-120"/>
               </a:rPr>
-              <a:t>FAILS CLOSED, NEVER OPEN</a:t>
+              <a:t>SESSION WINDOW</a:t>
             </a:r>
             <a:endParaRPr lang="en-US" sz="1000" dirty="0"/>
           </a:p>
@@ -6737,53 +6668,14 @@
       </p:sp>
       <p:sp>
         <p:nvSpPr>
-          <p:cNvPr id="26" name="Text 24"/>
-          <p:cNvSpPr txBox="1"/>
-          <p:nvPr/>
-        </p:nvSpPr>
-        <p:spPr>
-          <a:xfrm>
-            <a:off x="6492240" y="4105656"/>
-            <a:ext cx="4855464" cy="411480"/>
-          </a:xfrm>
-          <a:prstGeom prst="rect">
-            <a:avLst/>
-          </a:prstGeom>
-          <a:noFill/>
-          <a:ln/>
-        </p:spPr>
-        <p:txBody>
-          <a:bodyPr wrap="square" lIns="0" tIns="0" rIns="0" bIns="0" rtlCol="0" anchor="ctr"/>
-          <a:lstStyle/>
-          <a:p>
-            <a:pPr indent="0" marL="0">
-              <a:buNone/>
-            </a:pPr>
-            <a:r>
-              <a:rPr lang="en-US" sz="2000" b="1" dirty="0">
-                <a:solidFill>
-                  <a:srgbClr val="FFFFFF"/>
-                </a:solidFill>
-                <a:latin typeface="Arial" pitchFamily="34" charset="0"/>
-                <a:ea typeface="Arial" pitchFamily="34" charset="-122"/>
-                <a:cs typeface="Arial" pitchFamily="34" charset="-120"/>
-              </a:rPr>
-              <a:t>degrade, don't guess</a:t>
-            </a:r>
-            <a:endParaRPr lang="en-US" sz="2000" dirty="0"/>
-          </a:p>
-        </p:txBody>
-      </p:sp>
-      <p:sp>
-        <p:nvSpPr>
-          <p:cNvPr id="27" name="Text 25"/>
-          <p:cNvSpPr txBox="1"/>
-          <p:nvPr/>
-        </p:nvSpPr>
-        <p:spPr>
-          <a:xfrm>
-            <a:off x="6492240" y="4572000"/>
-            <a:ext cx="4855464" cy="566928"/>
+          <p:cNvPr id="21" name="Text 19"/>
+          <p:cNvSpPr txBox="1"/>
+          <p:nvPr/>
+        </p:nvSpPr>
+        <p:spPr>
+          <a:xfrm>
+            <a:off x="4608576" y="4736592"/>
+            <a:ext cx="2971800" cy="731520"/>
           </a:xfrm>
           <a:prstGeom prst="rect">
             <a:avLst/>
@@ -6810,7 +6702,7 @@
                 <a:ea typeface="Arial" pitchFamily="34" charset="-122"/>
                 <a:cs typeface="Arial" pitchFamily="34" charset="-120"/>
               </a:rPr>
-              <a:t>A missing key or unparseable reply degrades to the deterministic gate and says so in the journal. The agent never trades on a model response it could not read.</a:t>
+              <a:t>No entry after 15:00 ET. Hard flatten at 15:50 - a 0DTE never reaches expiry.</a:t>
             </a:r>
             <a:endParaRPr lang="en-US" sz="1100" dirty="0"/>
           </a:p>
@@ -6818,14 +6710,41 @@
       </p:sp>
       <p:sp>
         <p:nvSpPr>
-          <p:cNvPr id="28" name="Text 26"/>
-          <p:cNvSpPr txBox="1"/>
-          <p:nvPr/>
-        </p:nvSpPr>
-        <p:spPr>
-          <a:xfrm>
-            <a:off x="548640" y="5486400"/>
-            <a:ext cx="11091672" cy="365760"/>
+          <p:cNvPr id="22" name="Shape 20"/>
+          <p:cNvSpPr/>
+          <p:nvPr/>
+        </p:nvSpPr>
+        <p:spPr>
+          <a:xfrm>
+            <a:off x="8083296" y="4242816"/>
+            <a:ext cx="3557016" cy="1389888"/>
+          </a:xfrm>
+          <a:prstGeom prst="roundRect">
+            <a:avLst>
+              <a:gd name="adj" fmla="val 5263"/>
+            </a:avLst>
+          </a:prstGeom>
+          <a:solidFill>
+            <a:srgbClr val="141922"/>
+          </a:solidFill>
+          <a:ln w="12700">
+            <a:solidFill>
+              <a:srgbClr val="232A38"/>
+            </a:solidFill>
+            <a:prstDash val="solid"/>
+          </a:ln>
+        </p:spPr>
+      </p:sp>
+      <p:sp>
+        <p:nvSpPr>
+          <p:cNvPr id="23" name="Text 21"/>
+          <p:cNvSpPr txBox="1"/>
+          <p:nvPr/>
+        </p:nvSpPr>
+        <p:spPr>
+          <a:xfrm>
+            <a:off x="8375904" y="4443984"/>
+            <a:ext cx="2971800" cy="219456"/>
           </a:xfrm>
           <a:prstGeom prst="rect">
             <a:avLst/>
@@ -6841,7 +6760,7 @@
               <a:buNone/>
             </a:pPr>
             <a:r>
-              <a:rPr lang="en-US" sz="1000" dirty="0">
+              <a:rPr lang="en-US" sz="1000" spc="140" kern="0" dirty="0">
                 <a:solidFill>
                   <a:srgbClr val="6B7686"/>
                 </a:solidFill>
@@ -6849,9 +6768,90 @@
                 <a:ea typeface="Courier New" pitchFamily="34" charset="-122"/>
                 <a:cs typeface="Courier New" pitchFamily="34" charset="-120"/>
               </a:rPr>
-              <a:t>The scored sessions ran the deterministic gate; the Claude veto ships tested and runnable via --decision-mode llm.</a:t>
+              <a:t>ORPHAN SWEEP</a:t>
             </a:r>
             <a:endParaRPr lang="en-US" sz="1000" dirty="0"/>
+          </a:p>
+        </p:txBody>
+      </p:sp>
+      <p:sp>
+        <p:nvSpPr>
+          <p:cNvPr id="24" name="Text 22"/>
+          <p:cNvSpPr txBox="1"/>
+          <p:nvPr/>
+        </p:nvSpPr>
+        <p:spPr>
+          <a:xfrm>
+            <a:off x="8375904" y="4736592"/>
+            <a:ext cx="2971800" cy="731520"/>
+          </a:xfrm>
+          <a:prstGeom prst="rect">
+            <a:avLst/>
+          </a:prstGeom>
+          <a:noFill/>
+          <a:ln/>
+        </p:spPr>
+        <p:txBody>
+          <a:bodyPr wrap="square" lIns="0" tIns="0" rIns="0" bIns="0" rtlCol="0" anchor="t"/>
+          <a:lstStyle/>
+          <a:p>
+            <a:pPr indent="0" marL="0">
+              <a:lnSpc>
+                <a:spcPct val="120000"/>
+              </a:lnSpc>
+              <a:buNone/>
+            </a:pPr>
+            <a:r>
+              <a:rPr lang="en-US" sz="1100" dirty="0">
+                <a:solidFill>
+                  <a:srgbClr val="A1A8B5"/>
+                </a:solidFill>
+                <a:latin typeface="Arial" pitchFamily="34" charset="0"/>
+                <a:ea typeface="Arial" pitchFamily="34" charset="-122"/>
+                <a:cs typeface="Arial" pitchFamily="34" charset="-120"/>
+              </a:rPr>
+              <a:t>Any option position the agent did not open is flattened at startup and at EOD.</a:t>
+            </a:r>
+            <a:endParaRPr lang="en-US" sz="1100" dirty="0"/>
+          </a:p>
+        </p:txBody>
+      </p:sp>
+      <p:sp>
+        <p:nvSpPr>
+          <p:cNvPr id="25" name="Text 23"/>
+          <p:cNvSpPr txBox="1"/>
+          <p:nvPr/>
+        </p:nvSpPr>
+        <p:spPr>
+          <a:xfrm>
+            <a:off x="548640" y="5870448"/>
+            <a:ext cx="11091672" cy="365760"/>
+          </a:xfrm>
+          <a:prstGeom prst="rect">
+            <a:avLst/>
+          </a:prstGeom>
+          <a:noFill/>
+          <a:ln/>
+        </p:spPr>
+        <p:txBody>
+          <a:bodyPr wrap="square" lIns="0" tIns="0" rIns="0" bIns="0" rtlCol="0" anchor="ctr"/>
+          <a:lstStyle/>
+          <a:p>
+            <a:pPr indent="0" marL="0">
+              <a:buNone/>
+            </a:pPr>
+            <a:r>
+              <a:rPr lang="en-US" sz="1100" dirty="0">
+                <a:solidFill>
+                  <a:srgbClr val="A1A8B5"/>
+                </a:solidFill>
+                <a:latin typeface="Arial" pitchFamily="34" charset="0"/>
+                <a:ea typeface="Arial" pitchFamily="34" charset="-122"/>
+                <a:cs typeface="Arial" pitchFamily="34" charset="-120"/>
+              </a:rPr>
+              <a:t>Exits ladder in both directions:  +40% scales out half and trails the runner by 40% of its peak gain  ·  -20% sells half, -40% the rest  ·  a 30-minute stop closes anything still under water  ·  15:50 flatten.</a:t>
+            </a:r>
+            <a:endParaRPr lang="en-US" sz="1100" dirty="0"/>
           </a:p>
         </p:txBody>
       </p:sp>

</xml_diff>